<commit_message>
feat(apresentacao): pitch HTML vivo — animação constante, partículas e roteiro embutido
Apresentação fullscreen autônoma (fontes/logo em base64, funciona offline):
partículas em canvas, órbita com cometa, pacotes SVG fluindo nos diagramas,
curva de receita que se desenha, discos respirando; entradas por máscara de
linha e transições suaves; navegação por teclado/passador, F tela cheia,
N abre o roteiro (palco reencaixa acima do painel); reduced-motion ok.
Painel de crítica (2 lentes + verificador): 8 fixes aplicados e retrofitados
aos outros formatos (eyebrow verde no S2, viúva do título, dois tons no S7)
— PDF, PPTX de imagens e PPTX nativo regenerados.

Co-Authored-By: Claude Fable 5 <noreply@anthropic.com>
</commit_message>
<xml_diff>
--- a/docs/apresentacao/Dreamy — Apresentação Institucional (editável).pptx
+++ b/docs/apresentacao/Dreamy — Apresentação Institucional (editável).pptx
@@ -211,7 +211,7 @@
             </a:lvl1pPr>
           </a:lstStyle>
           <a:p>
-            <a:fld id="{132F0903-87B3-402A-B2D7-54CFFD9CCBF9}" type="datetimeFigureOut">
+            <a:fld id="{C1ED2B35-3B30-481E-90CB-AEC01FDA4513}" type="datetimeFigureOut">
               <a:rPr lang="pt-BR" smtClean="0"/>
               <a:t>19/08/2026</a:t>
             </a:fld>
@@ -369,7 +369,7 @@
             </a:lvl1pPr>
           </a:lstStyle>
           <a:p>
-            <a:fld id="{28B3D8F5-F0D5-446F-9F12-2EF6D7824B56}" type="slidenum">
+            <a:fld id="{8938F200-F25E-4279-B90D-7528218E0D07}" type="slidenum">
               <a:rPr lang="pt-BR" smtClean="0"/>
               <a:t>‹nº›</a:t>
             </a:fld>
@@ -380,7 +380,7 @@
     </p:spTree>
     <p:extLst>
       <p:ext uri="{BB962C8B-B14F-4D97-AF65-F5344CB8AC3E}">
-        <p14:creationId xmlns:p14="http://schemas.microsoft.com/office/powerpoint/2010/main" val="458591754"/>
+        <p14:creationId xmlns:p14="http://schemas.microsoft.com/office/powerpoint/2010/main" val="731986770"/>
       </p:ext>
     </p:extLst>
   </p:cSld>
@@ -549,7 +549,7 @@
           <a:bodyPr/>
           <a:lstStyle/>
           <a:p>
-            <a:fld id="{28B3D8F5-F0D5-446F-9F12-2EF6D7824B56}" type="slidenum">
+            <a:fld id="{8938F200-F25E-4279-B90D-7528218E0D07}" type="slidenum">
               <a:rPr lang="pt-BR" smtClean="0"/>
               <a:t>1</a:t>
             </a:fld>
@@ -560,7 +560,7 @@
     </p:spTree>
     <p:extLst>
       <p:ext uri="{BB962C8B-B14F-4D97-AF65-F5344CB8AC3E}">
-        <p14:creationId xmlns:p14="http://schemas.microsoft.com/office/powerpoint/2010/main" val="126707831"/>
+        <p14:creationId xmlns:p14="http://schemas.microsoft.com/office/powerpoint/2010/main" val="742385936"/>
       </p:ext>
     </p:extLst>
   </p:cSld>
@@ -639,7 +639,7 @@
           <a:bodyPr/>
           <a:lstStyle/>
           <a:p>
-            <a:fld id="{28B3D8F5-F0D5-446F-9F12-2EF6D7824B56}" type="slidenum">
+            <a:fld id="{8938F200-F25E-4279-B90D-7528218E0D07}" type="slidenum">
               <a:rPr lang="pt-BR" smtClean="0"/>
               <a:t>10</a:t>
             </a:fld>
@@ -650,7 +650,7 @@
     </p:spTree>
     <p:extLst>
       <p:ext uri="{BB962C8B-B14F-4D97-AF65-F5344CB8AC3E}">
-        <p14:creationId xmlns:p14="http://schemas.microsoft.com/office/powerpoint/2010/main" val="564356990"/>
+        <p14:creationId xmlns:p14="http://schemas.microsoft.com/office/powerpoint/2010/main" val="1782610984"/>
       </p:ext>
     </p:extLst>
   </p:cSld>
@@ -729,7 +729,7 @@
           <a:bodyPr/>
           <a:lstStyle/>
           <a:p>
-            <a:fld id="{28B3D8F5-F0D5-446F-9F12-2EF6D7824B56}" type="slidenum">
+            <a:fld id="{8938F200-F25E-4279-B90D-7528218E0D07}" type="slidenum">
               <a:rPr lang="pt-BR" smtClean="0"/>
               <a:t>11</a:t>
             </a:fld>
@@ -740,7 +740,7 @@
     </p:spTree>
     <p:extLst>
       <p:ext uri="{BB962C8B-B14F-4D97-AF65-F5344CB8AC3E}">
-        <p14:creationId xmlns:p14="http://schemas.microsoft.com/office/powerpoint/2010/main" val="3162990305"/>
+        <p14:creationId xmlns:p14="http://schemas.microsoft.com/office/powerpoint/2010/main" val="104528618"/>
       </p:ext>
     </p:extLst>
   </p:cSld>
@@ -822,7 +822,7 @@
           <a:bodyPr/>
           <a:lstStyle/>
           <a:p>
-            <a:fld id="{28B3D8F5-F0D5-446F-9F12-2EF6D7824B56}" type="slidenum">
+            <a:fld id="{8938F200-F25E-4279-B90D-7528218E0D07}" type="slidenum">
               <a:rPr lang="pt-BR" smtClean="0"/>
               <a:t>12</a:t>
             </a:fld>
@@ -833,7 +833,7 @@
     </p:spTree>
     <p:extLst>
       <p:ext uri="{BB962C8B-B14F-4D97-AF65-F5344CB8AC3E}">
-        <p14:creationId xmlns:p14="http://schemas.microsoft.com/office/powerpoint/2010/main" val="1734183414"/>
+        <p14:creationId xmlns:p14="http://schemas.microsoft.com/office/powerpoint/2010/main" val="2597180120"/>
       </p:ext>
     </p:extLst>
   </p:cSld>
@@ -913,7 +913,7 @@
           <a:bodyPr/>
           <a:lstStyle/>
           <a:p>
-            <a:fld id="{28B3D8F5-F0D5-446F-9F12-2EF6D7824B56}" type="slidenum">
+            <a:fld id="{8938F200-F25E-4279-B90D-7528218E0D07}" type="slidenum">
               <a:rPr lang="pt-BR" smtClean="0"/>
               <a:t>2</a:t>
             </a:fld>
@@ -924,7 +924,7 @@
     </p:spTree>
     <p:extLst>
       <p:ext uri="{BB962C8B-B14F-4D97-AF65-F5344CB8AC3E}">
-        <p14:creationId xmlns:p14="http://schemas.microsoft.com/office/powerpoint/2010/main" val="3562915677"/>
+        <p14:creationId xmlns:p14="http://schemas.microsoft.com/office/powerpoint/2010/main" val="2218761738"/>
       </p:ext>
     </p:extLst>
   </p:cSld>
@@ -1003,7 +1003,7 @@
           <a:bodyPr/>
           <a:lstStyle/>
           <a:p>
-            <a:fld id="{28B3D8F5-F0D5-446F-9F12-2EF6D7824B56}" type="slidenum">
+            <a:fld id="{8938F200-F25E-4279-B90D-7528218E0D07}" type="slidenum">
               <a:rPr lang="pt-BR" smtClean="0"/>
               <a:t>3</a:t>
             </a:fld>
@@ -1014,7 +1014,7 @@
     </p:spTree>
     <p:extLst>
       <p:ext uri="{BB962C8B-B14F-4D97-AF65-F5344CB8AC3E}">
-        <p14:creationId xmlns:p14="http://schemas.microsoft.com/office/powerpoint/2010/main" val="945426238"/>
+        <p14:creationId xmlns:p14="http://schemas.microsoft.com/office/powerpoint/2010/main" val="653886227"/>
       </p:ext>
     </p:extLst>
   </p:cSld>
@@ -1093,7 +1093,7 @@
           <a:bodyPr/>
           <a:lstStyle/>
           <a:p>
-            <a:fld id="{28B3D8F5-F0D5-446F-9F12-2EF6D7824B56}" type="slidenum">
+            <a:fld id="{8938F200-F25E-4279-B90D-7528218E0D07}" type="slidenum">
               <a:rPr lang="pt-BR" smtClean="0"/>
               <a:t>4</a:t>
             </a:fld>
@@ -1104,7 +1104,7 @@
     </p:spTree>
     <p:extLst>
       <p:ext uri="{BB962C8B-B14F-4D97-AF65-F5344CB8AC3E}">
-        <p14:creationId xmlns:p14="http://schemas.microsoft.com/office/powerpoint/2010/main" val="4190040735"/>
+        <p14:creationId xmlns:p14="http://schemas.microsoft.com/office/powerpoint/2010/main" val="2933766601"/>
       </p:ext>
     </p:extLst>
   </p:cSld>
@@ -1183,7 +1183,7 @@
           <a:bodyPr/>
           <a:lstStyle/>
           <a:p>
-            <a:fld id="{28B3D8F5-F0D5-446F-9F12-2EF6D7824B56}" type="slidenum">
+            <a:fld id="{8938F200-F25E-4279-B90D-7528218E0D07}" type="slidenum">
               <a:rPr lang="pt-BR" smtClean="0"/>
               <a:t>5</a:t>
             </a:fld>
@@ -1194,7 +1194,7 @@
     </p:spTree>
     <p:extLst>
       <p:ext uri="{BB962C8B-B14F-4D97-AF65-F5344CB8AC3E}">
-        <p14:creationId xmlns:p14="http://schemas.microsoft.com/office/powerpoint/2010/main" val="143599707"/>
+        <p14:creationId xmlns:p14="http://schemas.microsoft.com/office/powerpoint/2010/main" val="2027018748"/>
       </p:ext>
     </p:extLst>
   </p:cSld>
@@ -1274,7 +1274,7 @@
           <a:bodyPr/>
           <a:lstStyle/>
           <a:p>
-            <a:fld id="{28B3D8F5-F0D5-446F-9F12-2EF6D7824B56}" type="slidenum">
+            <a:fld id="{8938F200-F25E-4279-B90D-7528218E0D07}" type="slidenum">
               <a:rPr lang="pt-BR" smtClean="0"/>
               <a:t>6</a:t>
             </a:fld>
@@ -1285,7 +1285,7 @@
     </p:spTree>
     <p:extLst>
       <p:ext uri="{BB962C8B-B14F-4D97-AF65-F5344CB8AC3E}">
-        <p14:creationId xmlns:p14="http://schemas.microsoft.com/office/powerpoint/2010/main" val="1653011141"/>
+        <p14:creationId xmlns:p14="http://schemas.microsoft.com/office/powerpoint/2010/main" val="1397401957"/>
       </p:ext>
     </p:extLst>
   </p:cSld>
@@ -1365,7 +1365,7 @@
           <a:bodyPr/>
           <a:lstStyle/>
           <a:p>
-            <a:fld id="{28B3D8F5-F0D5-446F-9F12-2EF6D7824B56}" type="slidenum">
+            <a:fld id="{8938F200-F25E-4279-B90D-7528218E0D07}" type="slidenum">
               <a:rPr lang="pt-BR" smtClean="0"/>
               <a:t>7</a:t>
             </a:fld>
@@ -1376,7 +1376,7 @@
     </p:spTree>
     <p:extLst>
       <p:ext uri="{BB962C8B-B14F-4D97-AF65-F5344CB8AC3E}">
-        <p14:creationId xmlns:p14="http://schemas.microsoft.com/office/powerpoint/2010/main" val="278374265"/>
+        <p14:creationId xmlns:p14="http://schemas.microsoft.com/office/powerpoint/2010/main" val="2958422597"/>
       </p:ext>
     </p:extLst>
   </p:cSld>
@@ -1456,7 +1456,7 @@
           <a:bodyPr/>
           <a:lstStyle/>
           <a:p>
-            <a:fld id="{28B3D8F5-F0D5-446F-9F12-2EF6D7824B56}" type="slidenum">
+            <a:fld id="{8938F200-F25E-4279-B90D-7528218E0D07}" type="slidenum">
               <a:rPr lang="pt-BR" smtClean="0"/>
               <a:t>8</a:t>
             </a:fld>
@@ -1467,7 +1467,7 @@
     </p:spTree>
     <p:extLst>
       <p:ext uri="{BB962C8B-B14F-4D97-AF65-F5344CB8AC3E}">
-        <p14:creationId xmlns:p14="http://schemas.microsoft.com/office/powerpoint/2010/main" val="1980869883"/>
+        <p14:creationId xmlns:p14="http://schemas.microsoft.com/office/powerpoint/2010/main" val="3168433147"/>
       </p:ext>
     </p:extLst>
   </p:cSld>
@@ -1548,7 +1548,7 @@
           <a:bodyPr/>
           <a:lstStyle/>
           <a:p>
-            <a:fld id="{28B3D8F5-F0D5-446F-9F12-2EF6D7824B56}" type="slidenum">
+            <a:fld id="{8938F200-F25E-4279-B90D-7528218E0D07}" type="slidenum">
               <a:rPr lang="pt-BR" smtClean="0"/>
               <a:t>9</a:t>
             </a:fld>
@@ -1559,7 +1559,7 @@
     </p:spTree>
     <p:extLst>
       <p:ext uri="{BB962C8B-B14F-4D97-AF65-F5344CB8AC3E}">
-        <p14:creationId xmlns:p14="http://schemas.microsoft.com/office/powerpoint/2010/main" val="1281207127"/>
+        <p14:creationId xmlns:p14="http://schemas.microsoft.com/office/powerpoint/2010/main" val="260366392"/>
       </p:ext>
     </p:extLst>
   </p:cSld>
@@ -1591,7 +1591,7 @@
           <p:cNvPr id="2" name="Título 1">
             <a:extLst>
               <a:ext uri="{FF2B5EF4-FFF2-40B4-BE49-F238E27FC236}">
-                <a16:creationId xmlns:a16="http://schemas.microsoft.com/office/drawing/2014/main" id="{C402F0A0-E7E1-D028-E001-3C8C38C01686}"/>
+                <a16:creationId xmlns:a16="http://schemas.microsoft.com/office/drawing/2014/main" id="{F989FE1D-83B3-23F4-6086-DCD31C9A33DD}"/>
               </a:ext>
             </a:extLst>
           </p:cNvPr>
@@ -1628,7 +1628,7 @@
           <p:cNvPr id="3" name="Subtítulo 2">
             <a:extLst>
               <a:ext uri="{FF2B5EF4-FFF2-40B4-BE49-F238E27FC236}">
-                <a16:creationId xmlns:a16="http://schemas.microsoft.com/office/drawing/2014/main" id="{0BDA4E1D-AD8F-31A0-67C1-18EEE83E810B}"/>
+                <a16:creationId xmlns:a16="http://schemas.microsoft.com/office/drawing/2014/main" id="{6EB34919-F056-AE1A-BB29-03969DE9C027}"/>
               </a:ext>
             </a:extLst>
           </p:cNvPr>
@@ -1698,7 +1698,7 @@
           <p:cNvPr id="4" name="Espaço Reservado para Data 3">
             <a:extLst>
               <a:ext uri="{FF2B5EF4-FFF2-40B4-BE49-F238E27FC236}">
-                <a16:creationId xmlns:a16="http://schemas.microsoft.com/office/drawing/2014/main" id="{DDEEBAA5-FFFF-15F6-A994-BAAB0D95C21E}"/>
+                <a16:creationId xmlns:a16="http://schemas.microsoft.com/office/drawing/2014/main" id="{D80575D1-02DF-1C1C-4DE5-3A367D9EEBA5}"/>
               </a:ext>
             </a:extLst>
           </p:cNvPr>
@@ -1714,7 +1714,7 @@
           <a:bodyPr/>
           <a:lstStyle/>
           <a:p>
-            <a:fld id="{37BC8248-C4A9-4E61-9781-4EA1B2387A6F}" type="datetimeFigureOut">
+            <a:fld id="{53940624-BB9A-4F64-9034-800251E0A6B4}" type="datetimeFigureOut">
               <a:rPr lang="pt-BR" smtClean="0"/>
               <a:t>19/08/2026</a:t>
             </a:fld>
@@ -1727,7 +1727,7 @@
           <p:cNvPr id="5" name="Espaço Reservado para Rodapé 4">
             <a:extLst>
               <a:ext uri="{FF2B5EF4-FFF2-40B4-BE49-F238E27FC236}">
-                <a16:creationId xmlns:a16="http://schemas.microsoft.com/office/drawing/2014/main" id="{613E5306-203D-4EC1-36DA-165CF85AE65C}"/>
+                <a16:creationId xmlns:a16="http://schemas.microsoft.com/office/drawing/2014/main" id="{E3DB4C65-40B3-E8B6-1A0D-BBD1E6684F82}"/>
               </a:ext>
             </a:extLst>
           </p:cNvPr>
@@ -1752,7 +1752,7 @@
           <p:cNvPr id="6" name="Espaço Reservado para Número de Slide 5">
             <a:extLst>
               <a:ext uri="{FF2B5EF4-FFF2-40B4-BE49-F238E27FC236}">
-                <a16:creationId xmlns:a16="http://schemas.microsoft.com/office/drawing/2014/main" id="{0018FCE0-307C-6EE1-C37C-2A784400CDE2}"/>
+                <a16:creationId xmlns:a16="http://schemas.microsoft.com/office/drawing/2014/main" id="{5CB9DD6F-181B-E81D-36B1-F92138CA7A11}"/>
               </a:ext>
             </a:extLst>
           </p:cNvPr>
@@ -1768,7 +1768,7 @@
           <a:bodyPr/>
           <a:lstStyle/>
           <a:p>
-            <a:fld id="{820B318C-A250-4EE9-97D4-C4723DE988C6}" type="slidenum">
+            <a:fld id="{1F74E298-800F-430B-B75D-DE368AAA8DFD}" type="slidenum">
               <a:rPr lang="pt-BR" smtClean="0"/>
               <a:t>‹nº›</a:t>
             </a:fld>
@@ -1779,7 +1779,7 @@
     </p:spTree>
     <p:extLst>
       <p:ext uri="{BB962C8B-B14F-4D97-AF65-F5344CB8AC3E}">
-        <p14:creationId xmlns:p14="http://schemas.microsoft.com/office/powerpoint/2010/main" val="2767602699"/>
+        <p14:creationId xmlns:p14="http://schemas.microsoft.com/office/powerpoint/2010/main" val="331484411"/>
       </p:ext>
     </p:extLst>
   </p:cSld>
@@ -1811,7 +1811,7 @@
           <p:cNvPr id="2" name="Título 1">
             <a:extLst>
               <a:ext uri="{FF2B5EF4-FFF2-40B4-BE49-F238E27FC236}">
-                <a16:creationId xmlns:a16="http://schemas.microsoft.com/office/drawing/2014/main" id="{9BFF2EB3-7A44-FD07-A2F2-3FE37938F51D}"/>
+                <a16:creationId xmlns:a16="http://schemas.microsoft.com/office/drawing/2014/main" id="{C6100233-974F-E806-323D-7DA725EF85C6}"/>
               </a:ext>
             </a:extLst>
           </p:cNvPr>
@@ -1839,7 +1839,7 @@
           <p:cNvPr id="3" name="Espaço Reservado para Texto Vertical 2">
             <a:extLst>
               <a:ext uri="{FF2B5EF4-FFF2-40B4-BE49-F238E27FC236}">
-                <a16:creationId xmlns:a16="http://schemas.microsoft.com/office/drawing/2014/main" id="{8C7F3FAE-4BE9-FF2F-2EAC-754CA10A492F}"/>
+                <a16:creationId xmlns:a16="http://schemas.microsoft.com/office/drawing/2014/main" id="{DEDEDB6F-C675-89B8-D75B-D68C6B649856}"/>
               </a:ext>
             </a:extLst>
           </p:cNvPr>
@@ -1896,7 +1896,7 @@
           <p:cNvPr id="4" name="Espaço Reservado para Data 3">
             <a:extLst>
               <a:ext uri="{FF2B5EF4-FFF2-40B4-BE49-F238E27FC236}">
-                <a16:creationId xmlns:a16="http://schemas.microsoft.com/office/drawing/2014/main" id="{9DA15DFB-910E-C39C-6056-AA9632E9E09F}"/>
+                <a16:creationId xmlns:a16="http://schemas.microsoft.com/office/drawing/2014/main" id="{81EB8D41-9B77-D4DF-B918-46E6CB255AF7}"/>
               </a:ext>
             </a:extLst>
           </p:cNvPr>
@@ -1912,7 +1912,7 @@
           <a:bodyPr/>
           <a:lstStyle/>
           <a:p>
-            <a:fld id="{37BC8248-C4A9-4E61-9781-4EA1B2387A6F}" type="datetimeFigureOut">
+            <a:fld id="{53940624-BB9A-4F64-9034-800251E0A6B4}" type="datetimeFigureOut">
               <a:rPr lang="pt-BR" smtClean="0"/>
               <a:t>19/08/2026</a:t>
             </a:fld>
@@ -1925,7 +1925,7 @@
           <p:cNvPr id="5" name="Espaço Reservado para Rodapé 4">
             <a:extLst>
               <a:ext uri="{FF2B5EF4-FFF2-40B4-BE49-F238E27FC236}">
-                <a16:creationId xmlns:a16="http://schemas.microsoft.com/office/drawing/2014/main" id="{0EB1059B-F6F8-041A-823A-CAA8B4F9C3F6}"/>
+                <a16:creationId xmlns:a16="http://schemas.microsoft.com/office/drawing/2014/main" id="{A6B564C7-B6FD-0DF7-75ED-62D726579E68}"/>
               </a:ext>
             </a:extLst>
           </p:cNvPr>
@@ -1950,7 +1950,7 @@
           <p:cNvPr id="6" name="Espaço Reservado para Número de Slide 5">
             <a:extLst>
               <a:ext uri="{FF2B5EF4-FFF2-40B4-BE49-F238E27FC236}">
-                <a16:creationId xmlns:a16="http://schemas.microsoft.com/office/drawing/2014/main" id="{F54E2AF7-4D17-2534-3711-54D7A5195307}"/>
+                <a16:creationId xmlns:a16="http://schemas.microsoft.com/office/drawing/2014/main" id="{AFC0CE0C-7EAB-43EB-F74D-56BEBD052F3D}"/>
               </a:ext>
             </a:extLst>
           </p:cNvPr>
@@ -1966,7 +1966,7 @@
           <a:bodyPr/>
           <a:lstStyle/>
           <a:p>
-            <a:fld id="{820B318C-A250-4EE9-97D4-C4723DE988C6}" type="slidenum">
+            <a:fld id="{1F74E298-800F-430B-B75D-DE368AAA8DFD}" type="slidenum">
               <a:rPr lang="pt-BR" smtClean="0"/>
               <a:t>‹nº›</a:t>
             </a:fld>
@@ -1977,7 +1977,7 @@
     </p:spTree>
     <p:extLst>
       <p:ext uri="{BB962C8B-B14F-4D97-AF65-F5344CB8AC3E}">
-        <p14:creationId xmlns:p14="http://schemas.microsoft.com/office/powerpoint/2010/main" val="2891973915"/>
+        <p14:creationId xmlns:p14="http://schemas.microsoft.com/office/powerpoint/2010/main" val="2745103219"/>
       </p:ext>
     </p:extLst>
   </p:cSld>
@@ -2009,7 +2009,7 @@
           <p:cNvPr id="2" name="Título Vertical 1">
             <a:extLst>
               <a:ext uri="{FF2B5EF4-FFF2-40B4-BE49-F238E27FC236}">
-                <a16:creationId xmlns:a16="http://schemas.microsoft.com/office/drawing/2014/main" id="{1FDDFFEA-6ACE-F98F-6690-87E92611181D}"/>
+                <a16:creationId xmlns:a16="http://schemas.microsoft.com/office/drawing/2014/main" id="{A433B3EE-A270-7D88-BCDE-E78A48D6CA98}"/>
               </a:ext>
             </a:extLst>
           </p:cNvPr>
@@ -2042,7 +2042,7 @@
           <p:cNvPr id="3" name="Espaço Reservado para Texto Vertical 2">
             <a:extLst>
               <a:ext uri="{FF2B5EF4-FFF2-40B4-BE49-F238E27FC236}">
-                <a16:creationId xmlns:a16="http://schemas.microsoft.com/office/drawing/2014/main" id="{7CAB1E5F-8227-9F0F-B4EB-EBCC4B403687}"/>
+                <a16:creationId xmlns:a16="http://schemas.microsoft.com/office/drawing/2014/main" id="{CD940E14-B070-8ED9-3849-87A265D3A02D}"/>
               </a:ext>
             </a:extLst>
           </p:cNvPr>
@@ -2104,7 +2104,7 @@
           <p:cNvPr id="4" name="Espaço Reservado para Data 3">
             <a:extLst>
               <a:ext uri="{FF2B5EF4-FFF2-40B4-BE49-F238E27FC236}">
-                <a16:creationId xmlns:a16="http://schemas.microsoft.com/office/drawing/2014/main" id="{655CEC27-8701-BB88-2B69-1951ACED5906}"/>
+                <a16:creationId xmlns:a16="http://schemas.microsoft.com/office/drawing/2014/main" id="{354B295A-C0FE-1D66-6E3B-523736F59DB7}"/>
               </a:ext>
             </a:extLst>
           </p:cNvPr>
@@ -2120,7 +2120,7 @@
           <a:bodyPr/>
           <a:lstStyle/>
           <a:p>
-            <a:fld id="{37BC8248-C4A9-4E61-9781-4EA1B2387A6F}" type="datetimeFigureOut">
+            <a:fld id="{53940624-BB9A-4F64-9034-800251E0A6B4}" type="datetimeFigureOut">
               <a:rPr lang="pt-BR" smtClean="0"/>
               <a:t>19/08/2026</a:t>
             </a:fld>
@@ -2133,7 +2133,7 @@
           <p:cNvPr id="5" name="Espaço Reservado para Rodapé 4">
             <a:extLst>
               <a:ext uri="{FF2B5EF4-FFF2-40B4-BE49-F238E27FC236}">
-                <a16:creationId xmlns:a16="http://schemas.microsoft.com/office/drawing/2014/main" id="{EC154C83-B61B-662F-DA23-70D5CDC433FF}"/>
+                <a16:creationId xmlns:a16="http://schemas.microsoft.com/office/drawing/2014/main" id="{721D9F4E-AC4A-DF16-AD6C-C11DCA6EB7DA}"/>
               </a:ext>
             </a:extLst>
           </p:cNvPr>
@@ -2158,7 +2158,7 @@
           <p:cNvPr id="6" name="Espaço Reservado para Número de Slide 5">
             <a:extLst>
               <a:ext uri="{FF2B5EF4-FFF2-40B4-BE49-F238E27FC236}">
-                <a16:creationId xmlns:a16="http://schemas.microsoft.com/office/drawing/2014/main" id="{4B24D901-E677-C5EE-8856-3962FA95C979}"/>
+                <a16:creationId xmlns:a16="http://schemas.microsoft.com/office/drawing/2014/main" id="{A56FC253-8D1E-1EDB-1A73-33B2555E9286}"/>
               </a:ext>
             </a:extLst>
           </p:cNvPr>
@@ -2174,7 +2174,7 @@
           <a:bodyPr/>
           <a:lstStyle/>
           <a:p>
-            <a:fld id="{820B318C-A250-4EE9-97D4-C4723DE988C6}" type="slidenum">
+            <a:fld id="{1F74E298-800F-430B-B75D-DE368AAA8DFD}" type="slidenum">
               <a:rPr lang="pt-BR" smtClean="0"/>
               <a:t>‹nº›</a:t>
             </a:fld>
@@ -2185,7 +2185,7 @@
     </p:spTree>
     <p:extLst>
       <p:ext uri="{BB962C8B-B14F-4D97-AF65-F5344CB8AC3E}">
-        <p14:creationId xmlns:p14="http://schemas.microsoft.com/office/powerpoint/2010/main" val="2904036352"/>
+        <p14:creationId xmlns:p14="http://schemas.microsoft.com/office/powerpoint/2010/main" val="2233074246"/>
       </p:ext>
     </p:extLst>
   </p:cSld>
@@ -2217,7 +2217,7 @@
           <p:cNvPr id="2" name="Título 1">
             <a:extLst>
               <a:ext uri="{FF2B5EF4-FFF2-40B4-BE49-F238E27FC236}">
-                <a16:creationId xmlns:a16="http://schemas.microsoft.com/office/drawing/2014/main" id="{5389A400-F636-C659-F67B-BB22D4861227}"/>
+                <a16:creationId xmlns:a16="http://schemas.microsoft.com/office/drawing/2014/main" id="{F64177F4-4662-0D70-A544-FDE8E5F7204D}"/>
               </a:ext>
             </a:extLst>
           </p:cNvPr>
@@ -2245,7 +2245,7 @@
           <p:cNvPr id="3" name="Espaço Reservado para Conteúdo 2">
             <a:extLst>
               <a:ext uri="{FF2B5EF4-FFF2-40B4-BE49-F238E27FC236}">
-                <a16:creationId xmlns:a16="http://schemas.microsoft.com/office/drawing/2014/main" id="{86E8B646-ABCF-BBB4-600F-435DDB2ACF0F}"/>
+                <a16:creationId xmlns:a16="http://schemas.microsoft.com/office/drawing/2014/main" id="{A05BA256-2EC9-1887-D35E-9F059732EB6E}"/>
               </a:ext>
             </a:extLst>
           </p:cNvPr>
@@ -2302,7 +2302,7 @@
           <p:cNvPr id="4" name="Espaço Reservado para Data 3">
             <a:extLst>
               <a:ext uri="{FF2B5EF4-FFF2-40B4-BE49-F238E27FC236}">
-                <a16:creationId xmlns:a16="http://schemas.microsoft.com/office/drawing/2014/main" id="{DA83529C-F7A2-79A9-E4AE-5D5E1E2A17DA}"/>
+                <a16:creationId xmlns:a16="http://schemas.microsoft.com/office/drawing/2014/main" id="{0807CEF5-85F0-8E8F-A908-274CA2B326E6}"/>
               </a:ext>
             </a:extLst>
           </p:cNvPr>
@@ -2318,7 +2318,7 @@
           <a:bodyPr/>
           <a:lstStyle/>
           <a:p>
-            <a:fld id="{37BC8248-C4A9-4E61-9781-4EA1B2387A6F}" type="datetimeFigureOut">
+            <a:fld id="{53940624-BB9A-4F64-9034-800251E0A6B4}" type="datetimeFigureOut">
               <a:rPr lang="pt-BR" smtClean="0"/>
               <a:t>19/08/2026</a:t>
             </a:fld>
@@ -2331,7 +2331,7 @@
           <p:cNvPr id="5" name="Espaço Reservado para Rodapé 4">
             <a:extLst>
               <a:ext uri="{FF2B5EF4-FFF2-40B4-BE49-F238E27FC236}">
-                <a16:creationId xmlns:a16="http://schemas.microsoft.com/office/drawing/2014/main" id="{9520B75F-5F3B-32EF-2E35-47CCFCC650B4}"/>
+                <a16:creationId xmlns:a16="http://schemas.microsoft.com/office/drawing/2014/main" id="{AC3668FE-E658-BA8C-A6DF-C2073E8B66DB}"/>
               </a:ext>
             </a:extLst>
           </p:cNvPr>
@@ -2356,7 +2356,7 @@
           <p:cNvPr id="6" name="Espaço Reservado para Número de Slide 5">
             <a:extLst>
               <a:ext uri="{FF2B5EF4-FFF2-40B4-BE49-F238E27FC236}">
-                <a16:creationId xmlns:a16="http://schemas.microsoft.com/office/drawing/2014/main" id="{338AAAF4-BC19-7E10-4AE0-FF1E4C66009B}"/>
+                <a16:creationId xmlns:a16="http://schemas.microsoft.com/office/drawing/2014/main" id="{DDF3A636-2CC0-CF64-72BF-5CC7CFD5D359}"/>
               </a:ext>
             </a:extLst>
           </p:cNvPr>
@@ -2372,7 +2372,7 @@
           <a:bodyPr/>
           <a:lstStyle/>
           <a:p>
-            <a:fld id="{820B318C-A250-4EE9-97D4-C4723DE988C6}" type="slidenum">
+            <a:fld id="{1F74E298-800F-430B-B75D-DE368AAA8DFD}" type="slidenum">
               <a:rPr lang="pt-BR" smtClean="0"/>
               <a:t>‹nº›</a:t>
             </a:fld>
@@ -2383,7 +2383,7 @@
     </p:spTree>
     <p:extLst>
       <p:ext uri="{BB962C8B-B14F-4D97-AF65-F5344CB8AC3E}">
-        <p14:creationId xmlns:p14="http://schemas.microsoft.com/office/powerpoint/2010/main" val="4276498406"/>
+        <p14:creationId xmlns:p14="http://schemas.microsoft.com/office/powerpoint/2010/main" val="1237846446"/>
       </p:ext>
     </p:extLst>
   </p:cSld>
@@ -2415,7 +2415,7 @@
           <p:cNvPr id="2" name="Título 1">
             <a:extLst>
               <a:ext uri="{FF2B5EF4-FFF2-40B4-BE49-F238E27FC236}">
-                <a16:creationId xmlns:a16="http://schemas.microsoft.com/office/drawing/2014/main" id="{568F2D1C-9697-1248-C796-41ADC7756968}"/>
+                <a16:creationId xmlns:a16="http://schemas.microsoft.com/office/drawing/2014/main" id="{5E100BFF-FD8A-83A0-1DE8-E2195E4A3BDC}"/>
               </a:ext>
             </a:extLst>
           </p:cNvPr>
@@ -2452,7 +2452,7 @@
           <p:cNvPr id="3" name="Espaço Reservado para Texto 2">
             <a:extLst>
               <a:ext uri="{FF2B5EF4-FFF2-40B4-BE49-F238E27FC236}">
-                <a16:creationId xmlns:a16="http://schemas.microsoft.com/office/drawing/2014/main" id="{912E87B2-8F61-2253-64A1-20321033AF65}"/>
+                <a16:creationId xmlns:a16="http://schemas.microsoft.com/office/drawing/2014/main" id="{2E04FDDF-F2E1-F2E2-7230-55B1A13698BB}"/>
               </a:ext>
             </a:extLst>
           </p:cNvPr>
@@ -2577,7 +2577,7 @@
           <p:cNvPr id="4" name="Espaço Reservado para Data 3">
             <a:extLst>
               <a:ext uri="{FF2B5EF4-FFF2-40B4-BE49-F238E27FC236}">
-                <a16:creationId xmlns:a16="http://schemas.microsoft.com/office/drawing/2014/main" id="{8BC172D1-47D5-D8CA-2334-5038DFAA336E}"/>
+                <a16:creationId xmlns:a16="http://schemas.microsoft.com/office/drawing/2014/main" id="{95A5545D-C20B-1B91-15DC-297CC02311BC}"/>
               </a:ext>
             </a:extLst>
           </p:cNvPr>
@@ -2593,7 +2593,7 @@
           <a:bodyPr/>
           <a:lstStyle/>
           <a:p>
-            <a:fld id="{37BC8248-C4A9-4E61-9781-4EA1B2387A6F}" type="datetimeFigureOut">
+            <a:fld id="{53940624-BB9A-4F64-9034-800251E0A6B4}" type="datetimeFigureOut">
               <a:rPr lang="pt-BR" smtClean="0"/>
               <a:t>19/08/2026</a:t>
             </a:fld>
@@ -2606,7 +2606,7 @@
           <p:cNvPr id="5" name="Espaço Reservado para Rodapé 4">
             <a:extLst>
               <a:ext uri="{FF2B5EF4-FFF2-40B4-BE49-F238E27FC236}">
-                <a16:creationId xmlns:a16="http://schemas.microsoft.com/office/drawing/2014/main" id="{635176DC-2971-6CB3-0178-88C0AAD0834F}"/>
+                <a16:creationId xmlns:a16="http://schemas.microsoft.com/office/drawing/2014/main" id="{93FE2C6E-8164-43FB-59FF-EE3158417EBC}"/>
               </a:ext>
             </a:extLst>
           </p:cNvPr>
@@ -2631,7 +2631,7 @@
           <p:cNvPr id="6" name="Espaço Reservado para Número de Slide 5">
             <a:extLst>
               <a:ext uri="{FF2B5EF4-FFF2-40B4-BE49-F238E27FC236}">
-                <a16:creationId xmlns:a16="http://schemas.microsoft.com/office/drawing/2014/main" id="{0ADDC02B-9960-40F6-7A0D-E07A375656F7}"/>
+                <a16:creationId xmlns:a16="http://schemas.microsoft.com/office/drawing/2014/main" id="{AD012BC1-BBAA-EC2E-6C14-5CDE175A3BA3}"/>
               </a:ext>
             </a:extLst>
           </p:cNvPr>
@@ -2647,7 +2647,7 @@
           <a:bodyPr/>
           <a:lstStyle/>
           <a:p>
-            <a:fld id="{820B318C-A250-4EE9-97D4-C4723DE988C6}" type="slidenum">
+            <a:fld id="{1F74E298-800F-430B-B75D-DE368AAA8DFD}" type="slidenum">
               <a:rPr lang="pt-BR" smtClean="0"/>
               <a:t>‹nº›</a:t>
             </a:fld>
@@ -2658,7 +2658,7 @@
     </p:spTree>
     <p:extLst>
       <p:ext uri="{BB962C8B-B14F-4D97-AF65-F5344CB8AC3E}">
-        <p14:creationId xmlns:p14="http://schemas.microsoft.com/office/powerpoint/2010/main" val="2437162514"/>
+        <p14:creationId xmlns:p14="http://schemas.microsoft.com/office/powerpoint/2010/main" val="1936295174"/>
       </p:ext>
     </p:extLst>
   </p:cSld>
@@ -2690,7 +2690,7 @@
           <p:cNvPr id="2" name="Título 1">
             <a:extLst>
               <a:ext uri="{FF2B5EF4-FFF2-40B4-BE49-F238E27FC236}">
-                <a16:creationId xmlns:a16="http://schemas.microsoft.com/office/drawing/2014/main" id="{9623CE90-C9A9-6888-72F2-EDE94421E671}"/>
+                <a16:creationId xmlns:a16="http://schemas.microsoft.com/office/drawing/2014/main" id="{5551D1B2-39A3-BC76-2D7C-6344813D6E93}"/>
               </a:ext>
             </a:extLst>
           </p:cNvPr>
@@ -2718,7 +2718,7 @@
           <p:cNvPr id="3" name="Espaço Reservado para Conteúdo 2">
             <a:extLst>
               <a:ext uri="{FF2B5EF4-FFF2-40B4-BE49-F238E27FC236}">
-                <a16:creationId xmlns:a16="http://schemas.microsoft.com/office/drawing/2014/main" id="{5710E77E-AD7B-7714-4591-0AE372749661}"/>
+                <a16:creationId xmlns:a16="http://schemas.microsoft.com/office/drawing/2014/main" id="{BA6BF66A-C751-DD08-1354-D149B5112906}"/>
               </a:ext>
             </a:extLst>
           </p:cNvPr>
@@ -2780,7 +2780,7 @@
           <p:cNvPr id="4" name="Espaço Reservado para Conteúdo 3">
             <a:extLst>
               <a:ext uri="{FF2B5EF4-FFF2-40B4-BE49-F238E27FC236}">
-                <a16:creationId xmlns:a16="http://schemas.microsoft.com/office/drawing/2014/main" id="{93CCB09E-3EAA-BBA2-7387-8D601F8A3A35}"/>
+                <a16:creationId xmlns:a16="http://schemas.microsoft.com/office/drawing/2014/main" id="{7228F6E2-82BD-FB7F-8CFC-5E8A61264456}"/>
               </a:ext>
             </a:extLst>
           </p:cNvPr>
@@ -2842,7 +2842,7 @@
           <p:cNvPr id="5" name="Espaço Reservado para Data 4">
             <a:extLst>
               <a:ext uri="{FF2B5EF4-FFF2-40B4-BE49-F238E27FC236}">
-                <a16:creationId xmlns:a16="http://schemas.microsoft.com/office/drawing/2014/main" id="{763DDBC4-E42E-088C-9705-7EABB085462D}"/>
+                <a16:creationId xmlns:a16="http://schemas.microsoft.com/office/drawing/2014/main" id="{2C0BF5A4-9050-D9F4-A74A-78510D65B09B}"/>
               </a:ext>
             </a:extLst>
           </p:cNvPr>
@@ -2858,7 +2858,7 @@
           <a:bodyPr/>
           <a:lstStyle/>
           <a:p>
-            <a:fld id="{37BC8248-C4A9-4E61-9781-4EA1B2387A6F}" type="datetimeFigureOut">
+            <a:fld id="{53940624-BB9A-4F64-9034-800251E0A6B4}" type="datetimeFigureOut">
               <a:rPr lang="pt-BR" smtClean="0"/>
               <a:t>19/08/2026</a:t>
             </a:fld>
@@ -2871,7 +2871,7 @@
           <p:cNvPr id="6" name="Espaço Reservado para Rodapé 5">
             <a:extLst>
               <a:ext uri="{FF2B5EF4-FFF2-40B4-BE49-F238E27FC236}">
-                <a16:creationId xmlns:a16="http://schemas.microsoft.com/office/drawing/2014/main" id="{A2503B7F-1877-8260-F5D5-5F396641F547}"/>
+                <a16:creationId xmlns:a16="http://schemas.microsoft.com/office/drawing/2014/main" id="{2EB97833-639C-E0B4-0CD8-BB1F37E7F702}"/>
               </a:ext>
             </a:extLst>
           </p:cNvPr>
@@ -2896,7 +2896,7 @@
           <p:cNvPr id="7" name="Espaço Reservado para Número de Slide 6">
             <a:extLst>
               <a:ext uri="{FF2B5EF4-FFF2-40B4-BE49-F238E27FC236}">
-                <a16:creationId xmlns:a16="http://schemas.microsoft.com/office/drawing/2014/main" id="{69765728-8424-FBDF-0B32-0A8E1D6E15BB}"/>
+                <a16:creationId xmlns:a16="http://schemas.microsoft.com/office/drawing/2014/main" id="{DC20E567-54AB-9ADE-87A5-A553BDC07311}"/>
               </a:ext>
             </a:extLst>
           </p:cNvPr>
@@ -2912,7 +2912,7 @@
           <a:bodyPr/>
           <a:lstStyle/>
           <a:p>
-            <a:fld id="{820B318C-A250-4EE9-97D4-C4723DE988C6}" type="slidenum">
+            <a:fld id="{1F74E298-800F-430B-B75D-DE368AAA8DFD}" type="slidenum">
               <a:rPr lang="pt-BR" smtClean="0"/>
               <a:t>‹nº›</a:t>
             </a:fld>
@@ -2923,7 +2923,7 @@
     </p:spTree>
     <p:extLst>
       <p:ext uri="{BB962C8B-B14F-4D97-AF65-F5344CB8AC3E}">
-        <p14:creationId xmlns:p14="http://schemas.microsoft.com/office/powerpoint/2010/main" val="1124049683"/>
+        <p14:creationId xmlns:p14="http://schemas.microsoft.com/office/powerpoint/2010/main" val="1833805124"/>
       </p:ext>
     </p:extLst>
   </p:cSld>
@@ -2955,7 +2955,7 @@
           <p:cNvPr id="2" name="Título 1">
             <a:extLst>
               <a:ext uri="{FF2B5EF4-FFF2-40B4-BE49-F238E27FC236}">
-                <a16:creationId xmlns:a16="http://schemas.microsoft.com/office/drawing/2014/main" id="{AB30FE9E-0564-A5AF-ED28-D502A8DD91CB}"/>
+                <a16:creationId xmlns:a16="http://schemas.microsoft.com/office/drawing/2014/main" id="{10E4C41B-EDBA-557C-2FE3-38B10A53EF9B}"/>
               </a:ext>
             </a:extLst>
           </p:cNvPr>
@@ -2988,7 +2988,7 @@
           <p:cNvPr id="3" name="Espaço Reservado para Texto 2">
             <a:extLst>
               <a:ext uri="{FF2B5EF4-FFF2-40B4-BE49-F238E27FC236}">
-                <a16:creationId xmlns:a16="http://schemas.microsoft.com/office/drawing/2014/main" id="{ED54E1E1-71E1-7222-A47D-CD83AA8CC0D8}"/>
+                <a16:creationId xmlns:a16="http://schemas.microsoft.com/office/drawing/2014/main" id="{FD1D5AAA-3FFF-0F48-45E3-E9BCED74288A}"/>
               </a:ext>
             </a:extLst>
           </p:cNvPr>
@@ -3059,7 +3059,7 @@
           <p:cNvPr id="4" name="Espaço Reservado para Conteúdo 3">
             <a:extLst>
               <a:ext uri="{FF2B5EF4-FFF2-40B4-BE49-F238E27FC236}">
-                <a16:creationId xmlns:a16="http://schemas.microsoft.com/office/drawing/2014/main" id="{64089F9B-1699-32F2-4C15-D147D0FCDCB7}"/>
+                <a16:creationId xmlns:a16="http://schemas.microsoft.com/office/drawing/2014/main" id="{4FD81949-DED9-D755-EBF3-97DEB44073D6}"/>
               </a:ext>
             </a:extLst>
           </p:cNvPr>
@@ -3121,7 +3121,7 @@
           <p:cNvPr id="5" name="Espaço Reservado para Texto 4">
             <a:extLst>
               <a:ext uri="{FF2B5EF4-FFF2-40B4-BE49-F238E27FC236}">
-                <a16:creationId xmlns:a16="http://schemas.microsoft.com/office/drawing/2014/main" id="{C683B308-4BE3-BF35-5325-AF50AB028157}"/>
+                <a16:creationId xmlns:a16="http://schemas.microsoft.com/office/drawing/2014/main" id="{8AB0A417-1901-7FA3-1659-F6FACE297E72}"/>
               </a:ext>
             </a:extLst>
           </p:cNvPr>
@@ -3192,7 +3192,7 @@
           <p:cNvPr id="6" name="Espaço Reservado para Conteúdo 5">
             <a:extLst>
               <a:ext uri="{FF2B5EF4-FFF2-40B4-BE49-F238E27FC236}">
-                <a16:creationId xmlns:a16="http://schemas.microsoft.com/office/drawing/2014/main" id="{AD21A58A-903B-F3DF-E0B0-77CF8BF0BAF8}"/>
+                <a16:creationId xmlns:a16="http://schemas.microsoft.com/office/drawing/2014/main" id="{0D02D08D-73BD-ACA5-2CAC-6E7B3E7C0AC4}"/>
               </a:ext>
             </a:extLst>
           </p:cNvPr>
@@ -3254,7 +3254,7 @@
           <p:cNvPr id="7" name="Espaço Reservado para Data 6">
             <a:extLst>
               <a:ext uri="{FF2B5EF4-FFF2-40B4-BE49-F238E27FC236}">
-                <a16:creationId xmlns:a16="http://schemas.microsoft.com/office/drawing/2014/main" id="{881610F9-4A30-FF81-AD9E-EFC552C86ADE}"/>
+                <a16:creationId xmlns:a16="http://schemas.microsoft.com/office/drawing/2014/main" id="{BD806257-070E-1C73-EDD8-F77771C300C1}"/>
               </a:ext>
             </a:extLst>
           </p:cNvPr>
@@ -3270,7 +3270,7 @@
           <a:bodyPr/>
           <a:lstStyle/>
           <a:p>
-            <a:fld id="{37BC8248-C4A9-4E61-9781-4EA1B2387A6F}" type="datetimeFigureOut">
+            <a:fld id="{53940624-BB9A-4F64-9034-800251E0A6B4}" type="datetimeFigureOut">
               <a:rPr lang="pt-BR" smtClean="0"/>
               <a:t>19/08/2026</a:t>
             </a:fld>
@@ -3283,7 +3283,7 @@
           <p:cNvPr id="8" name="Espaço Reservado para Rodapé 7">
             <a:extLst>
               <a:ext uri="{FF2B5EF4-FFF2-40B4-BE49-F238E27FC236}">
-                <a16:creationId xmlns:a16="http://schemas.microsoft.com/office/drawing/2014/main" id="{9947FD18-EDB2-2C83-A274-7DE041E36282}"/>
+                <a16:creationId xmlns:a16="http://schemas.microsoft.com/office/drawing/2014/main" id="{F80BDA73-0129-5F94-FCD3-BC00AC3FCBBF}"/>
               </a:ext>
             </a:extLst>
           </p:cNvPr>
@@ -3308,7 +3308,7 @@
           <p:cNvPr id="9" name="Espaço Reservado para Número de Slide 8">
             <a:extLst>
               <a:ext uri="{FF2B5EF4-FFF2-40B4-BE49-F238E27FC236}">
-                <a16:creationId xmlns:a16="http://schemas.microsoft.com/office/drawing/2014/main" id="{E680074C-ADF9-C4F7-0504-D0CDBF519D06}"/>
+                <a16:creationId xmlns:a16="http://schemas.microsoft.com/office/drawing/2014/main" id="{716ED4D9-82BC-1FDB-8C75-776B8894BE83}"/>
               </a:ext>
             </a:extLst>
           </p:cNvPr>
@@ -3324,7 +3324,7 @@
           <a:bodyPr/>
           <a:lstStyle/>
           <a:p>
-            <a:fld id="{820B318C-A250-4EE9-97D4-C4723DE988C6}" type="slidenum">
+            <a:fld id="{1F74E298-800F-430B-B75D-DE368AAA8DFD}" type="slidenum">
               <a:rPr lang="pt-BR" smtClean="0"/>
               <a:t>‹nº›</a:t>
             </a:fld>
@@ -3335,7 +3335,7 @@
     </p:spTree>
     <p:extLst>
       <p:ext uri="{BB962C8B-B14F-4D97-AF65-F5344CB8AC3E}">
-        <p14:creationId xmlns:p14="http://schemas.microsoft.com/office/powerpoint/2010/main" val="1773102299"/>
+        <p14:creationId xmlns:p14="http://schemas.microsoft.com/office/powerpoint/2010/main" val="3830999354"/>
       </p:ext>
     </p:extLst>
   </p:cSld>
@@ -3367,7 +3367,7 @@
           <p:cNvPr id="2" name="Título 1">
             <a:extLst>
               <a:ext uri="{FF2B5EF4-FFF2-40B4-BE49-F238E27FC236}">
-                <a16:creationId xmlns:a16="http://schemas.microsoft.com/office/drawing/2014/main" id="{D09D260E-80F0-E056-FBFD-294BC8808C7A}"/>
+                <a16:creationId xmlns:a16="http://schemas.microsoft.com/office/drawing/2014/main" id="{50DC6364-6E06-93BE-A778-1344CABCF0C6}"/>
               </a:ext>
             </a:extLst>
           </p:cNvPr>
@@ -3395,7 +3395,7 @@
           <p:cNvPr id="3" name="Espaço Reservado para Data 2">
             <a:extLst>
               <a:ext uri="{FF2B5EF4-FFF2-40B4-BE49-F238E27FC236}">
-                <a16:creationId xmlns:a16="http://schemas.microsoft.com/office/drawing/2014/main" id="{4196926E-8F15-AF51-318B-3905D5E57F88}"/>
+                <a16:creationId xmlns:a16="http://schemas.microsoft.com/office/drawing/2014/main" id="{A5FDDD78-1945-A972-5B79-DD72D44ED4CA}"/>
               </a:ext>
             </a:extLst>
           </p:cNvPr>
@@ -3411,7 +3411,7 @@
           <a:bodyPr/>
           <a:lstStyle/>
           <a:p>
-            <a:fld id="{37BC8248-C4A9-4E61-9781-4EA1B2387A6F}" type="datetimeFigureOut">
+            <a:fld id="{53940624-BB9A-4F64-9034-800251E0A6B4}" type="datetimeFigureOut">
               <a:rPr lang="pt-BR" smtClean="0"/>
               <a:t>19/08/2026</a:t>
             </a:fld>
@@ -3424,7 +3424,7 @@
           <p:cNvPr id="4" name="Espaço Reservado para Rodapé 3">
             <a:extLst>
               <a:ext uri="{FF2B5EF4-FFF2-40B4-BE49-F238E27FC236}">
-                <a16:creationId xmlns:a16="http://schemas.microsoft.com/office/drawing/2014/main" id="{D48726F9-A39D-D485-EEB0-5E4EB3A503F8}"/>
+                <a16:creationId xmlns:a16="http://schemas.microsoft.com/office/drawing/2014/main" id="{2247932A-A8C6-6DBA-D50A-E331B6514E08}"/>
               </a:ext>
             </a:extLst>
           </p:cNvPr>
@@ -3449,7 +3449,7 @@
           <p:cNvPr id="5" name="Espaço Reservado para Número de Slide 4">
             <a:extLst>
               <a:ext uri="{FF2B5EF4-FFF2-40B4-BE49-F238E27FC236}">
-                <a16:creationId xmlns:a16="http://schemas.microsoft.com/office/drawing/2014/main" id="{705B66E6-A2CF-D018-92E2-F9522F80A81A}"/>
+                <a16:creationId xmlns:a16="http://schemas.microsoft.com/office/drawing/2014/main" id="{CB6A0A59-7415-2E79-FE73-7E46614A5DDA}"/>
               </a:ext>
             </a:extLst>
           </p:cNvPr>
@@ -3465,7 +3465,7 @@
           <a:bodyPr/>
           <a:lstStyle/>
           <a:p>
-            <a:fld id="{820B318C-A250-4EE9-97D4-C4723DE988C6}" type="slidenum">
+            <a:fld id="{1F74E298-800F-430B-B75D-DE368AAA8DFD}" type="slidenum">
               <a:rPr lang="pt-BR" smtClean="0"/>
               <a:t>‹nº›</a:t>
             </a:fld>
@@ -3476,7 +3476,7 @@
     </p:spTree>
     <p:extLst>
       <p:ext uri="{BB962C8B-B14F-4D97-AF65-F5344CB8AC3E}">
-        <p14:creationId xmlns:p14="http://schemas.microsoft.com/office/powerpoint/2010/main" val="425684546"/>
+        <p14:creationId xmlns:p14="http://schemas.microsoft.com/office/powerpoint/2010/main" val="1984280308"/>
       </p:ext>
     </p:extLst>
   </p:cSld>
@@ -3508,7 +3508,7 @@
           <p:cNvPr id="2" name="Espaço Reservado para Data 1">
             <a:extLst>
               <a:ext uri="{FF2B5EF4-FFF2-40B4-BE49-F238E27FC236}">
-                <a16:creationId xmlns:a16="http://schemas.microsoft.com/office/drawing/2014/main" id="{09D7F8C9-A514-D4DA-C4CB-EFDA155F35C8}"/>
+                <a16:creationId xmlns:a16="http://schemas.microsoft.com/office/drawing/2014/main" id="{1EC549AE-23AF-D2CF-B919-D71FB753B0A5}"/>
               </a:ext>
             </a:extLst>
           </p:cNvPr>
@@ -3524,7 +3524,7 @@
           <a:bodyPr/>
           <a:lstStyle/>
           <a:p>
-            <a:fld id="{37BC8248-C4A9-4E61-9781-4EA1B2387A6F}" type="datetimeFigureOut">
+            <a:fld id="{53940624-BB9A-4F64-9034-800251E0A6B4}" type="datetimeFigureOut">
               <a:rPr lang="pt-BR" smtClean="0"/>
               <a:t>19/08/2026</a:t>
             </a:fld>
@@ -3537,7 +3537,7 @@
           <p:cNvPr id="3" name="Espaço Reservado para Rodapé 2">
             <a:extLst>
               <a:ext uri="{FF2B5EF4-FFF2-40B4-BE49-F238E27FC236}">
-                <a16:creationId xmlns:a16="http://schemas.microsoft.com/office/drawing/2014/main" id="{4259CDD1-E000-524F-2FA1-1F92BB37C449}"/>
+                <a16:creationId xmlns:a16="http://schemas.microsoft.com/office/drawing/2014/main" id="{485872E2-63D8-7819-E8AB-3300301BBB34}"/>
               </a:ext>
             </a:extLst>
           </p:cNvPr>
@@ -3562,7 +3562,7 @@
           <p:cNvPr id="4" name="Espaço Reservado para Número de Slide 3">
             <a:extLst>
               <a:ext uri="{FF2B5EF4-FFF2-40B4-BE49-F238E27FC236}">
-                <a16:creationId xmlns:a16="http://schemas.microsoft.com/office/drawing/2014/main" id="{EFC225A2-25C5-43E7-2341-C9DA0EF964DA}"/>
+                <a16:creationId xmlns:a16="http://schemas.microsoft.com/office/drawing/2014/main" id="{EFB70FFF-BF16-71FE-756B-20A4A4E70AF5}"/>
               </a:ext>
             </a:extLst>
           </p:cNvPr>
@@ -3578,7 +3578,7 @@
           <a:bodyPr/>
           <a:lstStyle/>
           <a:p>
-            <a:fld id="{820B318C-A250-4EE9-97D4-C4723DE988C6}" type="slidenum">
+            <a:fld id="{1F74E298-800F-430B-B75D-DE368AAA8DFD}" type="slidenum">
               <a:rPr lang="pt-BR" smtClean="0"/>
               <a:t>‹nº›</a:t>
             </a:fld>
@@ -3589,7 +3589,7 @@
     </p:spTree>
     <p:extLst>
       <p:ext uri="{BB962C8B-B14F-4D97-AF65-F5344CB8AC3E}">
-        <p14:creationId xmlns:p14="http://schemas.microsoft.com/office/powerpoint/2010/main" val="746828226"/>
+        <p14:creationId xmlns:p14="http://schemas.microsoft.com/office/powerpoint/2010/main" val="2194841998"/>
       </p:ext>
     </p:extLst>
   </p:cSld>
@@ -3621,7 +3621,7 @@
           <p:cNvPr id="2" name="Título 1">
             <a:extLst>
               <a:ext uri="{FF2B5EF4-FFF2-40B4-BE49-F238E27FC236}">
-                <a16:creationId xmlns:a16="http://schemas.microsoft.com/office/drawing/2014/main" id="{4A7308CD-7348-900A-117F-1E54B649A6B5}"/>
+                <a16:creationId xmlns:a16="http://schemas.microsoft.com/office/drawing/2014/main" id="{64C777AF-1827-874E-C09C-F5496D1CF446}"/>
               </a:ext>
             </a:extLst>
           </p:cNvPr>
@@ -3658,7 +3658,7 @@
           <p:cNvPr id="3" name="Espaço Reservado para Conteúdo 2">
             <a:extLst>
               <a:ext uri="{FF2B5EF4-FFF2-40B4-BE49-F238E27FC236}">
-                <a16:creationId xmlns:a16="http://schemas.microsoft.com/office/drawing/2014/main" id="{3A928FAF-ADC1-9E29-8C47-28F00B9767EE}"/>
+                <a16:creationId xmlns:a16="http://schemas.microsoft.com/office/drawing/2014/main" id="{4D3DF6F9-9D0F-1C3A-A614-3F52E0803D41}"/>
               </a:ext>
             </a:extLst>
           </p:cNvPr>
@@ -3748,7 +3748,7 @@
           <p:cNvPr id="4" name="Espaço Reservado para Texto 3">
             <a:extLst>
               <a:ext uri="{FF2B5EF4-FFF2-40B4-BE49-F238E27FC236}">
-                <a16:creationId xmlns:a16="http://schemas.microsoft.com/office/drawing/2014/main" id="{A8F704C6-0D99-FFC0-B7B9-CDD02FDDB53C}"/>
+                <a16:creationId xmlns:a16="http://schemas.microsoft.com/office/drawing/2014/main" id="{543D7E05-6537-F70E-F096-E753B363C09F}"/>
               </a:ext>
             </a:extLst>
           </p:cNvPr>
@@ -3819,7 +3819,7 @@
           <p:cNvPr id="5" name="Espaço Reservado para Data 4">
             <a:extLst>
               <a:ext uri="{FF2B5EF4-FFF2-40B4-BE49-F238E27FC236}">
-                <a16:creationId xmlns:a16="http://schemas.microsoft.com/office/drawing/2014/main" id="{B60540B8-031F-8A71-7B0E-B2FEF748E1CD}"/>
+                <a16:creationId xmlns:a16="http://schemas.microsoft.com/office/drawing/2014/main" id="{53897F4D-2151-7010-8802-A92BC1DAD977}"/>
               </a:ext>
             </a:extLst>
           </p:cNvPr>
@@ -3835,7 +3835,7 @@
           <a:bodyPr/>
           <a:lstStyle/>
           <a:p>
-            <a:fld id="{37BC8248-C4A9-4E61-9781-4EA1B2387A6F}" type="datetimeFigureOut">
+            <a:fld id="{53940624-BB9A-4F64-9034-800251E0A6B4}" type="datetimeFigureOut">
               <a:rPr lang="pt-BR" smtClean="0"/>
               <a:t>19/08/2026</a:t>
             </a:fld>
@@ -3848,7 +3848,7 @@
           <p:cNvPr id="6" name="Espaço Reservado para Rodapé 5">
             <a:extLst>
               <a:ext uri="{FF2B5EF4-FFF2-40B4-BE49-F238E27FC236}">
-                <a16:creationId xmlns:a16="http://schemas.microsoft.com/office/drawing/2014/main" id="{C0A94ECE-9A31-E54A-2B80-B64747557268}"/>
+                <a16:creationId xmlns:a16="http://schemas.microsoft.com/office/drawing/2014/main" id="{BC0EBC63-CA06-7BA8-CEA1-5203E59CE02B}"/>
               </a:ext>
             </a:extLst>
           </p:cNvPr>
@@ -3873,7 +3873,7 @@
           <p:cNvPr id="7" name="Espaço Reservado para Número de Slide 6">
             <a:extLst>
               <a:ext uri="{FF2B5EF4-FFF2-40B4-BE49-F238E27FC236}">
-                <a16:creationId xmlns:a16="http://schemas.microsoft.com/office/drawing/2014/main" id="{ED82A5BD-350C-5218-257A-299FE9E096CC}"/>
+                <a16:creationId xmlns:a16="http://schemas.microsoft.com/office/drawing/2014/main" id="{D32B787E-549E-3ABD-4E20-D663571B791C}"/>
               </a:ext>
             </a:extLst>
           </p:cNvPr>
@@ -3889,7 +3889,7 @@
           <a:bodyPr/>
           <a:lstStyle/>
           <a:p>
-            <a:fld id="{820B318C-A250-4EE9-97D4-C4723DE988C6}" type="slidenum">
+            <a:fld id="{1F74E298-800F-430B-B75D-DE368AAA8DFD}" type="slidenum">
               <a:rPr lang="pt-BR" smtClean="0"/>
               <a:t>‹nº›</a:t>
             </a:fld>
@@ -3900,7 +3900,7 @@
     </p:spTree>
     <p:extLst>
       <p:ext uri="{BB962C8B-B14F-4D97-AF65-F5344CB8AC3E}">
-        <p14:creationId xmlns:p14="http://schemas.microsoft.com/office/powerpoint/2010/main" val="4059871453"/>
+        <p14:creationId xmlns:p14="http://schemas.microsoft.com/office/powerpoint/2010/main" val="1695428105"/>
       </p:ext>
     </p:extLst>
   </p:cSld>
@@ -3932,7 +3932,7 @@
           <p:cNvPr id="2" name="Título 1">
             <a:extLst>
               <a:ext uri="{FF2B5EF4-FFF2-40B4-BE49-F238E27FC236}">
-                <a16:creationId xmlns:a16="http://schemas.microsoft.com/office/drawing/2014/main" id="{2287A77F-8BB9-9C06-6EDC-F7D4C4A2CAE4}"/>
+                <a16:creationId xmlns:a16="http://schemas.microsoft.com/office/drawing/2014/main" id="{70E73A7B-C5ED-510D-C299-F557C3E6E166}"/>
               </a:ext>
             </a:extLst>
           </p:cNvPr>
@@ -3969,7 +3969,7 @@
           <p:cNvPr id="3" name="Espaço Reservado para Imagem 2">
             <a:extLst>
               <a:ext uri="{FF2B5EF4-FFF2-40B4-BE49-F238E27FC236}">
-                <a16:creationId xmlns:a16="http://schemas.microsoft.com/office/drawing/2014/main" id="{BC6F9022-95EB-0E81-DE94-EAC7696EF602}"/>
+                <a16:creationId xmlns:a16="http://schemas.microsoft.com/office/drawing/2014/main" id="{B322142A-0A3E-D464-D86A-EFE8280EDE33}"/>
               </a:ext>
             </a:extLst>
           </p:cNvPr>
@@ -4036,7 +4036,7 @@
           <p:cNvPr id="4" name="Espaço Reservado para Texto 3">
             <a:extLst>
               <a:ext uri="{FF2B5EF4-FFF2-40B4-BE49-F238E27FC236}">
-                <a16:creationId xmlns:a16="http://schemas.microsoft.com/office/drawing/2014/main" id="{E703C834-A549-E6EE-FCF5-C844583CC171}"/>
+                <a16:creationId xmlns:a16="http://schemas.microsoft.com/office/drawing/2014/main" id="{9A2BFA24-D545-286F-6C04-D10983849E22}"/>
               </a:ext>
             </a:extLst>
           </p:cNvPr>
@@ -4107,7 +4107,7 @@
           <p:cNvPr id="5" name="Espaço Reservado para Data 4">
             <a:extLst>
               <a:ext uri="{FF2B5EF4-FFF2-40B4-BE49-F238E27FC236}">
-                <a16:creationId xmlns:a16="http://schemas.microsoft.com/office/drawing/2014/main" id="{328D01E3-C883-1CE3-47C1-A9E19856181A}"/>
+                <a16:creationId xmlns:a16="http://schemas.microsoft.com/office/drawing/2014/main" id="{F10B05D1-57BF-FEEF-3A00-6BD9C3AF9194}"/>
               </a:ext>
             </a:extLst>
           </p:cNvPr>
@@ -4123,7 +4123,7 @@
           <a:bodyPr/>
           <a:lstStyle/>
           <a:p>
-            <a:fld id="{37BC8248-C4A9-4E61-9781-4EA1B2387A6F}" type="datetimeFigureOut">
+            <a:fld id="{53940624-BB9A-4F64-9034-800251E0A6B4}" type="datetimeFigureOut">
               <a:rPr lang="pt-BR" smtClean="0"/>
               <a:t>19/08/2026</a:t>
             </a:fld>
@@ -4136,7 +4136,7 @@
           <p:cNvPr id="6" name="Espaço Reservado para Rodapé 5">
             <a:extLst>
               <a:ext uri="{FF2B5EF4-FFF2-40B4-BE49-F238E27FC236}">
-                <a16:creationId xmlns:a16="http://schemas.microsoft.com/office/drawing/2014/main" id="{2639BD28-C197-C3CD-351D-A6161A8A8EFF}"/>
+                <a16:creationId xmlns:a16="http://schemas.microsoft.com/office/drawing/2014/main" id="{7CE9C2B7-A934-9F3D-B445-B4658A15B4B8}"/>
               </a:ext>
             </a:extLst>
           </p:cNvPr>
@@ -4161,7 +4161,7 @@
           <p:cNvPr id="7" name="Espaço Reservado para Número de Slide 6">
             <a:extLst>
               <a:ext uri="{FF2B5EF4-FFF2-40B4-BE49-F238E27FC236}">
-                <a16:creationId xmlns:a16="http://schemas.microsoft.com/office/drawing/2014/main" id="{9CBB989F-0556-3198-251D-ADCBACF68C82}"/>
+                <a16:creationId xmlns:a16="http://schemas.microsoft.com/office/drawing/2014/main" id="{8A55B064-5553-A50A-839C-36069142E731}"/>
               </a:ext>
             </a:extLst>
           </p:cNvPr>
@@ -4177,7 +4177,7 @@
           <a:bodyPr/>
           <a:lstStyle/>
           <a:p>
-            <a:fld id="{820B318C-A250-4EE9-97D4-C4723DE988C6}" type="slidenum">
+            <a:fld id="{1F74E298-800F-430B-B75D-DE368AAA8DFD}" type="slidenum">
               <a:rPr lang="pt-BR" smtClean="0"/>
               <a:t>‹nº›</a:t>
             </a:fld>
@@ -4188,7 +4188,7 @@
     </p:spTree>
     <p:extLst>
       <p:ext uri="{BB962C8B-B14F-4D97-AF65-F5344CB8AC3E}">
-        <p14:creationId xmlns:p14="http://schemas.microsoft.com/office/powerpoint/2010/main" val="4096838882"/>
+        <p14:creationId xmlns:p14="http://schemas.microsoft.com/office/powerpoint/2010/main" val="3059572493"/>
       </p:ext>
     </p:extLst>
   </p:cSld>
@@ -4225,7 +4225,7 @@
           <p:cNvPr id="2" name="Espaço Reservado para Título 1">
             <a:extLst>
               <a:ext uri="{FF2B5EF4-FFF2-40B4-BE49-F238E27FC236}">
-                <a16:creationId xmlns:a16="http://schemas.microsoft.com/office/drawing/2014/main" id="{D594B7E0-3F3C-3AC4-2076-DB62CAEBCFC2}"/>
+                <a16:creationId xmlns:a16="http://schemas.microsoft.com/office/drawing/2014/main" id="{7AC38162-F2BB-2921-66ED-983C4B30F4E6}"/>
               </a:ext>
             </a:extLst>
           </p:cNvPr>
@@ -4263,7 +4263,7 @@
           <p:cNvPr id="3" name="Espaço Reservado para Texto 2">
             <a:extLst>
               <a:ext uri="{FF2B5EF4-FFF2-40B4-BE49-F238E27FC236}">
-                <a16:creationId xmlns:a16="http://schemas.microsoft.com/office/drawing/2014/main" id="{9CC25DF2-F8C7-DB6B-C84F-9D1AF5816669}"/>
+                <a16:creationId xmlns:a16="http://schemas.microsoft.com/office/drawing/2014/main" id="{78661A34-8CDE-8CBD-1EB6-C7D859506E1C}"/>
               </a:ext>
             </a:extLst>
           </p:cNvPr>
@@ -4330,7 +4330,7 @@
           <p:cNvPr id="4" name="Espaço Reservado para Data 3">
             <a:extLst>
               <a:ext uri="{FF2B5EF4-FFF2-40B4-BE49-F238E27FC236}">
-                <a16:creationId xmlns:a16="http://schemas.microsoft.com/office/drawing/2014/main" id="{FD2C780E-82E6-9462-0DB1-C6A1335E2C30}"/>
+                <a16:creationId xmlns:a16="http://schemas.microsoft.com/office/drawing/2014/main" id="{AC8035E6-BB6D-78B1-DE9A-FA53858410E6}"/>
               </a:ext>
             </a:extLst>
           </p:cNvPr>
@@ -4364,7 +4364,7 @@
             </a:lvl1pPr>
           </a:lstStyle>
           <a:p>
-            <a:fld id="{37BC8248-C4A9-4E61-9781-4EA1B2387A6F}" type="datetimeFigureOut">
+            <a:fld id="{53940624-BB9A-4F64-9034-800251E0A6B4}" type="datetimeFigureOut">
               <a:rPr lang="pt-BR" smtClean="0"/>
               <a:t>19/08/2026</a:t>
             </a:fld>
@@ -4377,7 +4377,7 @@
           <p:cNvPr id="5" name="Espaço Reservado para Rodapé 4">
             <a:extLst>
               <a:ext uri="{FF2B5EF4-FFF2-40B4-BE49-F238E27FC236}">
-                <a16:creationId xmlns:a16="http://schemas.microsoft.com/office/drawing/2014/main" id="{1757A781-314F-4D04-03C0-71DF51773B9F}"/>
+                <a16:creationId xmlns:a16="http://schemas.microsoft.com/office/drawing/2014/main" id="{4974CB51-DD9B-B7A3-51BF-13C611FA5CF8}"/>
               </a:ext>
             </a:extLst>
           </p:cNvPr>
@@ -4420,7 +4420,7 @@
           <p:cNvPr id="6" name="Espaço Reservado para Número de Slide 5">
             <a:extLst>
               <a:ext uri="{FF2B5EF4-FFF2-40B4-BE49-F238E27FC236}">
-                <a16:creationId xmlns:a16="http://schemas.microsoft.com/office/drawing/2014/main" id="{B75BFCEE-75AA-D748-EEEE-41889C4C75C1}"/>
+                <a16:creationId xmlns:a16="http://schemas.microsoft.com/office/drawing/2014/main" id="{7E26C2C7-459A-679D-D34E-26F00D14C8D7}"/>
               </a:ext>
             </a:extLst>
           </p:cNvPr>
@@ -4454,7 +4454,7 @@
             </a:lvl1pPr>
           </a:lstStyle>
           <a:p>
-            <a:fld id="{820B318C-A250-4EE9-97D4-C4723DE988C6}" type="slidenum">
+            <a:fld id="{1F74E298-800F-430B-B75D-DE368AAA8DFD}" type="slidenum">
               <a:rPr lang="pt-BR" smtClean="0"/>
               <a:t>‹nº›</a:t>
             </a:fld>
@@ -4465,7 +4465,7 @@
     </p:spTree>
     <p:extLst>
       <p:ext uri="{BB962C8B-B14F-4D97-AF65-F5344CB8AC3E}">
-        <p14:creationId xmlns:p14="http://schemas.microsoft.com/office/powerpoint/2010/main" val="3810412535"/>
+        <p14:creationId xmlns:p14="http://schemas.microsoft.com/office/powerpoint/2010/main" val="1144592998"/>
       </p:ext>
     </p:extLst>
   </p:cSld>
@@ -4796,7 +4796,7 @@
           <p:cNvPr id="2" name="Elipse 1">
             <a:extLst>
               <a:ext uri="{FF2B5EF4-FFF2-40B4-BE49-F238E27FC236}">
-                <a16:creationId xmlns:a16="http://schemas.microsoft.com/office/drawing/2014/main" id="{EB49C1DE-3340-AD29-1263-47C3BB7299CF}"/>
+                <a16:creationId xmlns:a16="http://schemas.microsoft.com/office/drawing/2014/main" id="{A38A50E1-5AFE-DEA1-9163-2205868E1D33}"/>
               </a:ext>
             </a:extLst>
           </p:cNvPr>
@@ -4866,7 +4866,7 @@
           <p:cNvPr id="3" name="Elipse 2">
             <a:extLst>
               <a:ext uri="{FF2B5EF4-FFF2-40B4-BE49-F238E27FC236}">
-                <a16:creationId xmlns:a16="http://schemas.microsoft.com/office/drawing/2014/main" id="{CEF48238-2DCE-A5F2-C903-67D8584C30A7}"/>
+                <a16:creationId xmlns:a16="http://schemas.microsoft.com/office/drawing/2014/main" id="{67FC2821-C4AB-7186-8E64-D406B5C40049}"/>
               </a:ext>
             </a:extLst>
           </p:cNvPr>
@@ -4936,7 +4936,7 @@
           <p:cNvPr id="4" name="Elipse 3">
             <a:extLst>
               <a:ext uri="{FF2B5EF4-FFF2-40B4-BE49-F238E27FC236}">
-                <a16:creationId xmlns:a16="http://schemas.microsoft.com/office/drawing/2014/main" id="{A06CC60C-7551-3718-5C1D-52CDD3A260F9}"/>
+                <a16:creationId xmlns:a16="http://schemas.microsoft.com/office/drawing/2014/main" id="{F23BCE36-B213-D219-1AEA-951917364E7C}"/>
               </a:ext>
             </a:extLst>
           </p:cNvPr>
@@ -5006,7 +5006,7 @@
           <p:cNvPr id="6" name="Imagem 5">
             <a:extLst>
               <a:ext uri="{FF2B5EF4-FFF2-40B4-BE49-F238E27FC236}">
-                <a16:creationId xmlns:a16="http://schemas.microsoft.com/office/drawing/2014/main" id="{5EB08315-DF01-C68A-C4D4-0F8D985BEEB9}"/>
+                <a16:creationId xmlns:a16="http://schemas.microsoft.com/office/drawing/2014/main" id="{A0643283-A238-BDED-175F-A8D2E8034F8F}"/>
               </a:ext>
             </a:extLst>
           </p:cNvPr>
@@ -5042,7 +5042,7 @@
           <p:cNvPr id="7" name="CaixaDeTexto 6">
             <a:extLst>
               <a:ext uri="{FF2B5EF4-FFF2-40B4-BE49-F238E27FC236}">
-                <a16:creationId xmlns:a16="http://schemas.microsoft.com/office/drawing/2014/main" id="{2801D32F-4331-27E3-3662-DA0B9E002665}"/>
+                <a16:creationId xmlns:a16="http://schemas.microsoft.com/office/drawing/2014/main" id="{0180A169-ACD8-25F0-B92D-7992184DD03E}"/>
               </a:ext>
             </a:extLst>
           </p:cNvPr>
@@ -5087,7 +5087,7 @@
           <p:cNvPr id="8" name="CaixaDeTexto 7">
             <a:extLst>
               <a:ext uri="{FF2B5EF4-FFF2-40B4-BE49-F238E27FC236}">
-                <a16:creationId xmlns:a16="http://schemas.microsoft.com/office/drawing/2014/main" id="{8593C9E9-E62D-7A0B-85B9-1DE0128F3F54}"/>
+                <a16:creationId xmlns:a16="http://schemas.microsoft.com/office/drawing/2014/main" id="{CC717307-14CF-CCF4-B806-4CBFAFDC7976}"/>
               </a:ext>
             </a:extLst>
           </p:cNvPr>
@@ -5192,7 +5192,7 @@
           <p:cNvPr id="9" name="CaixaDeTexto 8">
             <a:extLst>
               <a:ext uri="{FF2B5EF4-FFF2-40B4-BE49-F238E27FC236}">
-                <a16:creationId xmlns:a16="http://schemas.microsoft.com/office/drawing/2014/main" id="{0D6008B5-9C68-E8F8-ACB0-84A65B35445B}"/>
+                <a16:creationId xmlns:a16="http://schemas.microsoft.com/office/drawing/2014/main" id="{79C5D9D3-EC15-5D89-A94D-7E2A8CC74629}"/>
               </a:ext>
             </a:extLst>
           </p:cNvPr>
@@ -5237,7 +5237,7 @@
           <p:cNvPr id="27" name="Agrupar 26">
             <a:extLst>
               <a:ext uri="{FF2B5EF4-FFF2-40B4-BE49-F238E27FC236}">
-                <a16:creationId xmlns:a16="http://schemas.microsoft.com/office/drawing/2014/main" id="{EE28CA23-435F-8A33-E4D4-635B71928C99}"/>
+                <a16:creationId xmlns:a16="http://schemas.microsoft.com/office/drawing/2014/main" id="{F5407A56-BB02-61DB-B3C6-9582B5187BF0}"/>
               </a:ext>
             </a:extLst>
           </p:cNvPr>
@@ -5257,7 +5257,7 @@
             <p:cNvPr id="10" name="Elipse 9">
               <a:extLst>
                 <a:ext uri="{FF2B5EF4-FFF2-40B4-BE49-F238E27FC236}">
-                  <a16:creationId xmlns:a16="http://schemas.microsoft.com/office/drawing/2014/main" id="{39624BE1-4EC7-41FB-80F1-249E154DA7CD}"/>
+                  <a16:creationId xmlns:a16="http://schemas.microsoft.com/office/drawing/2014/main" id="{83F50A53-98AA-5E84-0EB1-28F21E7F36A3}"/>
                 </a:ext>
               </a:extLst>
             </p:cNvPr>
@@ -5325,7 +5325,7 @@
             <p:cNvPr id="11" name="Elipse 10">
               <a:extLst>
                 <a:ext uri="{FF2B5EF4-FFF2-40B4-BE49-F238E27FC236}">
-                  <a16:creationId xmlns:a16="http://schemas.microsoft.com/office/drawing/2014/main" id="{4FB90413-F1D6-030B-8B56-82EAE772ED9A}"/>
+                  <a16:creationId xmlns:a16="http://schemas.microsoft.com/office/drawing/2014/main" id="{5F144777-17A2-BC29-075A-C357A9D1DDC3}"/>
                 </a:ext>
               </a:extLst>
             </p:cNvPr>
@@ -5395,7 +5395,7 @@
             <p:cNvPr id="12" name="Elipse 11">
               <a:extLst>
                 <a:ext uri="{FF2B5EF4-FFF2-40B4-BE49-F238E27FC236}">
-                  <a16:creationId xmlns:a16="http://schemas.microsoft.com/office/drawing/2014/main" id="{3535A571-EDB0-A0E4-862F-605A9C62FE26}"/>
+                  <a16:creationId xmlns:a16="http://schemas.microsoft.com/office/drawing/2014/main" id="{535B4BAF-3284-C957-BF7D-F7CF05A41878}"/>
                 </a:ext>
               </a:extLst>
             </p:cNvPr>
@@ -5465,7 +5465,7 @@
             <p:cNvPr id="13" name="Conector reto 12">
               <a:extLst>
                 <a:ext uri="{FF2B5EF4-FFF2-40B4-BE49-F238E27FC236}">
-                  <a16:creationId xmlns:a16="http://schemas.microsoft.com/office/drawing/2014/main" id="{D8D2D499-0458-3B4A-CA8C-2FDECE9D237E}"/>
+                  <a16:creationId xmlns:a16="http://schemas.microsoft.com/office/drawing/2014/main" id="{B33713B0-1CE1-C180-C74E-CC3CAE916509}"/>
                 </a:ext>
               </a:extLst>
             </p:cNvPr>
@@ -5512,7 +5512,7 @@
             <p:cNvPr id="14" name="Conector reto 13">
               <a:extLst>
                 <a:ext uri="{FF2B5EF4-FFF2-40B4-BE49-F238E27FC236}">
-                  <a16:creationId xmlns:a16="http://schemas.microsoft.com/office/drawing/2014/main" id="{F82907DF-01D1-D725-F205-9903B3DCBBC2}"/>
+                  <a16:creationId xmlns:a16="http://schemas.microsoft.com/office/drawing/2014/main" id="{1B058F43-6119-23D6-C59C-8FE81CEB0ADD}"/>
                 </a:ext>
               </a:extLst>
             </p:cNvPr>
@@ -5559,7 +5559,7 @@
             <p:cNvPr id="15" name="Conector reto 14">
               <a:extLst>
                 <a:ext uri="{FF2B5EF4-FFF2-40B4-BE49-F238E27FC236}">
-                  <a16:creationId xmlns:a16="http://schemas.microsoft.com/office/drawing/2014/main" id="{E88630DA-5FAA-1417-AD97-CC4F3156C51B}"/>
+                  <a16:creationId xmlns:a16="http://schemas.microsoft.com/office/drawing/2014/main" id="{8C17E2C1-254E-56AE-8377-A13008C72BA9}"/>
                 </a:ext>
               </a:extLst>
             </p:cNvPr>
@@ -5606,7 +5606,7 @@
             <p:cNvPr id="16" name="Conector reto 15">
               <a:extLst>
                 <a:ext uri="{FF2B5EF4-FFF2-40B4-BE49-F238E27FC236}">
-                  <a16:creationId xmlns:a16="http://schemas.microsoft.com/office/drawing/2014/main" id="{D36C96F7-162A-6ECA-D698-4D08FB20038D}"/>
+                  <a16:creationId xmlns:a16="http://schemas.microsoft.com/office/drawing/2014/main" id="{29129DCE-3850-8F2F-269C-5291442F4CEA}"/>
                 </a:ext>
               </a:extLst>
             </p:cNvPr>
@@ -5653,7 +5653,7 @@
             <p:cNvPr id="17" name="Conector reto 16">
               <a:extLst>
                 <a:ext uri="{FF2B5EF4-FFF2-40B4-BE49-F238E27FC236}">
-                  <a16:creationId xmlns:a16="http://schemas.microsoft.com/office/drawing/2014/main" id="{37D69552-E169-D3DF-DCD5-53C1C29A763A}"/>
+                  <a16:creationId xmlns:a16="http://schemas.microsoft.com/office/drawing/2014/main" id="{A5028673-1297-1730-E9F9-BC3226B0ACD9}"/>
                 </a:ext>
               </a:extLst>
             </p:cNvPr>
@@ -5700,7 +5700,7 @@
             <p:cNvPr id="18" name="Conector reto 17">
               <a:extLst>
                 <a:ext uri="{FF2B5EF4-FFF2-40B4-BE49-F238E27FC236}">
-                  <a16:creationId xmlns:a16="http://schemas.microsoft.com/office/drawing/2014/main" id="{AAF484AF-4235-A232-2CC4-14D12A089685}"/>
+                  <a16:creationId xmlns:a16="http://schemas.microsoft.com/office/drawing/2014/main" id="{034E00EA-5BEE-2176-703E-0F25583F63C5}"/>
                 </a:ext>
               </a:extLst>
             </p:cNvPr>
@@ -5747,7 +5747,7 @@
             <p:cNvPr id="19" name="Retângulo: Cantos Arredondados 18">
               <a:extLst>
                 <a:ext uri="{FF2B5EF4-FFF2-40B4-BE49-F238E27FC236}">
-                  <a16:creationId xmlns:a16="http://schemas.microsoft.com/office/drawing/2014/main" id="{FEAF642D-32BB-BFD1-EFEC-3FB4BAA79AF0}"/>
+                  <a16:creationId xmlns:a16="http://schemas.microsoft.com/office/drawing/2014/main" id="{602AE290-438D-68C9-3ECC-561DCB1B89A9}"/>
                 </a:ext>
               </a:extLst>
             </p:cNvPr>
@@ -5819,7 +5819,7 @@
             <p:cNvPr id="20" name="Retângulo: Cantos Arredondados 19">
               <a:extLst>
                 <a:ext uri="{FF2B5EF4-FFF2-40B4-BE49-F238E27FC236}">
-                  <a16:creationId xmlns:a16="http://schemas.microsoft.com/office/drawing/2014/main" id="{76B68387-1E8E-4E98-C6A0-89524682B273}"/>
+                  <a16:creationId xmlns:a16="http://schemas.microsoft.com/office/drawing/2014/main" id="{00457524-7D44-CB19-A2FF-C5679E71306F}"/>
                 </a:ext>
               </a:extLst>
             </p:cNvPr>
@@ -5891,7 +5891,7 @@
             <p:cNvPr id="21" name="Retângulo: Cantos Arredondados 20">
               <a:extLst>
                 <a:ext uri="{FF2B5EF4-FFF2-40B4-BE49-F238E27FC236}">
-                  <a16:creationId xmlns:a16="http://schemas.microsoft.com/office/drawing/2014/main" id="{7E1F339C-7560-95AF-9584-905EC0AE0B94}"/>
+                  <a16:creationId xmlns:a16="http://schemas.microsoft.com/office/drawing/2014/main" id="{7B15523A-1792-BE66-2928-4869A855DDAA}"/>
                 </a:ext>
               </a:extLst>
             </p:cNvPr>
@@ -5969,7 +5969,7 @@
             <p:cNvPr id="22" name="Retângulo: Cantos Arredondados 21">
               <a:extLst>
                 <a:ext uri="{FF2B5EF4-FFF2-40B4-BE49-F238E27FC236}">
-                  <a16:creationId xmlns:a16="http://schemas.microsoft.com/office/drawing/2014/main" id="{26F9603A-41CD-8151-1361-72A81744C6F9}"/>
+                  <a16:creationId xmlns:a16="http://schemas.microsoft.com/office/drawing/2014/main" id="{95CFE9DC-103F-9459-E619-B7881AC792C8}"/>
                 </a:ext>
               </a:extLst>
             </p:cNvPr>
@@ -6041,7 +6041,7 @@
             <p:cNvPr id="23" name="Retângulo: Cantos Arredondados 22">
               <a:extLst>
                 <a:ext uri="{FF2B5EF4-FFF2-40B4-BE49-F238E27FC236}">
-                  <a16:creationId xmlns:a16="http://schemas.microsoft.com/office/drawing/2014/main" id="{FA143951-BF7F-D8DE-61DE-0C8434BA7C3A}"/>
+                  <a16:creationId xmlns:a16="http://schemas.microsoft.com/office/drawing/2014/main" id="{0EB4417F-0BE3-6EC6-8C3F-72C1084B4476}"/>
                 </a:ext>
               </a:extLst>
             </p:cNvPr>
@@ -6119,7 +6119,7 @@
             <p:cNvPr id="24" name="Retângulo: Cantos Arredondados 23">
               <a:extLst>
                 <a:ext uri="{FF2B5EF4-FFF2-40B4-BE49-F238E27FC236}">
-                  <a16:creationId xmlns:a16="http://schemas.microsoft.com/office/drawing/2014/main" id="{DDAE18E8-BB55-0BBA-35B2-BBD48A970429}"/>
+                  <a16:creationId xmlns:a16="http://schemas.microsoft.com/office/drawing/2014/main" id="{D1F1CDF0-EADA-A97E-6F93-85F1CE7B10BC}"/>
                 </a:ext>
               </a:extLst>
             </p:cNvPr>
@@ -6191,7 +6191,7 @@
             <p:cNvPr id="25" name="Elipse 24">
               <a:extLst>
                 <a:ext uri="{FF2B5EF4-FFF2-40B4-BE49-F238E27FC236}">
-                  <a16:creationId xmlns:a16="http://schemas.microsoft.com/office/drawing/2014/main" id="{1474F19C-8378-D78D-1EE5-64C9539FF337}"/>
+                  <a16:creationId xmlns:a16="http://schemas.microsoft.com/office/drawing/2014/main" id="{283F910A-19DD-58AC-89DE-0AECF2B5B7C4}"/>
                 </a:ext>
               </a:extLst>
             </p:cNvPr>
@@ -6249,7 +6249,7 @@
             <p:cNvPr id="26" name="CaixaDeTexto 25">
               <a:extLst>
                 <a:ext uri="{FF2B5EF4-FFF2-40B4-BE49-F238E27FC236}">
-                  <a16:creationId xmlns:a16="http://schemas.microsoft.com/office/drawing/2014/main" id="{D24655E5-EF5D-DB2C-A310-C4E35C3296D1}"/>
+                  <a16:creationId xmlns:a16="http://schemas.microsoft.com/office/drawing/2014/main" id="{731C798A-0AF5-DE00-896F-0C8CBE3F86C6}"/>
                 </a:ext>
               </a:extLst>
             </p:cNvPr>
@@ -6296,7 +6296,7 @@
           <p:cNvPr id="28" name="Conector reto 27">
             <a:extLst>
               <a:ext uri="{FF2B5EF4-FFF2-40B4-BE49-F238E27FC236}">
-                <a16:creationId xmlns:a16="http://schemas.microsoft.com/office/drawing/2014/main" id="{82A4DDF8-5C8E-F5EF-69AF-A3310DC3EBDF}"/>
+                <a16:creationId xmlns:a16="http://schemas.microsoft.com/office/drawing/2014/main" id="{6C5D9B24-1F00-9C32-7695-70CEB2C0F091}"/>
               </a:ext>
             </a:extLst>
           </p:cNvPr>
@@ -6343,7 +6343,7 @@
           <p:cNvPr id="29" name="Conector reto 28">
             <a:extLst>
               <a:ext uri="{FF2B5EF4-FFF2-40B4-BE49-F238E27FC236}">
-                <a16:creationId xmlns:a16="http://schemas.microsoft.com/office/drawing/2014/main" id="{4708E683-33A5-9872-264B-727EF8467E02}"/>
+                <a16:creationId xmlns:a16="http://schemas.microsoft.com/office/drawing/2014/main" id="{CC0CDF1D-709D-955E-29FE-39E676392F67}"/>
               </a:ext>
             </a:extLst>
           </p:cNvPr>
@@ -6388,7 +6388,7 @@
           <p:cNvPr id="30" name="Elipse 29">
             <a:extLst>
               <a:ext uri="{FF2B5EF4-FFF2-40B4-BE49-F238E27FC236}">
-                <a16:creationId xmlns:a16="http://schemas.microsoft.com/office/drawing/2014/main" id="{28E32B33-888A-304E-8911-71A79637F489}"/>
+                <a16:creationId xmlns:a16="http://schemas.microsoft.com/office/drawing/2014/main" id="{4AC99B0D-4968-496A-42FB-D43440C5B8F3}"/>
               </a:ext>
             </a:extLst>
           </p:cNvPr>
@@ -6456,7 +6456,7 @@
           <p:cNvPr id="31" name="CaixaDeTexto 30">
             <a:extLst>
               <a:ext uri="{FF2B5EF4-FFF2-40B4-BE49-F238E27FC236}">
-                <a16:creationId xmlns:a16="http://schemas.microsoft.com/office/drawing/2014/main" id="{C9648782-4214-BC68-56C3-6E0E4733EBD7}"/>
+                <a16:creationId xmlns:a16="http://schemas.microsoft.com/office/drawing/2014/main" id="{6BF40666-A6F5-996C-320F-D2D4DD995A5F}"/>
               </a:ext>
             </a:extLst>
           </p:cNvPr>
@@ -6499,7 +6499,7 @@
     </p:spTree>
     <p:extLst>
       <p:ext uri="{BB962C8B-B14F-4D97-AF65-F5344CB8AC3E}">
-        <p14:creationId xmlns:p14="http://schemas.microsoft.com/office/powerpoint/2010/main" val="2074340529"/>
+        <p14:creationId xmlns:p14="http://schemas.microsoft.com/office/powerpoint/2010/main" val="1177443521"/>
       </p:ext>
     </p:extLst>
   </p:cSld>
@@ -6743,7 +6743,7 @@
           <p:cNvPr id="2" name="CaixaDeTexto 1">
             <a:extLst>
               <a:ext uri="{FF2B5EF4-FFF2-40B4-BE49-F238E27FC236}">
-                <a16:creationId xmlns:a16="http://schemas.microsoft.com/office/drawing/2014/main" id="{4125F5FC-13B1-330D-C8BE-7B58FF54200E}"/>
+                <a16:creationId xmlns:a16="http://schemas.microsoft.com/office/drawing/2014/main" id="{044FED72-FD08-EEA7-3F38-3A1951BEA8FA}"/>
               </a:ext>
             </a:extLst>
           </p:cNvPr>
@@ -6788,7 +6788,7 @@
           <p:cNvPr id="3" name="CaixaDeTexto 2">
             <a:extLst>
               <a:ext uri="{FF2B5EF4-FFF2-40B4-BE49-F238E27FC236}">
-                <a16:creationId xmlns:a16="http://schemas.microsoft.com/office/drawing/2014/main" id="{9D56E912-E165-4DF9-B073-04B47C86A55C}"/>
+                <a16:creationId xmlns:a16="http://schemas.microsoft.com/office/drawing/2014/main" id="{4FE38E71-D094-468C-81CE-7D96FA6C2365}"/>
               </a:ext>
             </a:extLst>
           </p:cNvPr>
@@ -6842,7 +6842,7 @@
           <p:cNvPr id="4" name="Conector reto 3">
             <a:extLst>
               <a:ext uri="{FF2B5EF4-FFF2-40B4-BE49-F238E27FC236}">
-                <a16:creationId xmlns:a16="http://schemas.microsoft.com/office/drawing/2014/main" id="{E8379A60-D483-5386-126F-D26070EAF9DF}"/>
+                <a16:creationId xmlns:a16="http://schemas.microsoft.com/office/drawing/2014/main" id="{21756DE2-D36A-B3FF-6911-07FA18AE492E}"/>
               </a:ext>
             </a:extLst>
           </p:cNvPr>
@@ -6889,7 +6889,7 @@
           <p:cNvPr id="9" name="Agrupar 8">
             <a:extLst>
               <a:ext uri="{FF2B5EF4-FFF2-40B4-BE49-F238E27FC236}">
-                <a16:creationId xmlns:a16="http://schemas.microsoft.com/office/drawing/2014/main" id="{F9EDD258-E36D-2B0F-8D43-4DD9E364ED9E}"/>
+                <a16:creationId xmlns:a16="http://schemas.microsoft.com/office/drawing/2014/main" id="{5D886644-6240-9755-A3D6-559BD6327C9D}"/>
               </a:ext>
             </a:extLst>
           </p:cNvPr>
@@ -6909,7 +6909,7 @@
             <p:cNvPr id="5" name="Elipse 4">
               <a:extLst>
                 <a:ext uri="{FF2B5EF4-FFF2-40B4-BE49-F238E27FC236}">
-                  <a16:creationId xmlns:a16="http://schemas.microsoft.com/office/drawing/2014/main" id="{6350689B-9C5F-2E19-7629-7D1D5283B457}"/>
+                  <a16:creationId xmlns:a16="http://schemas.microsoft.com/office/drawing/2014/main" id="{193116C0-11BA-2BB5-EC41-0B10E6E235FF}"/>
                 </a:ext>
               </a:extLst>
             </p:cNvPr>
@@ -6969,7 +6969,7 @@
             <p:cNvPr id="6" name="CaixaDeTexto 5">
               <a:extLst>
                 <a:ext uri="{FF2B5EF4-FFF2-40B4-BE49-F238E27FC236}">
-                  <a16:creationId xmlns:a16="http://schemas.microsoft.com/office/drawing/2014/main" id="{CF45A653-1273-03C2-3781-70FFBF2934BA}"/>
+                  <a16:creationId xmlns:a16="http://schemas.microsoft.com/office/drawing/2014/main" id="{D072D2CA-8686-A972-8601-9409118BFC6D}"/>
                 </a:ext>
               </a:extLst>
             </p:cNvPr>
@@ -7014,7 +7014,7 @@
             <p:cNvPr id="7" name="CaixaDeTexto 6">
               <a:extLst>
                 <a:ext uri="{FF2B5EF4-FFF2-40B4-BE49-F238E27FC236}">
-                  <a16:creationId xmlns:a16="http://schemas.microsoft.com/office/drawing/2014/main" id="{4AAE0E09-C48C-ED8A-1E5A-BCBA97CA669D}"/>
+                  <a16:creationId xmlns:a16="http://schemas.microsoft.com/office/drawing/2014/main" id="{C4A58302-0488-5F86-7FE6-83E37C356784}"/>
                 </a:ext>
               </a:extLst>
             </p:cNvPr>
@@ -7059,7 +7059,7 @@
             <p:cNvPr id="8" name="CaixaDeTexto 7">
               <a:extLst>
                 <a:ext uri="{FF2B5EF4-FFF2-40B4-BE49-F238E27FC236}">
-                  <a16:creationId xmlns:a16="http://schemas.microsoft.com/office/drawing/2014/main" id="{80E51D56-A4F0-465C-5663-7803D5F56EAF}"/>
+                  <a16:creationId xmlns:a16="http://schemas.microsoft.com/office/drawing/2014/main" id="{9A526C61-527D-2B3D-4092-76FCE5875C46}"/>
                 </a:ext>
               </a:extLst>
             </p:cNvPr>
@@ -7105,7 +7105,7 @@
           <p:cNvPr id="14" name="Agrupar 13">
             <a:extLst>
               <a:ext uri="{FF2B5EF4-FFF2-40B4-BE49-F238E27FC236}">
-                <a16:creationId xmlns:a16="http://schemas.microsoft.com/office/drawing/2014/main" id="{8BF999BF-29C4-A595-86A6-B6F2D4D9EB5B}"/>
+                <a16:creationId xmlns:a16="http://schemas.microsoft.com/office/drawing/2014/main" id="{045A6D97-DFA7-2CD6-EAF4-3D8B741B56DC}"/>
               </a:ext>
             </a:extLst>
           </p:cNvPr>
@@ -7125,7 +7125,7 @@
             <p:cNvPr id="10" name="Elipse 9">
               <a:extLst>
                 <a:ext uri="{FF2B5EF4-FFF2-40B4-BE49-F238E27FC236}">
-                  <a16:creationId xmlns:a16="http://schemas.microsoft.com/office/drawing/2014/main" id="{6390E58F-8DF0-41F1-DDFF-26E90A731926}"/>
+                  <a16:creationId xmlns:a16="http://schemas.microsoft.com/office/drawing/2014/main" id="{2D9C7D4C-C19C-8DFB-756A-273A21B46524}"/>
                 </a:ext>
               </a:extLst>
             </p:cNvPr>
@@ -7185,7 +7185,7 @@
             <p:cNvPr id="11" name="CaixaDeTexto 10">
               <a:extLst>
                 <a:ext uri="{FF2B5EF4-FFF2-40B4-BE49-F238E27FC236}">
-                  <a16:creationId xmlns:a16="http://schemas.microsoft.com/office/drawing/2014/main" id="{00E9EF02-BC53-1FE8-A52F-553EE1C1428F}"/>
+                  <a16:creationId xmlns:a16="http://schemas.microsoft.com/office/drawing/2014/main" id="{D0B4B07C-623C-CF0D-BE40-59D8147CE553}"/>
                 </a:ext>
               </a:extLst>
             </p:cNvPr>
@@ -7230,7 +7230,7 @@
             <p:cNvPr id="12" name="CaixaDeTexto 11">
               <a:extLst>
                 <a:ext uri="{FF2B5EF4-FFF2-40B4-BE49-F238E27FC236}">
-                  <a16:creationId xmlns:a16="http://schemas.microsoft.com/office/drawing/2014/main" id="{3C02DA8B-9CFF-29C7-916D-5F821298288E}"/>
+                  <a16:creationId xmlns:a16="http://schemas.microsoft.com/office/drawing/2014/main" id="{3D558CC3-A905-D220-11FC-FE4CE7CD866B}"/>
                 </a:ext>
               </a:extLst>
             </p:cNvPr>
@@ -7275,7 +7275,7 @@
             <p:cNvPr id="13" name="CaixaDeTexto 12">
               <a:extLst>
                 <a:ext uri="{FF2B5EF4-FFF2-40B4-BE49-F238E27FC236}">
-                  <a16:creationId xmlns:a16="http://schemas.microsoft.com/office/drawing/2014/main" id="{3BAFAB00-E94A-46AF-686E-74B4B949F927}"/>
+                  <a16:creationId xmlns:a16="http://schemas.microsoft.com/office/drawing/2014/main" id="{7093C7ED-8A1B-05C6-37F2-A96735AD6C1E}"/>
                 </a:ext>
               </a:extLst>
             </p:cNvPr>
@@ -7321,7 +7321,7 @@
           <p:cNvPr id="19" name="Agrupar 18">
             <a:extLst>
               <a:ext uri="{FF2B5EF4-FFF2-40B4-BE49-F238E27FC236}">
-                <a16:creationId xmlns:a16="http://schemas.microsoft.com/office/drawing/2014/main" id="{A55344D0-D274-CF85-ED79-313E2A613963}"/>
+                <a16:creationId xmlns:a16="http://schemas.microsoft.com/office/drawing/2014/main" id="{E9E5831B-64CA-021C-D9C5-193FC2847D36}"/>
               </a:ext>
             </a:extLst>
           </p:cNvPr>
@@ -7341,7 +7341,7 @@
             <p:cNvPr id="15" name="Elipse 14">
               <a:extLst>
                 <a:ext uri="{FF2B5EF4-FFF2-40B4-BE49-F238E27FC236}">
-                  <a16:creationId xmlns:a16="http://schemas.microsoft.com/office/drawing/2014/main" id="{858DD874-CBCE-3F0F-BC8A-611A7132972C}"/>
+                  <a16:creationId xmlns:a16="http://schemas.microsoft.com/office/drawing/2014/main" id="{3C484B3D-843D-98C7-7900-19F060711F32}"/>
                 </a:ext>
               </a:extLst>
             </p:cNvPr>
@@ -7401,7 +7401,7 @@
             <p:cNvPr id="16" name="CaixaDeTexto 15">
               <a:extLst>
                 <a:ext uri="{FF2B5EF4-FFF2-40B4-BE49-F238E27FC236}">
-                  <a16:creationId xmlns:a16="http://schemas.microsoft.com/office/drawing/2014/main" id="{3C7CF717-FFF8-159F-FBEB-F60E03883297}"/>
+                  <a16:creationId xmlns:a16="http://schemas.microsoft.com/office/drawing/2014/main" id="{220C12A3-96CA-5DDB-1B23-7732A315E8D3}"/>
                 </a:ext>
               </a:extLst>
             </p:cNvPr>
@@ -7446,7 +7446,7 @@
             <p:cNvPr id="17" name="CaixaDeTexto 16">
               <a:extLst>
                 <a:ext uri="{FF2B5EF4-FFF2-40B4-BE49-F238E27FC236}">
-                  <a16:creationId xmlns:a16="http://schemas.microsoft.com/office/drawing/2014/main" id="{95646C33-7294-29B5-AE92-F150408F11F3}"/>
+                  <a16:creationId xmlns:a16="http://schemas.microsoft.com/office/drawing/2014/main" id="{330BBDEF-5400-B0A9-9415-BEB0CC4E3E51}"/>
                 </a:ext>
               </a:extLst>
             </p:cNvPr>
@@ -7491,7 +7491,7 @@
             <p:cNvPr id="18" name="CaixaDeTexto 17">
               <a:extLst>
                 <a:ext uri="{FF2B5EF4-FFF2-40B4-BE49-F238E27FC236}">
-                  <a16:creationId xmlns:a16="http://schemas.microsoft.com/office/drawing/2014/main" id="{9C219B1D-A4EA-7E15-D5D4-0202BC0FC170}"/>
+                  <a16:creationId xmlns:a16="http://schemas.microsoft.com/office/drawing/2014/main" id="{B0CBDDA6-72BD-9942-5859-37768BA82A5F}"/>
                 </a:ext>
               </a:extLst>
             </p:cNvPr>
@@ -7537,7 +7537,7 @@
           <p:cNvPr id="24" name="Agrupar 23">
             <a:extLst>
               <a:ext uri="{FF2B5EF4-FFF2-40B4-BE49-F238E27FC236}">
-                <a16:creationId xmlns:a16="http://schemas.microsoft.com/office/drawing/2014/main" id="{A1D3EE18-F8D5-36B7-1882-D08685757ABB}"/>
+                <a16:creationId xmlns:a16="http://schemas.microsoft.com/office/drawing/2014/main" id="{E6DBE15C-7A36-52FD-F01F-18A46AE2FC83}"/>
               </a:ext>
             </a:extLst>
           </p:cNvPr>
@@ -7557,7 +7557,7 @@
             <p:cNvPr id="20" name="Elipse 19">
               <a:extLst>
                 <a:ext uri="{FF2B5EF4-FFF2-40B4-BE49-F238E27FC236}">
-                  <a16:creationId xmlns:a16="http://schemas.microsoft.com/office/drawing/2014/main" id="{E0E0A97D-5661-ADDC-D80D-6C037A9F30EE}"/>
+                  <a16:creationId xmlns:a16="http://schemas.microsoft.com/office/drawing/2014/main" id="{C9D09402-E5B8-022A-CE33-86511E8F6F6C}"/>
                 </a:ext>
               </a:extLst>
             </p:cNvPr>
@@ -7617,7 +7617,7 @@
             <p:cNvPr id="21" name="CaixaDeTexto 20">
               <a:extLst>
                 <a:ext uri="{FF2B5EF4-FFF2-40B4-BE49-F238E27FC236}">
-                  <a16:creationId xmlns:a16="http://schemas.microsoft.com/office/drawing/2014/main" id="{D48EDAB5-B859-03DC-FE9A-B18310EE5F36}"/>
+                  <a16:creationId xmlns:a16="http://schemas.microsoft.com/office/drawing/2014/main" id="{F6856B17-B3A4-5377-9F79-2C420CD6885D}"/>
                 </a:ext>
               </a:extLst>
             </p:cNvPr>
@@ -7662,7 +7662,7 @@
             <p:cNvPr id="22" name="CaixaDeTexto 21">
               <a:extLst>
                 <a:ext uri="{FF2B5EF4-FFF2-40B4-BE49-F238E27FC236}">
-                  <a16:creationId xmlns:a16="http://schemas.microsoft.com/office/drawing/2014/main" id="{FEC7A3D5-CD6B-417D-B0AB-29DEB04560E5}"/>
+                  <a16:creationId xmlns:a16="http://schemas.microsoft.com/office/drawing/2014/main" id="{576FB0B8-1297-30AD-2D7D-BF47FBC623A5}"/>
                 </a:ext>
               </a:extLst>
             </p:cNvPr>
@@ -7707,7 +7707,7 @@
             <p:cNvPr id="23" name="CaixaDeTexto 22">
               <a:extLst>
                 <a:ext uri="{FF2B5EF4-FFF2-40B4-BE49-F238E27FC236}">
-                  <a16:creationId xmlns:a16="http://schemas.microsoft.com/office/drawing/2014/main" id="{CB08CCD0-D821-B269-5B51-F050DBDCBE48}"/>
+                  <a16:creationId xmlns:a16="http://schemas.microsoft.com/office/drawing/2014/main" id="{8E9339DD-59FC-E523-622E-89ACD1875DF7}"/>
                 </a:ext>
               </a:extLst>
             </p:cNvPr>
@@ -7753,7 +7753,7 @@
           <p:cNvPr id="29" name="Agrupar 28">
             <a:extLst>
               <a:ext uri="{FF2B5EF4-FFF2-40B4-BE49-F238E27FC236}">
-                <a16:creationId xmlns:a16="http://schemas.microsoft.com/office/drawing/2014/main" id="{3746B24E-F423-13CB-3CF8-0A138E09EE2F}"/>
+                <a16:creationId xmlns:a16="http://schemas.microsoft.com/office/drawing/2014/main" id="{72BE8846-7DDA-00A5-2C0C-01797E85D0B5}"/>
               </a:ext>
             </a:extLst>
           </p:cNvPr>
@@ -7773,7 +7773,7 @@
             <p:cNvPr id="25" name="Elipse 24">
               <a:extLst>
                 <a:ext uri="{FF2B5EF4-FFF2-40B4-BE49-F238E27FC236}">
-                  <a16:creationId xmlns:a16="http://schemas.microsoft.com/office/drawing/2014/main" id="{5CCDCC44-ACAC-AD1F-6578-EF263F89D7F1}"/>
+                  <a16:creationId xmlns:a16="http://schemas.microsoft.com/office/drawing/2014/main" id="{71368D00-A135-0EB2-04B7-808B8FF00690}"/>
                 </a:ext>
               </a:extLst>
             </p:cNvPr>
@@ -7841,7 +7841,7 @@
             <p:cNvPr id="26" name="CaixaDeTexto 25">
               <a:extLst>
                 <a:ext uri="{FF2B5EF4-FFF2-40B4-BE49-F238E27FC236}">
-                  <a16:creationId xmlns:a16="http://schemas.microsoft.com/office/drawing/2014/main" id="{735AA982-7FCB-9128-64BD-F69440D4AE4E}"/>
+                  <a16:creationId xmlns:a16="http://schemas.microsoft.com/office/drawing/2014/main" id="{7DE41FB0-785C-191D-9CEA-CB1BCCC33F51}"/>
                 </a:ext>
               </a:extLst>
             </p:cNvPr>
@@ -7886,7 +7886,7 @@
             <p:cNvPr id="27" name="CaixaDeTexto 26">
               <a:extLst>
                 <a:ext uri="{FF2B5EF4-FFF2-40B4-BE49-F238E27FC236}">
-                  <a16:creationId xmlns:a16="http://schemas.microsoft.com/office/drawing/2014/main" id="{07436ADF-4140-6336-DECD-328100FED3C4}"/>
+                  <a16:creationId xmlns:a16="http://schemas.microsoft.com/office/drawing/2014/main" id="{E8886B17-338C-52A2-C414-17389B9744C7}"/>
                 </a:ext>
               </a:extLst>
             </p:cNvPr>
@@ -7931,7 +7931,7 @@
             <p:cNvPr id="28" name="CaixaDeTexto 27">
               <a:extLst>
                 <a:ext uri="{FF2B5EF4-FFF2-40B4-BE49-F238E27FC236}">
-                  <a16:creationId xmlns:a16="http://schemas.microsoft.com/office/drawing/2014/main" id="{2CEB8315-9240-6F7F-455B-668BADFA3F3B}"/>
+                  <a16:creationId xmlns:a16="http://schemas.microsoft.com/office/drawing/2014/main" id="{7C8615EF-DC9C-9531-D8EE-63D1CE3C7649}"/>
                 </a:ext>
               </a:extLst>
             </p:cNvPr>
@@ -7977,7 +7977,7 @@
           <p:cNvPr id="30" name="Conector reto 29">
             <a:extLst>
               <a:ext uri="{FF2B5EF4-FFF2-40B4-BE49-F238E27FC236}">
-                <a16:creationId xmlns:a16="http://schemas.microsoft.com/office/drawing/2014/main" id="{FECB3DB3-D18B-EA16-FBA8-326FDC200A42}"/>
+                <a16:creationId xmlns:a16="http://schemas.microsoft.com/office/drawing/2014/main" id="{209EFDB3-9DF5-3B37-F772-A3F70E62A267}"/>
               </a:ext>
             </a:extLst>
           </p:cNvPr>
@@ -8024,7 +8024,7 @@
           <p:cNvPr id="31" name="Conector reto 30">
             <a:extLst>
               <a:ext uri="{FF2B5EF4-FFF2-40B4-BE49-F238E27FC236}">
-                <a16:creationId xmlns:a16="http://schemas.microsoft.com/office/drawing/2014/main" id="{DEF96C48-B43B-8BDA-CC23-C94302185ABB}"/>
+                <a16:creationId xmlns:a16="http://schemas.microsoft.com/office/drawing/2014/main" id="{01571133-E192-A670-9330-616803A4C700}"/>
               </a:ext>
             </a:extLst>
           </p:cNvPr>
@@ -8069,7 +8069,7 @@
           <p:cNvPr id="32" name="Elipse 31">
             <a:extLst>
               <a:ext uri="{FF2B5EF4-FFF2-40B4-BE49-F238E27FC236}">
-                <a16:creationId xmlns:a16="http://schemas.microsoft.com/office/drawing/2014/main" id="{87EB9825-47D6-F9FB-12E2-5E0FDF9E7ACA}"/>
+                <a16:creationId xmlns:a16="http://schemas.microsoft.com/office/drawing/2014/main" id="{18C0BD21-0030-9D71-5304-F3CB12D0ACD3}"/>
               </a:ext>
             </a:extLst>
           </p:cNvPr>
@@ -8137,7 +8137,7 @@
           <p:cNvPr id="33" name="CaixaDeTexto 32">
             <a:extLst>
               <a:ext uri="{FF2B5EF4-FFF2-40B4-BE49-F238E27FC236}">
-                <a16:creationId xmlns:a16="http://schemas.microsoft.com/office/drawing/2014/main" id="{B921178B-1D5A-4A10-EB61-118EDFF64320}"/>
+                <a16:creationId xmlns:a16="http://schemas.microsoft.com/office/drawing/2014/main" id="{9DD82640-FA2C-6FBB-A558-EB3DD6CB42AA}"/>
               </a:ext>
             </a:extLst>
           </p:cNvPr>
@@ -8180,7 +8180,7 @@
     </p:spTree>
     <p:extLst>
       <p:ext uri="{BB962C8B-B14F-4D97-AF65-F5344CB8AC3E}">
-        <p14:creationId xmlns:p14="http://schemas.microsoft.com/office/powerpoint/2010/main" val="3791430626"/>
+        <p14:creationId xmlns:p14="http://schemas.microsoft.com/office/powerpoint/2010/main" val="1959708994"/>
       </p:ext>
     </p:extLst>
   </p:cSld>
@@ -8532,7 +8532,7 @@
           <p:cNvPr id="2" name="CaixaDeTexto 1">
             <a:extLst>
               <a:ext uri="{FF2B5EF4-FFF2-40B4-BE49-F238E27FC236}">
-                <a16:creationId xmlns:a16="http://schemas.microsoft.com/office/drawing/2014/main" id="{78CDAC83-5C27-35DB-F3B5-5F9857375775}"/>
+                <a16:creationId xmlns:a16="http://schemas.microsoft.com/office/drawing/2014/main" id="{89A70992-B060-D114-EDF6-1F6B918BF745}"/>
               </a:ext>
             </a:extLst>
           </p:cNvPr>
@@ -8577,7 +8577,7 @@
           <p:cNvPr id="3" name="CaixaDeTexto 2">
             <a:extLst>
               <a:ext uri="{FF2B5EF4-FFF2-40B4-BE49-F238E27FC236}">
-                <a16:creationId xmlns:a16="http://schemas.microsoft.com/office/drawing/2014/main" id="{30AABF11-F77C-C8BC-9939-B03476088F01}"/>
+                <a16:creationId xmlns:a16="http://schemas.microsoft.com/office/drawing/2014/main" id="{B2678786-AB12-6365-6291-FD6F6B294983}"/>
               </a:ext>
             </a:extLst>
           </p:cNvPr>
@@ -8632,7 +8632,7 @@
           <p:cNvPr id="4" name="Retângulo: Cantos Arredondados 3">
             <a:extLst>
               <a:ext uri="{FF2B5EF4-FFF2-40B4-BE49-F238E27FC236}">
-                <a16:creationId xmlns:a16="http://schemas.microsoft.com/office/drawing/2014/main" id="{60ECB634-CA9B-C082-BCE7-104F44470B68}"/>
+                <a16:creationId xmlns:a16="http://schemas.microsoft.com/office/drawing/2014/main" id="{85F71FAC-34CA-13BC-4163-305AE60B3703}"/>
               </a:ext>
             </a:extLst>
           </p:cNvPr>
@@ -8704,7 +8704,7 @@
           <p:cNvPr id="5" name="Retângulo: Cantos Arredondados 4">
             <a:extLst>
               <a:ext uri="{FF2B5EF4-FFF2-40B4-BE49-F238E27FC236}">
-                <a16:creationId xmlns:a16="http://schemas.microsoft.com/office/drawing/2014/main" id="{CCAB61CA-D0E8-3B70-387F-B477ED1ED624}"/>
+                <a16:creationId xmlns:a16="http://schemas.microsoft.com/office/drawing/2014/main" id="{83AC4E89-F328-0C87-E7DA-B26A338A5D5E}"/>
               </a:ext>
             </a:extLst>
           </p:cNvPr>
@@ -8776,7 +8776,7 @@
           <p:cNvPr id="6" name="Retângulo: Cantos Arredondados 5">
             <a:extLst>
               <a:ext uri="{FF2B5EF4-FFF2-40B4-BE49-F238E27FC236}">
-                <a16:creationId xmlns:a16="http://schemas.microsoft.com/office/drawing/2014/main" id="{6EBE5E52-FCE9-21E9-3F67-6EF3CA898333}"/>
+                <a16:creationId xmlns:a16="http://schemas.microsoft.com/office/drawing/2014/main" id="{293A235E-8A09-055B-6674-AC1756F1BD39}"/>
               </a:ext>
             </a:extLst>
           </p:cNvPr>
@@ -8848,7 +8848,7 @@
           <p:cNvPr id="7" name="Retângulo: Cantos Arredondados 6">
             <a:extLst>
               <a:ext uri="{FF2B5EF4-FFF2-40B4-BE49-F238E27FC236}">
-                <a16:creationId xmlns:a16="http://schemas.microsoft.com/office/drawing/2014/main" id="{B0A0944E-40E1-28E0-C583-3D34E5F0E2FD}"/>
+                <a16:creationId xmlns:a16="http://schemas.microsoft.com/office/drawing/2014/main" id="{5E683AD2-5657-E04F-73F0-8B27C2625FA9}"/>
               </a:ext>
             </a:extLst>
           </p:cNvPr>
@@ -8920,7 +8920,7 @@
           <p:cNvPr id="8" name="CaixaDeTexto 7">
             <a:extLst>
               <a:ext uri="{FF2B5EF4-FFF2-40B4-BE49-F238E27FC236}">
-                <a16:creationId xmlns:a16="http://schemas.microsoft.com/office/drawing/2014/main" id="{81CC37D9-4C4B-FBFA-0C0F-9BEDCA712097}"/>
+                <a16:creationId xmlns:a16="http://schemas.microsoft.com/office/drawing/2014/main" id="{E14052A0-E701-AE53-048D-83A078EEF77B}"/>
               </a:ext>
             </a:extLst>
           </p:cNvPr>
@@ -8974,7 +8974,7 @@
           <p:cNvPr id="9" name="Conector reto 8">
             <a:extLst>
               <a:ext uri="{FF2B5EF4-FFF2-40B4-BE49-F238E27FC236}">
-                <a16:creationId xmlns:a16="http://schemas.microsoft.com/office/drawing/2014/main" id="{69ECEBB5-BFFE-3050-B325-8F9EDF8B88D8}"/>
+                <a16:creationId xmlns:a16="http://schemas.microsoft.com/office/drawing/2014/main" id="{932D8315-972D-6038-3A30-AA148205C0AE}"/>
               </a:ext>
             </a:extLst>
           </p:cNvPr>
@@ -9021,7 +9021,7 @@
           <p:cNvPr id="10" name="Conector reto 9">
             <a:extLst>
               <a:ext uri="{FF2B5EF4-FFF2-40B4-BE49-F238E27FC236}">
-                <a16:creationId xmlns:a16="http://schemas.microsoft.com/office/drawing/2014/main" id="{B700452E-F9F5-40A8-8E3A-C6C596416033}"/>
+                <a16:creationId xmlns:a16="http://schemas.microsoft.com/office/drawing/2014/main" id="{72032AFB-777B-7E39-9B37-4DC8635588BD}"/>
               </a:ext>
             </a:extLst>
           </p:cNvPr>
@@ -9066,7 +9066,7 @@
           <p:cNvPr id="11" name="Elipse 10">
             <a:extLst>
               <a:ext uri="{FF2B5EF4-FFF2-40B4-BE49-F238E27FC236}">
-                <a16:creationId xmlns:a16="http://schemas.microsoft.com/office/drawing/2014/main" id="{E63DFFC9-F8D7-61FD-5AF7-CC39DFC2B758}"/>
+                <a16:creationId xmlns:a16="http://schemas.microsoft.com/office/drawing/2014/main" id="{1292FE76-6AF3-84F6-6FEB-DDE0A136993B}"/>
               </a:ext>
             </a:extLst>
           </p:cNvPr>
@@ -9134,7 +9134,7 @@
           <p:cNvPr id="12" name="CaixaDeTexto 11">
             <a:extLst>
               <a:ext uri="{FF2B5EF4-FFF2-40B4-BE49-F238E27FC236}">
-                <a16:creationId xmlns:a16="http://schemas.microsoft.com/office/drawing/2014/main" id="{EFB7C43E-A3AA-9183-08AA-FECA2FBC475D}"/>
+                <a16:creationId xmlns:a16="http://schemas.microsoft.com/office/drawing/2014/main" id="{7DDDED54-FBEA-942C-EC00-502EE4492CD5}"/>
               </a:ext>
             </a:extLst>
           </p:cNvPr>
@@ -9177,7 +9177,7 @@
     </p:spTree>
     <p:extLst>
       <p:ext uri="{BB962C8B-B14F-4D97-AF65-F5344CB8AC3E}">
-        <p14:creationId xmlns:p14="http://schemas.microsoft.com/office/powerpoint/2010/main" val="1544573581"/>
+        <p14:creationId xmlns:p14="http://schemas.microsoft.com/office/powerpoint/2010/main" val="1793312072"/>
       </p:ext>
     </p:extLst>
   </p:cSld>
@@ -9534,7 +9534,7 @@
           <p:cNvPr id="2" name="Elipse 1">
             <a:extLst>
               <a:ext uri="{FF2B5EF4-FFF2-40B4-BE49-F238E27FC236}">
-                <a16:creationId xmlns:a16="http://schemas.microsoft.com/office/drawing/2014/main" id="{9CF8956B-329B-21E9-717F-59E731FEEF94}"/>
+                <a16:creationId xmlns:a16="http://schemas.microsoft.com/office/drawing/2014/main" id="{4E553F24-ADD6-B39F-0CC8-B066311BFDE0}"/>
               </a:ext>
             </a:extLst>
           </p:cNvPr>
@@ -9604,7 +9604,7 @@
           <p:cNvPr id="3" name="Elipse 2">
             <a:extLst>
               <a:ext uri="{FF2B5EF4-FFF2-40B4-BE49-F238E27FC236}">
-                <a16:creationId xmlns:a16="http://schemas.microsoft.com/office/drawing/2014/main" id="{ADC80204-522B-7C72-FD8A-C013973F7DC8}"/>
+                <a16:creationId xmlns:a16="http://schemas.microsoft.com/office/drawing/2014/main" id="{DADBF9B2-0414-DE41-EA26-2CAE8AC80AA4}"/>
               </a:ext>
             </a:extLst>
           </p:cNvPr>
@@ -9674,7 +9674,7 @@
           <p:cNvPr id="4" name="Elipse 3">
             <a:extLst>
               <a:ext uri="{FF2B5EF4-FFF2-40B4-BE49-F238E27FC236}">
-                <a16:creationId xmlns:a16="http://schemas.microsoft.com/office/drawing/2014/main" id="{3776BA94-579E-0D06-D28D-819676EE59F4}"/>
+                <a16:creationId xmlns:a16="http://schemas.microsoft.com/office/drawing/2014/main" id="{E607B017-4A7A-2938-0229-9F3F2F65924C}"/>
               </a:ext>
             </a:extLst>
           </p:cNvPr>
@@ -9744,7 +9744,7 @@
           <p:cNvPr id="6" name="Imagem 5">
             <a:extLst>
               <a:ext uri="{FF2B5EF4-FFF2-40B4-BE49-F238E27FC236}">
-                <a16:creationId xmlns:a16="http://schemas.microsoft.com/office/drawing/2014/main" id="{03C617CB-28D2-4B3A-825D-F674FC3CD74C}"/>
+                <a16:creationId xmlns:a16="http://schemas.microsoft.com/office/drawing/2014/main" id="{4F5971E6-B6AB-1409-684C-4D14FA646794}"/>
               </a:ext>
             </a:extLst>
           </p:cNvPr>
@@ -9780,7 +9780,7 @@
           <p:cNvPr id="7" name="CaixaDeTexto 6">
             <a:extLst>
               <a:ext uri="{FF2B5EF4-FFF2-40B4-BE49-F238E27FC236}">
-                <a16:creationId xmlns:a16="http://schemas.microsoft.com/office/drawing/2014/main" id="{BFA265E1-1D7C-AE2A-52B3-BD10DA3DEFEB}"/>
+                <a16:creationId xmlns:a16="http://schemas.microsoft.com/office/drawing/2014/main" id="{8B3D8DBD-9B04-5511-0500-03449000FF9E}"/>
               </a:ext>
             </a:extLst>
           </p:cNvPr>
@@ -9834,7 +9834,7 @@
           <p:cNvPr id="8" name="Retângulo: Cantos Arredondados 7">
             <a:extLst>
               <a:ext uri="{FF2B5EF4-FFF2-40B4-BE49-F238E27FC236}">
-                <a16:creationId xmlns:a16="http://schemas.microsoft.com/office/drawing/2014/main" id="{32E8E083-F239-F532-8139-89AEDA443718}"/>
+                <a16:creationId xmlns:a16="http://schemas.microsoft.com/office/drawing/2014/main" id="{F2F0C248-28A1-AF60-C3B8-9BAC58F9A1B8}"/>
               </a:ext>
             </a:extLst>
           </p:cNvPr>
@@ -9912,7 +9912,7 @@
           <p:cNvPr id="9" name="Retângulo: Cantos Arredondados 8">
             <a:extLst>
               <a:ext uri="{FF2B5EF4-FFF2-40B4-BE49-F238E27FC236}">
-                <a16:creationId xmlns:a16="http://schemas.microsoft.com/office/drawing/2014/main" id="{0960571D-A6B4-62D4-7C7B-048A97DCC869}"/>
+                <a16:creationId xmlns:a16="http://schemas.microsoft.com/office/drawing/2014/main" id="{7639C2D1-B35F-4B0C-E88B-BA393FDB96E6}"/>
               </a:ext>
             </a:extLst>
           </p:cNvPr>
@@ -9984,7 +9984,7 @@
           <p:cNvPr id="10" name="CaixaDeTexto 9">
             <a:extLst>
               <a:ext uri="{FF2B5EF4-FFF2-40B4-BE49-F238E27FC236}">
-                <a16:creationId xmlns:a16="http://schemas.microsoft.com/office/drawing/2014/main" id="{9DFC8EAD-5162-FE2E-66A6-E6101E002CAC}"/>
+                <a16:creationId xmlns:a16="http://schemas.microsoft.com/office/drawing/2014/main" id="{BE7524C2-5DF9-63AE-8A2A-39DC52156F00}"/>
               </a:ext>
             </a:extLst>
           </p:cNvPr>
@@ -10029,7 +10029,7 @@
           <p:cNvPr id="11" name="Conector reto 10">
             <a:extLst>
               <a:ext uri="{FF2B5EF4-FFF2-40B4-BE49-F238E27FC236}">
-                <a16:creationId xmlns:a16="http://schemas.microsoft.com/office/drawing/2014/main" id="{883A63E5-4B27-65FB-49C4-A4A5FECEC6A8}"/>
+                <a16:creationId xmlns:a16="http://schemas.microsoft.com/office/drawing/2014/main" id="{B7684167-75FE-3BC3-5049-556385336C9F}"/>
               </a:ext>
             </a:extLst>
           </p:cNvPr>
@@ -10076,7 +10076,7 @@
           <p:cNvPr id="12" name="Conector reto 11">
             <a:extLst>
               <a:ext uri="{FF2B5EF4-FFF2-40B4-BE49-F238E27FC236}">
-                <a16:creationId xmlns:a16="http://schemas.microsoft.com/office/drawing/2014/main" id="{8B5A0085-8AAF-B73F-2B40-51FB551C8BC5}"/>
+                <a16:creationId xmlns:a16="http://schemas.microsoft.com/office/drawing/2014/main" id="{CF66C08B-9039-EC32-885A-AA7E8BD78E66}"/>
               </a:ext>
             </a:extLst>
           </p:cNvPr>
@@ -10121,7 +10121,7 @@
           <p:cNvPr id="13" name="Elipse 12">
             <a:extLst>
               <a:ext uri="{FF2B5EF4-FFF2-40B4-BE49-F238E27FC236}">
-                <a16:creationId xmlns:a16="http://schemas.microsoft.com/office/drawing/2014/main" id="{A40AB93C-18A5-06D8-D1A1-D4FDD643C41D}"/>
+                <a16:creationId xmlns:a16="http://schemas.microsoft.com/office/drawing/2014/main" id="{2F948FBA-6D19-F7FC-0767-11C70F643D18}"/>
               </a:ext>
             </a:extLst>
           </p:cNvPr>
@@ -10189,7 +10189,7 @@
           <p:cNvPr id="14" name="CaixaDeTexto 13">
             <a:extLst>
               <a:ext uri="{FF2B5EF4-FFF2-40B4-BE49-F238E27FC236}">
-                <a16:creationId xmlns:a16="http://schemas.microsoft.com/office/drawing/2014/main" id="{410AB831-EF8B-E9E3-7942-B79EDC6E77AB}"/>
+                <a16:creationId xmlns:a16="http://schemas.microsoft.com/office/drawing/2014/main" id="{15218EA4-C97C-8D61-43A9-D14B60F4B9C5}"/>
               </a:ext>
             </a:extLst>
           </p:cNvPr>
@@ -10232,7 +10232,7 @@
     </p:spTree>
     <p:extLst>
       <p:ext uri="{BB962C8B-B14F-4D97-AF65-F5344CB8AC3E}">
-        <p14:creationId xmlns:p14="http://schemas.microsoft.com/office/powerpoint/2010/main" val="698729384"/>
+        <p14:creationId xmlns:p14="http://schemas.microsoft.com/office/powerpoint/2010/main" val="315050802"/>
       </p:ext>
     </p:extLst>
   </p:cSld>
@@ -10481,7 +10481,7 @@
           <p:cNvPr id="2" name="CaixaDeTexto 1">
             <a:extLst>
               <a:ext uri="{FF2B5EF4-FFF2-40B4-BE49-F238E27FC236}">
-                <a16:creationId xmlns:a16="http://schemas.microsoft.com/office/drawing/2014/main" id="{E9984C3C-9AC8-438D-9708-BEB48BD7E2FD}"/>
+                <a16:creationId xmlns:a16="http://schemas.microsoft.com/office/drawing/2014/main" id="{62065727-8D88-A766-FFC3-22DFC402A1F3}"/>
               </a:ext>
             </a:extLst>
           </p:cNvPr>
@@ -10512,7 +10512,7 @@
             <a:r>
               <a:rPr lang="pt-BR" sz="1000" spc="170">
                 <a:solidFill>
-                  <a:srgbClr val="9BA1A6"/>
+                  <a:srgbClr val="46EB7E"/>
                 </a:solidFill>
                 <a:latin typeface="Instrument Sans Medium" pitchFamily="2" charset="0"/>
               </a:rPr>
@@ -10526,7 +10526,7 @@
           <p:cNvPr id="3" name="CaixaDeTexto 2">
             <a:extLst>
               <a:ext uri="{FF2B5EF4-FFF2-40B4-BE49-F238E27FC236}">
-                <a16:creationId xmlns:a16="http://schemas.microsoft.com/office/drawing/2014/main" id="{9CF3ED4F-088B-41EC-0984-D063B8E0585A}"/>
+                <a16:creationId xmlns:a16="http://schemas.microsoft.com/office/drawing/2014/main" id="{8E6ABE6B-1D1D-DD0E-A98C-A940DF22D566}"/>
               </a:ext>
             </a:extLst>
           </p:cNvPr>
@@ -10580,7 +10580,7 @@
           <p:cNvPr id="21" name="Agrupar 20">
             <a:extLst>
               <a:ext uri="{FF2B5EF4-FFF2-40B4-BE49-F238E27FC236}">
-                <a16:creationId xmlns:a16="http://schemas.microsoft.com/office/drawing/2014/main" id="{052F13F9-71C4-B0AE-6EE1-064B602BB8E6}"/>
+                <a16:creationId xmlns:a16="http://schemas.microsoft.com/office/drawing/2014/main" id="{AB643DEF-5054-DDDB-3BB3-94DE8EC99ACA}"/>
               </a:ext>
             </a:extLst>
           </p:cNvPr>
@@ -10600,7 +10600,7 @@
             <p:cNvPr id="4" name="Conector reto 3">
               <a:extLst>
                 <a:ext uri="{FF2B5EF4-FFF2-40B4-BE49-F238E27FC236}">
-                  <a16:creationId xmlns:a16="http://schemas.microsoft.com/office/drawing/2014/main" id="{40179326-767B-B58F-4ED5-63B5339AEE49}"/>
+                  <a16:creationId xmlns:a16="http://schemas.microsoft.com/office/drawing/2014/main" id="{B4BC2852-EC64-7877-89EE-1B69FD6372AF}"/>
                 </a:ext>
               </a:extLst>
             </p:cNvPr>
@@ -10647,7 +10647,7 @@
             <p:cNvPr id="5" name="Conector reto 4">
               <a:extLst>
                 <a:ext uri="{FF2B5EF4-FFF2-40B4-BE49-F238E27FC236}">
-                  <a16:creationId xmlns:a16="http://schemas.microsoft.com/office/drawing/2014/main" id="{0406D135-128A-AFD8-CDB8-BFF23569F3F2}"/>
+                  <a16:creationId xmlns:a16="http://schemas.microsoft.com/office/drawing/2014/main" id="{3A624EFE-E615-9435-1B23-E974E7BEF245}"/>
                 </a:ext>
               </a:extLst>
             </p:cNvPr>
@@ -10694,7 +10694,7 @@
             <p:cNvPr id="6" name="Conector reto 5">
               <a:extLst>
                 <a:ext uri="{FF2B5EF4-FFF2-40B4-BE49-F238E27FC236}">
-                  <a16:creationId xmlns:a16="http://schemas.microsoft.com/office/drawing/2014/main" id="{83862B3C-578C-C6DC-9D97-08A3E6FCFF54}"/>
+                  <a16:creationId xmlns:a16="http://schemas.microsoft.com/office/drawing/2014/main" id="{E97F3C60-2137-93D3-DF6C-D735A87CCE3E}"/>
                 </a:ext>
               </a:extLst>
             </p:cNvPr>
@@ -10741,7 +10741,7 @@
             <p:cNvPr id="7" name="Conector reto 6">
               <a:extLst>
                 <a:ext uri="{FF2B5EF4-FFF2-40B4-BE49-F238E27FC236}">
-                  <a16:creationId xmlns:a16="http://schemas.microsoft.com/office/drawing/2014/main" id="{3761AFF9-43C1-3148-CCF0-3D1CF55DFD2F}"/>
+                  <a16:creationId xmlns:a16="http://schemas.microsoft.com/office/drawing/2014/main" id="{2FE17013-9D08-C16B-660F-3403858BCAC7}"/>
                 </a:ext>
               </a:extLst>
             </p:cNvPr>
@@ -10788,7 +10788,7 @@
             <p:cNvPr id="8" name="Conector reto 7">
               <a:extLst>
                 <a:ext uri="{FF2B5EF4-FFF2-40B4-BE49-F238E27FC236}">
-                  <a16:creationId xmlns:a16="http://schemas.microsoft.com/office/drawing/2014/main" id="{0F4A79D5-C5BE-40E5-AECC-783E76322CC0}"/>
+                  <a16:creationId xmlns:a16="http://schemas.microsoft.com/office/drawing/2014/main" id="{AB649A40-82AF-987B-E7C9-44FF160AD589}"/>
                 </a:ext>
               </a:extLst>
             </p:cNvPr>
@@ -10835,7 +10835,7 @@
             <p:cNvPr id="9" name="Conector reto 8">
               <a:extLst>
                 <a:ext uri="{FF2B5EF4-FFF2-40B4-BE49-F238E27FC236}">
-                  <a16:creationId xmlns:a16="http://schemas.microsoft.com/office/drawing/2014/main" id="{9C37F593-8108-C7AE-9B10-74D65E5B34A5}"/>
+                  <a16:creationId xmlns:a16="http://schemas.microsoft.com/office/drawing/2014/main" id="{112679BE-A913-0939-C786-B5D1341F3D60}"/>
                 </a:ext>
               </a:extLst>
             </p:cNvPr>
@@ -10882,7 +10882,7 @@
             <p:cNvPr id="10" name="Conector reto 9">
               <a:extLst>
                 <a:ext uri="{FF2B5EF4-FFF2-40B4-BE49-F238E27FC236}">
-                  <a16:creationId xmlns:a16="http://schemas.microsoft.com/office/drawing/2014/main" id="{16E959C2-75A2-6A6B-8B40-281344888B0D}"/>
+                  <a16:creationId xmlns:a16="http://schemas.microsoft.com/office/drawing/2014/main" id="{37D1CD16-B689-7620-FB22-3E24686BA7BA}"/>
                 </a:ext>
               </a:extLst>
             </p:cNvPr>
@@ -10929,7 +10929,7 @@
             <p:cNvPr id="11" name="Retângulo: Cantos Arredondados 10">
               <a:extLst>
                 <a:ext uri="{FF2B5EF4-FFF2-40B4-BE49-F238E27FC236}">
-                  <a16:creationId xmlns:a16="http://schemas.microsoft.com/office/drawing/2014/main" id="{5F27D3F8-D64A-794B-0AA5-3B1B9497F830}"/>
+                  <a16:creationId xmlns:a16="http://schemas.microsoft.com/office/drawing/2014/main" id="{19F4A4C0-45E8-B462-56DD-B6E0469CEB3C}"/>
                 </a:ext>
               </a:extLst>
             </p:cNvPr>
@@ -11001,7 +11001,7 @@
             <p:cNvPr id="12" name="Retângulo: Cantos Arredondados 11">
               <a:extLst>
                 <a:ext uri="{FF2B5EF4-FFF2-40B4-BE49-F238E27FC236}">
-                  <a16:creationId xmlns:a16="http://schemas.microsoft.com/office/drawing/2014/main" id="{27FAB01E-2439-7BF1-996A-FE586B2F1A51}"/>
+                  <a16:creationId xmlns:a16="http://schemas.microsoft.com/office/drawing/2014/main" id="{414FCAB9-8639-61C6-81DB-A76AF54F9E4B}"/>
                 </a:ext>
               </a:extLst>
             </p:cNvPr>
@@ -11073,7 +11073,7 @@
             <p:cNvPr id="13" name="Retângulo: Cantos Arredondados 12">
               <a:extLst>
                 <a:ext uri="{FF2B5EF4-FFF2-40B4-BE49-F238E27FC236}">
-                  <a16:creationId xmlns:a16="http://schemas.microsoft.com/office/drawing/2014/main" id="{B1CCF4D0-F378-8C4F-2C4D-67EF73C77FF6}"/>
+                  <a16:creationId xmlns:a16="http://schemas.microsoft.com/office/drawing/2014/main" id="{A2E6C1E8-A563-1CA1-45DA-A702415E2E3D}"/>
                 </a:ext>
               </a:extLst>
             </p:cNvPr>
@@ -11145,7 +11145,7 @@
             <p:cNvPr id="14" name="Retângulo: Cantos Arredondados 13">
               <a:extLst>
                 <a:ext uri="{FF2B5EF4-FFF2-40B4-BE49-F238E27FC236}">
-                  <a16:creationId xmlns:a16="http://schemas.microsoft.com/office/drawing/2014/main" id="{5D83C8E7-8BCE-9684-6962-7E11EBA216B6}"/>
+                  <a16:creationId xmlns:a16="http://schemas.microsoft.com/office/drawing/2014/main" id="{D7E58514-A378-0043-B717-6F772DC569FD}"/>
                 </a:ext>
               </a:extLst>
             </p:cNvPr>
@@ -11217,7 +11217,7 @@
             <p:cNvPr id="15" name="Elipse 14">
               <a:extLst>
                 <a:ext uri="{FF2B5EF4-FFF2-40B4-BE49-F238E27FC236}">
-                  <a16:creationId xmlns:a16="http://schemas.microsoft.com/office/drawing/2014/main" id="{4B204BDB-D749-61F1-6901-87BA233485E7}"/>
+                  <a16:creationId xmlns:a16="http://schemas.microsoft.com/office/drawing/2014/main" id="{F38F4A87-BC2D-4BE2-F897-C700EDAB06FB}"/>
                 </a:ext>
               </a:extLst>
             </p:cNvPr>
@@ -11287,7 +11287,7 @@
             <p:cNvPr id="16" name="Elipse 15">
               <a:extLst>
                 <a:ext uri="{FF2B5EF4-FFF2-40B4-BE49-F238E27FC236}">
-                  <a16:creationId xmlns:a16="http://schemas.microsoft.com/office/drawing/2014/main" id="{57BD1EBD-EEC2-214F-E130-32A3090010E9}"/>
+                  <a16:creationId xmlns:a16="http://schemas.microsoft.com/office/drawing/2014/main" id="{F0205676-C286-4507-9C74-7003213E2978}"/>
                 </a:ext>
               </a:extLst>
             </p:cNvPr>
@@ -11357,7 +11357,7 @@
             <p:cNvPr id="17" name="Elipse 16">
               <a:extLst>
                 <a:ext uri="{FF2B5EF4-FFF2-40B4-BE49-F238E27FC236}">
-                  <a16:creationId xmlns:a16="http://schemas.microsoft.com/office/drawing/2014/main" id="{1CF8EC02-FE16-AB8B-294E-AFC0A5BB6892}"/>
+                  <a16:creationId xmlns:a16="http://schemas.microsoft.com/office/drawing/2014/main" id="{6CF7D3FA-A5C0-6F68-8131-7EBB8C8FE1A0}"/>
                 </a:ext>
               </a:extLst>
             </p:cNvPr>
@@ -11427,7 +11427,7 @@
             <p:cNvPr id="18" name="Elipse 17">
               <a:extLst>
                 <a:ext uri="{FF2B5EF4-FFF2-40B4-BE49-F238E27FC236}">
-                  <a16:creationId xmlns:a16="http://schemas.microsoft.com/office/drawing/2014/main" id="{EE861F14-4E10-5EDF-D252-5EA491CDCC77}"/>
+                  <a16:creationId xmlns:a16="http://schemas.microsoft.com/office/drawing/2014/main" id="{6DD19419-8CC5-A7E0-C712-8ABD9A82BBF8}"/>
                 </a:ext>
               </a:extLst>
             </p:cNvPr>
@@ -11497,7 +11497,7 @@
             <p:cNvPr id="19" name="Elipse 18">
               <a:extLst>
                 <a:ext uri="{FF2B5EF4-FFF2-40B4-BE49-F238E27FC236}">
-                  <a16:creationId xmlns:a16="http://schemas.microsoft.com/office/drawing/2014/main" id="{EBE81E8B-28F3-F75D-E0FB-161A473369FF}"/>
+                  <a16:creationId xmlns:a16="http://schemas.microsoft.com/office/drawing/2014/main" id="{9D739C84-787A-16E3-D65E-37A4B74112C8}"/>
                 </a:ext>
               </a:extLst>
             </p:cNvPr>
@@ -11567,7 +11567,7 @@
             <p:cNvPr id="20" name="Elipse 19">
               <a:extLst>
                 <a:ext uri="{FF2B5EF4-FFF2-40B4-BE49-F238E27FC236}">
-                  <a16:creationId xmlns:a16="http://schemas.microsoft.com/office/drawing/2014/main" id="{A2412BE1-30FC-B195-E78C-E21D6F98A76A}"/>
+                  <a16:creationId xmlns:a16="http://schemas.microsoft.com/office/drawing/2014/main" id="{7ED610A8-5368-6F7A-5984-F79B69200C8A}"/>
                 </a:ext>
               </a:extLst>
             </p:cNvPr>
@@ -11638,7 +11638,7 @@
           <p:cNvPr id="22" name="Conector reto 21">
             <a:extLst>
               <a:ext uri="{FF2B5EF4-FFF2-40B4-BE49-F238E27FC236}">
-                <a16:creationId xmlns:a16="http://schemas.microsoft.com/office/drawing/2014/main" id="{089AB38E-426C-9DE2-46BA-8C6BDEBDB165}"/>
+                <a16:creationId xmlns:a16="http://schemas.microsoft.com/office/drawing/2014/main" id="{97CF611F-5217-F381-7F61-9619A793620D}"/>
               </a:ext>
             </a:extLst>
           </p:cNvPr>
@@ -11685,7 +11685,7 @@
           <p:cNvPr id="23" name="Conector reto 22">
             <a:extLst>
               <a:ext uri="{FF2B5EF4-FFF2-40B4-BE49-F238E27FC236}">
-                <a16:creationId xmlns:a16="http://schemas.microsoft.com/office/drawing/2014/main" id="{BC4A37AE-27AF-88CA-743F-C9D23F8E1B28}"/>
+                <a16:creationId xmlns:a16="http://schemas.microsoft.com/office/drawing/2014/main" id="{4E0CD49F-40F8-8C45-ACC4-61D642F40930}"/>
               </a:ext>
             </a:extLst>
           </p:cNvPr>
@@ -11730,7 +11730,7 @@
           <p:cNvPr id="24" name="Elipse 23">
             <a:extLst>
               <a:ext uri="{FF2B5EF4-FFF2-40B4-BE49-F238E27FC236}">
-                <a16:creationId xmlns:a16="http://schemas.microsoft.com/office/drawing/2014/main" id="{DD7B3DCE-E45A-4524-E8F9-2018C30CE8BB}"/>
+                <a16:creationId xmlns:a16="http://schemas.microsoft.com/office/drawing/2014/main" id="{09BF7F6F-1A61-A121-6F53-0B55D7B8885C}"/>
               </a:ext>
             </a:extLst>
           </p:cNvPr>
@@ -11798,7 +11798,7 @@
           <p:cNvPr id="25" name="CaixaDeTexto 24">
             <a:extLst>
               <a:ext uri="{FF2B5EF4-FFF2-40B4-BE49-F238E27FC236}">
-                <a16:creationId xmlns:a16="http://schemas.microsoft.com/office/drawing/2014/main" id="{C802FD4D-6B6E-BF5B-9F63-60BB65D7DBE0}"/>
+                <a16:creationId xmlns:a16="http://schemas.microsoft.com/office/drawing/2014/main" id="{06C21FA1-9E2B-68FA-DFA0-7CE852A39322}"/>
               </a:ext>
             </a:extLst>
           </p:cNvPr>
@@ -11841,7 +11841,7 @@
     </p:spTree>
     <p:extLst>
       <p:ext uri="{BB962C8B-B14F-4D97-AF65-F5344CB8AC3E}">
-        <p14:creationId xmlns:p14="http://schemas.microsoft.com/office/powerpoint/2010/main" val="1931940413"/>
+        <p14:creationId xmlns:p14="http://schemas.microsoft.com/office/powerpoint/2010/main" val="287958522"/>
       </p:ext>
     </p:extLst>
   </p:cSld>
@@ -12053,7 +12053,7 @@
           <p:cNvPr id="2" name="Elipse 1">
             <a:extLst>
               <a:ext uri="{FF2B5EF4-FFF2-40B4-BE49-F238E27FC236}">
-                <a16:creationId xmlns:a16="http://schemas.microsoft.com/office/drawing/2014/main" id="{87B1C7D7-49D7-CFA4-4162-0169369E09C5}"/>
+                <a16:creationId xmlns:a16="http://schemas.microsoft.com/office/drawing/2014/main" id="{04B6B93C-9F49-D296-1202-D7CF4F909EE2}"/>
               </a:ext>
             </a:extLst>
           </p:cNvPr>
@@ -12123,7 +12123,7 @@
           <p:cNvPr id="3" name="Elipse 2">
             <a:extLst>
               <a:ext uri="{FF2B5EF4-FFF2-40B4-BE49-F238E27FC236}">
-                <a16:creationId xmlns:a16="http://schemas.microsoft.com/office/drawing/2014/main" id="{835F6B66-D3EA-01D6-8DFA-FA3D5912F24E}"/>
+                <a16:creationId xmlns:a16="http://schemas.microsoft.com/office/drawing/2014/main" id="{D564C901-4C97-5CB8-6795-105834956DCF}"/>
               </a:ext>
             </a:extLst>
           </p:cNvPr>
@@ -12193,7 +12193,7 @@
           <p:cNvPr id="4" name="Elipse 3">
             <a:extLst>
               <a:ext uri="{FF2B5EF4-FFF2-40B4-BE49-F238E27FC236}">
-                <a16:creationId xmlns:a16="http://schemas.microsoft.com/office/drawing/2014/main" id="{11083E2D-140A-7E48-B442-B9074D135CB8}"/>
+                <a16:creationId xmlns:a16="http://schemas.microsoft.com/office/drawing/2014/main" id="{76408B34-905B-7BDD-E731-C99D50360506}"/>
               </a:ext>
             </a:extLst>
           </p:cNvPr>
@@ -12263,7 +12263,7 @@
           <p:cNvPr id="5" name="CaixaDeTexto 4">
             <a:extLst>
               <a:ext uri="{FF2B5EF4-FFF2-40B4-BE49-F238E27FC236}">
-                <a16:creationId xmlns:a16="http://schemas.microsoft.com/office/drawing/2014/main" id="{5F27AFC8-35AD-A97F-6B9A-F99D5FEDB751}"/>
+                <a16:creationId xmlns:a16="http://schemas.microsoft.com/office/drawing/2014/main" id="{51FAC682-1355-5F54-6B5D-1CE9E6BF32DD}"/>
               </a:ext>
             </a:extLst>
           </p:cNvPr>
@@ -12317,7 +12317,7 @@
           <p:cNvPr id="6" name="Conector reto 5">
             <a:extLst>
               <a:ext uri="{FF2B5EF4-FFF2-40B4-BE49-F238E27FC236}">
-                <a16:creationId xmlns:a16="http://schemas.microsoft.com/office/drawing/2014/main" id="{90C51403-E26A-01E4-D9FA-5BF313AEBD44}"/>
+                <a16:creationId xmlns:a16="http://schemas.microsoft.com/office/drawing/2014/main" id="{11DD4EEF-61DB-8035-3367-BF7BD3AAF5E5}"/>
               </a:ext>
             </a:extLst>
           </p:cNvPr>
@@ -12364,7 +12364,7 @@
           <p:cNvPr id="7" name="Conector reto 6">
             <a:extLst>
               <a:ext uri="{FF2B5EF4-FFF2-40B4-BE49-F238E27FC236}">
-                <a16:creationId xmlns:a16="http://schemas.microsoft.com/office/drawing/2014/main" id="{D6494ABE-0628-C0DB-1705-4D5FE00D75F6}"/>
+                <a16:creationId xmlns:a16="http://schemas.microsoft.com/office/drawing/2014/main" id="{8B4B2421-D5B2-352F-BFD0-B6B37B38BA68}"/>
               </a:ext>
             </a:extLst>
           </p:cNvPr>
@@ -12409,7 +12409,7 @@
           <p:cNvPr id="8" name="Elipse 7">
             <a:extLst>
               <a:ext uri="{FF2B5EF4-FFF2-40B4-BE49-F238E27FC236}">
-                <a16:creationId xmlns:a16="http://schemas.microsoft.com/office/drawing/2014/main" id="{3C00F6FC-5695-5A33-3DD4-145B6E435A62}"/>
+                <a16:creationId xmlns:a16="http://schemas.microsoft.com/office/drawing/2014/main" id="{9FA447A8-1A6D-E8DB-A6C6-CB44A44238A7}"/>
               </a:ext>
             </a:extLst>
           </p:cNvPr>
@@ -12477,7 +12477,7 @@
           <p:cNvPr id="9" name="CaixaDeTexto 8">
             <a:extLst>
               <a:ext uri="{FF2B5EF4-FFF2-40B4-BE49-F238E27FC236}">
-                <a16:creationId xmlns:a16="http://schemas.microsoft.com/office/drawing/2014/main" id="{3907B73D-EEB1-B32B-7A1D-4F32D9349AA0}"/>
+                <a16:creationId xmlns:a16="http://schemas.microsoft.com/office/drawing/2014/main" id="{6EE28018-4959-AC01-9BC4-645EBC9C8967}"/>
               </a:ext>
             </a:extLst>
           </p:cNvPr>
@@ -12520,7 +12520,7 @@
     </p:spTree>
     <p:extLst>
       <p:ext uri="{BB962C8B-B14F-4D97-AF65-F5344CB8AC3E}">
-        <p14:creationId xmlns:p14="http://schemas.microsoft.com/office/powerpoint/2010/main" val="2881075555"/>
+        <p14:creationId xmlns:p14="http://schemas.microsoft.com/office/powerpoint/2010/main" val="711388407"/>
       </p:ext>
     </p:extLst>
   </p:cSld>
@@ -12661,7 +12661,7 @@
           <p:cNvPr id="2" name="CaixaDeTexto 1">
             <a:extLst>
               <a:ext uri="{FF2B5EF4-FFF2-40B4-BE49-F238E27FC236}">
-                <a16:creationId xmlns:a16="http://schemas.microsoft.com/office/drawing/2014/main" id="{FB0274F1-3D0F-1E43-C581-E866076149E2}"/>
+                <a16:creationId xmlns:a16="http://schemas.microsoft.com/office/drawing/2014/main" id="{55A61762-A538-0088-F07B-3EF0B99C9314}"/>
               </a:ext>
             </a:extLst>
           </p:cNvPr>
@@ -12706,7 +12706,7 @@
           <p:cNvPr id="3" name="CaixaDeTexto 2">
             <a:extLst>
               <a:ext uri="{FF2B5EF4-FFF2-40B4-BE49-F238E27FC236}">
-                <a16:creationId xmlns:a16="http://schemas.microsoft.com/office/drawing/2014/main" id="{C1E3D48F-4948-963F-AAC2-404C53A56650}"/>
+                <a16:creationId xmlns:a16="http://schemas.microsoft.com/office/drawing/2014/main" id="{9E8F96FB-79E9-B8A4-8BE5-5A08008BE58A}"/>
               </a:ext>
             </a:extLst>
           </p:cNvPr>
@@ -12760,7 +12760,7 @@
           <p:cNvPr id="4" name="CaixaDeTexto 3">
             <a:extLst>
               <a:ext uri="{FF2B5EF4-FFF2-40B4-BE49-F238E27FC236}">
-                <a16:creationId xmlns:a16="http://schemas.microsoft.com/office/drawing/2014/main" id="{BF6A0BE9-4C29-E124-D4C4-3FC97026E066}"/>
+                <a16:creationId xmlns:a16="http://schemas.microsoft.com/office/drawing/2014/main" id="{36B17FB5-76A3-CB03-D751-9163FB503E81}"/>
               </a:ext>
             </a:extLst>
           </p:cNvPr>
@@ -12805,7 +12805,7 @@
           <p:cNvPr id="5" name="Conector reto 4">
             <a:extLst>
               <a:ext uri="{FF2B5EF4-FFF2-40B4-BE49-F238E27FC236}">
-                <a16:creationId xmlns:a16="http://schemas.microsoft.com/office/drawing/2014/main" id="{8A7EF6A0-B101-A3E8-F341-A9E14EB86D2C}"/>
+                <a16:creationId xmlns:a16="http://schemas.microsoft.com/office/drawing/2014/main" id="{9529627D-A52D-D5A7-DD32-56FCFDB6A2E6}"/>
               </a:ext>
             </a:extLst>
           </p:cNvPr>
@@ -12852,7 +12852,7 @@
           <p:cNvPr id="9" name="Agrupar 8">
             <a:extLst>
               <a:ext uri="{FF2B5EF4-FFF2-40B4-BE49-F238E27FC236}">
-                <a16:creationId xmlns:a16="http://schemas.microsoft.com/office/drawing/2014/main" id="{643E9E29-3F3B-00AA-6104-C9C0D948A2A2}"/>
+                <a16:creationId xmlns:a16="http://schemas.microsoft.com/office/drawing/2014/main" id="{26146CB6-1621-308F-08F2-318196DB7E38}"/>
               </a:ext>
             </a:extLst>
           </p:cNvPr>
@@ -12872,7 +12872,7 @@
             <p:cNvPr id="6" name="Elipse 5">
               <a:extLst>
                 <a:ext uri="{FF2B5EF4-FFF2-40B4-BE49-F238E27FC236}">
-                  <a16:creationId xmlns:a16="http://schemas.microsoft.com/office/drawing/2014/main" id="{5D77443F-707A-C35E-6E15-AEE6F7A48180}"/>
+                  <a16:creationId xmlns:a16="http://schemas.microsoft.com/office/drawing/2014/main" id="{BBC1180A-CCDE-152D-69DD-C5395E99FB27}"/>
                 </a:ext>
               </a:extLst>
             </p:cNvPr>
@@ -12932,7 +12932,7 @@
             <p:cNvPr id="7" name="CaixaDeTexto 6">
               <a:extLst>
                 <a:ext uri="{FF2B5EF4-FFF2-40B4-BE49-F238E27FC236}">
-                  <a16:creationId xmlns:a16="http://schemas.microsoft.com/office/drawing/2014/main" id="{6C0F365D-F77A-5479-0FB6-7225B1644BA7}"/>
+                  <a16:creationId xmlns:a16="http://schemas.microsoft.com/office/drawing/2014/main" id="{250EF192-25B2-20AB-0B60-00592DE190F0}"/>
                 </a:ext>
               </a:extLst>
             </p:cNvPr>
@@ -12977,7 +12977,7 @@
             <p:cNvPr id="8" name="CaixaDeTexto 7">
               <a:extLst>
                 <a:ext uri="{FF2B5EF4-FFF2-40B4-BE49-F238E27FC236}">
-                  <a16:creationId xmlns:a16="http://schemas.microsoft.com/office/drawing/2014/main" id="{8B2E44C0-D8AC-9263-20CE-44B70583D921}"/>
+                  <a16:creationId xmlns:a16="http://schemas.microsoft.com/office/drawing/2014/main" id="{D01298FB-6538-F482-8D90-B7EFC55EF3C9}"/>
                 </a:ext>
               </a:extLst>
             </p:cNvPr>
@@ -13023,7 +13023,7 @@
           <p:cNvPr id="13" name="Agrupar 12">
             <a:extLst>
               <a:ext uri="{FF2B5EF4-FFF2-40B4-BE49-F238E27FC236}">
-                <a16:creationId xmlns:a16="http://schemas.microsoft.com/office/drawing/2014/main" id="{2C595858-6F18-87B5-3290-1A3ED86717FA}"/>
+                <a16:creationId xmlns:a16="http://schemas.microsoft.com/office/drawing/2014/main" id="{29D9FBFE-EB73-789C-1275-AB25A6258CD4}"/>
               </a:ext>
             </a:extLst>
           </p:cNvPr>
@@ -13043,7 +13043,7 @@
             <p:cNvPr id="10" name="Elipse 9">
               <a:extLst>
                 <a:ext uri="{FF2B5EF4-FFF2-40B4-BE49-F238E27FC236}">
-                  <a16:creationId xmlns:a16="http://schemas.microsoft.com/office/drawing/2014/main" id="{CB72B04E-B50F-B987-2400-CDCECCF28B99}"/>
+                  <a16:creationId xmlns:a16="http://schemas.microsoft.com/office/drawing/2014/main" id="{46AA851C-75A4-64A2-F03D-23CBD9290392}"/>
                 </a:ext>
               </a:extLst>
             </p:cNvPr>
@@ -13103,7 +13103,7 @@
             <p:cNvPr id="11" name="CaixaDeTexto 10">
               <a:extLst>
                 <a:ext uri="{FF2B5EF4-FFF2-40B4-BE49-F238E27FC236}">
-                  <a16:creationId xmlns:a16="http://schemas.microsoft.com/office/drawing/2014/main" id="{8D7D51E7-87C9-A9B4-A9B2-014173515557}"/>
+                  <a16:creationId xmlns:a16="http://schemas.microsoft.com/office/drawing/2014/main" id="{46116979-89DF-C9D0-4F6E-637D4C9B78E4}"/>
                 </a:ext>
               </a:extLst>
             </p:cNvPr>
@@ -13148,7 +13148,7 @@
             <p:cNvPr id="12" name="CaixaDeTexto 11">
               <a:extLst>
                 <a:ext uri="{FF2B5EF4-FFF2-40B4-BE49-F238E27FC236}">
-                  <a16:creationId xmlns:a16="http://schemas.microsoft.com/office/drawing/2014/main" id="{75F0BDFD-134D-611B-4BAD-586207B24A09}"/>
+                  <a16:creationId xmlns:a16="http://schemas.microsoft.com/office/drawing/2014/main" id="{53EF9318-EC44-DB81-D5C8-4616C09386C0}"/>
                 </a:ext>
               </a:extLst>
             </p:cNvPr>
@@ -13194,7 +13194,7 @@
           <p:cNvPr id="17" name="Agrupar 16">
             <a:extLst>
               <a:ext uri="{FF2B5EF4-FFF2-40B4-BE49-F238E27FC236}">
-                <a16:creationId xmlns:a16="http://schemas.microsoft.com/office/drawing/2014/main" id="{D05739CC-88FD-A986-D835-9BCAE923E03C}"/>
+                <a16:creationId xmlns:a16="http://schemas.microsoft.com/office/drawing/2014/main" id="{2DBD3653-E81E-5D25-4086-B2E0B0B46565}"/>
               </a:ext>
             </a:extLst>
           </p:cNvPr>
@@ -13214,7 +13214,7 @@
             <p:cNvPr id="14" name="Elipse 13">
               <a:extLst>
                 <a:ext uri="{FF2B5EF4-FFF2-40B4-BE49-F238E27FC236}">
-                  <a16:creationId xmlns:a16="http://schemas.microsoft.com/office/drawing/2014/main" id="{E0724020-5CD0-D952-83B6-C5D82B889510}"/>
+                  <a16:creationId xmlns:a16="http://schemas.microsoft.com/office/drawing/2014/main" id="{D4373198-F90D-ECF8-BBB1-E21D2B6C155F}"/>
                 </a:ext>
               </a:extLst>
             </p:cNvPr>
@@ -13274,7 +13274,7 @@
             <p:cNvPr id="15" name="CaixaDeTexto 14">
               <a:extLst>
                 <a:ext uri="{FF2B5EF4-FFF2-40B4-BE49-F238E27FC236}">
-                  <a16:creationId xmlns:a16="http://schemas.microsoft.com/office/drawing/2014/main" id="{545E6CB1-1BF2-E61F-B305-F5C5974D9A7B}"/>
+                  <a16:creationId xmlns:a16="http://schemas.microsoft.com/office/drawing/2014/main" id="{B766E41B-4C49-4BAE-94A9-E6E64D83C9DC}"/>
                 </a:ext>
               </a:extLst>
             </p:cNvPr>
@@ -13319,7 +13319,7 @@
             <p:cNvPr id="16" name="CaixaDeTexto 15">
               <a:extLst>
                 <a:ext uri="{FF2B5EF4-FFF2-40B4-BE49-F238E27FC236}">
-                  <a16:creationId xmlns:a16="http://schemas.microsoft.com/office/drawing/2014/main" id="{BE06E503-67F7-90F6-C53A-F130A38B51A8}"/>
+                  <a16:creationId xmlns:a16="http://schemas.microsoft.com/office/drawing/2014/main" id="{0AD1D297-3EE9-28FA-0328-8C2961F452F4}"/>
                 </a:ext>
               </a:extLst>
             </p:cNvPr>
@@ -13365,7 +13365,7 @@
           <p:cNvPr id="21" name="Agrupar 20">
             <a:extLst>
               <a:ext uri="{FF2B5EF4-FFF2-40B4-BE49-F238E27FC236}">
-                <a16:creationId xmlns:a16="http://schemas.microsoft.com/office/drawing/2014/main" id="{2FCC3DE1-9CD2-613D-8E78-1CAE04D054C2}"/>
+                <a16:creationId xmlns:a16="http://schemas.microsoft.com/office/drawing/2014/main" id="{BDA6F971-F67C-ED0D-609E-517D80285DF6}"/>
               </a:ext>
             </a:extLst>
           </p:cNvPr>
@@ -13385,7 +13385,7 @@
             <p:cNvPr id="18" name="Elipse 17">
               <a:extLst>
                 <a:ext uri="{FF2B5EF4-FFF2-40B4-BE49-F238E27FC236}">
-                  <a16:creationId xmlns:a16="http://schemas.microsoft.com/office/drawing/2014/main" id="{06179899-FAE3-3B98-53D7-C151608A1D7E}"/>
+                  <a16:creationId xmlns:a16="http://schemas.microsoft.com/office/drawing/2014/main" id="{E691923F-59BD-BAF9-3DE1-45A07F77F52D}"/>
                 </a:ext>
               </a:extLst>
             </p:cNvPr>
@@ -13445,7 +13445,7 @@
             <p:cNvPr id="19" name="CaixaDeTexto 18">
               <a:extLst>
                 <a:ext uri="{FF2B5EF4-FFF2-40B4-BE49-F238E27FC236}">
-                  <a16:creationId xmlns:a16="http://schemas.microsoft.com/office/drawing/2014/main" id="{372CB457-2567-71DA-C33A-1C71B8608817}"/>
+                  <a16:creationId xmlns:a16="http://schemas.microsoft.com/office/drawing/2014/main" id="{BDEC2DAD-291B-887A-8883-6CF2A25A243E}"/>
                 </a:ext>
               </a:extLst>
             </p:cNvPr>
@@ -13490,7 +13490,7 @@
             <p:cNvPr id="20" name="CaixaDeTexto 19">
               <a:extLst>
                 <a:ext uri="{FF2B5EF4-FFF2-40B4-BE49-F238E27FC236}">
-                  <a16:creationId xmlns:a16="http://schemas.microsoft.com/office/drawing/2014/main" id="{A87832F7-E6E1-94FA-C5E6-921102044901}"/>
+                  <a16:creationId xmlns:a16="http://schemas.microsoft.com/office/drawing/2014/main" id="{A155E616-8EE7-5CFF-1E7D-27AE3864A93A}"/>
                 </a:ext>
               </a:extLst>
             </p:cNvPr>
@@ -13536,7 +13536,7 @@
           <p:cNvPr id="25" name="Agrupar 24">
             <a:extLst>
               <a:ext uri="{FF2B5EF4-FFF2-40B4-BE49-F238E27FC236}">
-                <a16:creationId xmlns:a16="http://schemas.microsoft.com/office/drawing/2014/main" id="{017BD084-ECE8-CE5C-F0D6-43F7EBC7E683}"/>
+                <a16:creationId xmlns:a16="http://schemas.microsoft.com/office/drawing/2014/main" id="{58B01B47-CA3C-6679-C442-4C8BE3421F9D}"/>
               </a:ext>
             </a:extLst>
           </p:cNvPr>
@@ -13556,7 +13556,7 @@
             <p:cNvPr id="22" name="Elipse 21">
               <a:extLst>
                 <a:ext uri="{FF2B5EF4-FFF2-40B4-BE49-F238E27FC236}">
-                  <a16:creationId xmlns:a16="http://schemas.microsoft.com/office/drawing/2014/main" id="{EAF939C8-C114-990A-DAC0-C5DB2FED9E62}"/>
+                  <a16:creationId xmlns:a16="http://schemas.microsoft.com/office/drawing/2014/main" id="{13B3A671-A806-ECDC-042C-B3A8AB182D1E}"/>
                 </a:ext>
               </a:extLst>
             </p:cNvPr>
@@ -13616,7 +13616,7 @@
             <p:cNvPr id="23" name="CaixaDeTexto 22">
               <a:extLst>
                 <a:ext uri="{FF2B5EF4-FFF2-40B4-BE49-F238E27FC236}">
-                  <a16:creationId xmlns:a16="http://schemas.microsoft.com/office/drawing/2014/main" id="{DD05D572-F8C8-6DFA-BADB-55B96F08EC7D}"/>
+                  <a16:creationId xmlns:a16="http://schemas.microsoft.com/office/drawing/2014/main" id="{99907FA3-01C6-57F1-E2D7-B7CCC9F1DB9C}"/>
                 </a:ext>
               </a:extLst>
             </p:cNvPr>
@@ -13661,7 +13661,7 @@
             <p:cNvPr id="24" name="CaixaDeTexto 23">
               <a:extLst>
                 <a:ext uri="{FF2B5EF4-FFF2-40B4-BE49-F238E27FC236}">
-                  <a16:creationId xmlns:a16="http://schemas.microsoft.com/office/drawing/2014/main" id="{3BD96FCC-B6CD-D27D-ED31-8D0BF4BB0AC6}"/>
+                  <a16:creationId xmlns:a16="http://schemas.microsoft.com/office/drawing/2014/main" id="{8BFE9280-DD5A-9761-B60B-4BE1A0D3451D}"/>
                 </a:ext>
               </a:extLst>
             </p:cNvPr>
@@ -13707,7 +13707,7 @@
           <p:cNvPr id="29" name="Agrupar 28">
             <a:extLst>
               <a:ext uri="{FF2B5EF4-FFF2-40B4-BE49-F238E27FC236}">
-                <a16:creationId xmlns:a16="http://schemas.microsoft.com/office/drawing/2014/main" id="{34446032-6B4C-FA40-D800-2B28B1D3B2C6}"/>
+                <a16:creationId xmlns:a16="http://schemas.microsoft.com/office/drawing/2014/main" id="{C290DE10-FEA8-8CFF-1A96-2695C58DF640}"/>
               </a:ext>
             </a:extLst>
           </p:cNvPr>
@@ -13727,7 +13727,7 @@
             <p:cNvPr id="26" name="Elipse 25">
               <a:extLst>
                 <a:ext uri="{FF2B5EF4-FFF2-40B4-BE49-F238E27FC236}">
-                  <a16:creationId xmlns:a16="http://schemas.microsoft.com/office/drawing/2014/main" id="{BB3CCC75-35A9-92E8-4847-9ABE0EBB9AAA}"/>
+                  <a16:creationId xmlns:a16="http://schemas.microsoft.com/office/drawing/2014/main" id="{B7FFC637-18CF-2BF8-EBB4-FE2EF31B414D}"/>
                 </a:ext>
               </a:extLst>
             </p:cNvPr>
@@ -13795,7 +13795,7 @@
             <p:cNvPr id="27" name="CaixaDeTexto 26">
               <a:extLst>
                 <a:ext uri="{FF2B5EF4-FFF2-40B4-BE49-F238E27FC236}">
-                  <a16:creationId xmlns:a16="http://schemas.microsoft.com/office/drawing/2014/main" id="{9C3E18A7-EB54-1191-2709-095BA5858CB7}"/>
+                  <a16:creationId xmlns:a16="http://schemas.microsoft.com/office/drawing/2014/main" id="{59928668-341D-CA9A-FD04-A4DE6293BF64}"/>
                 </a:ext>
               </a:extLst>
             </p:cNvPr>
@@ -13840,7 +13840,7 @@
             <p:cNvPr id="28" name="CaixaDeTexto 27">
               <a:extLst>
                 <a:ext uri="{FF2B5EF4-FFF2-40B4-BE49-F238E27FC236}">
-                  <a16:creationId xmlns:a16="http://schemas.microsoft.com/office/drawing/2014/main" id="{F733B094-2E72-7724-BB61-6B9485D26A13}"/>
+                  <a16:creationId xmlns:a16="http://schemas.microsoft.com/office/drawing/2014/main" id="{9CE82816-D66F-BD49-ED20-404FF70CDF61}"/>
                 </a:ext>
               </a:extLst>
             </p:cNvPr>
@@ -13886,7 +13886,7 @@
           <p:cNvPr id="30" name="Conector reto 29">
             <a:extLst>
               <a:ext uri="{FF2B5EF4-FFF2-40B4-BE49-F238E27FC236}">
-                <a16:creationId xmlns:a16="http://schemas.microsoft.com/office/drawing/2014/main" id="{22A2AB8A-C77C-55F2-EDD3-1730C7772016}"/>
+                <a16:creationId xmlns:a16="http://schemas.microsoft.com/office/drawing/2014/main" id="{F90D4995-8F64-F224-D819-8666AD3C6D27}"/>
               </a:ext>
             </a:extLst>
           </p:cNvPr>
@@ -13933,7 +13933,7 @@
           <p:cNvPr id="31" name="Conector reto 30">
             <a:extLst>
               <a:ext uri="{FF2B5EF4-FFF2-40B4-BE49-F238E27FC236}">
-                <a16:creationId xmlns:a16="http://schemas.microsoft.com/office/drawing/2014/main" id="{F22B7C99-9D9A-254E-08F2-435B12B8603D}"/>
+                <a16:creationId xmlns:a16="http://schemas.microsoft.com/office/drawing/2014/main" id="{D70A2028-880E-8DD2-976D-85BB33D4B00B}"/>
               </a:ext>
             </a:extLst>
           </p:cNvPr>
@@ -13978,7 +13978,7 @@
           <p:cNvPr id="32" name="Elipse 31">
             <a:extLst>
               <a:ext uri="{FF2B5EF4-FFF2-40B4-BE49-F238E27FC236}">
-                <a16:creationId xmlns:a16="http://schemas.microsoft.com/office/drawing/2014/main" id="{966AA287-4C13-FDA0-FE5B-2E2ADA72A3A9}"/>
+                <a16:creationId xmlns:a16="http://schemas.microsoft.com/office/drawing/2014/main" id="{D5BD4811-4186-2BC6-48F4-B74473B4CAD2}"/>
               </a:ext>
             </a:extLst>
           </p:cNvPr>
@@ -14046,7 +14046,7 @@
           <p:cNvPr id="33" name="CaixaDeTexto 32">
             <a:extLst>
               <a:ext uri="{FF2B5EF4-FFF2-40B4-BE49-F238E27FC236}">
-                <a16:creationId xmlns:a16="http://schemas.microsoft.com/office/drawing/2014/main" id="{B9E37322-A390-4E6C-37C5-02CC83B7F47A}"/>
+                <a16:creationId xmlns:a16="http://schemas.microsoft.com/office/drawing/2014/main" id="{0927717C-CE03-3241-F20A-9F537A94FCD2}"/>
               </a:ext>
             </a:extLst>
           </p:cNvPr>
@@ -14089,7 +14089,7 @@
     </p:spTree>
     <p:extLst>
       <p:ext uri="{BB962C8B-B14F-4D97-AF65-F5344CB8AC3E}">
-        <p14:creationId xmlns:p14="http://schemas.microsoft.com/office/powerpoint/2010/main" val="250456481"/>
+        <p14:creationId xmlns:p14="http://schemas.microsoft.com/office/powerpoint/2010/main" val="366908163"/>
       </p:ext>
     </p:extLst>
   </p:cSld>
@@ -14512,7 +14512,7 @@
           <p:cNvPr id="2" name="CaixaDeTexto 1">
             <a:extLst>
               <a:ext uri="{FF2B5EF4-FFF2-40B4-BE49-F238E27FC236}">
-                <a16:creationId xmlns:a16="http://schemas.microsoft.com/office/drawing/2014/main" id="{0BC62FB5-A865-18E4-BA48-DE9BBBAF6F1B}"/>
+                <a16:creationId xmlns:a16="http://schemas.microsoft.com/office/drawing/2014/main" id="{648577FA-0399-482B-1D8B-3DA00993985D}"/>
               </a:ext>
             </a:extLst>
           </p:cNvPr>
@@ -14557,7 +14557,7 @@
           <p:cNvPr id="3" name="CaixaDeTexto 2">
             <a:extLst>
               <a:ext uri="{FF2B5EF4-FFF2-40B4-BE49-F238E27FC236}">
-                <a16:creationId xmlns:a16="http://schemas.microsoft.com/office/drawing/2014/main" id="{428271DF-723C-1151-623D-98D90875CC66}"/>
+                <a16:creationId xmlns:a16="http://schemas.microsoft.com/office/drawing/2014/main" id="{C87E2214-7E0D-A914-CCDA-3BCBD6AB5A8D}"/>
               </a:ext>
             </a:extLst>
           </p:cNvPr>
@@ -14611,7 +14611,7 @@
           <p:cNvPr id="7" name="Agrupar 6">
             <a:extLst>
               <a:ext uri="{FF2B5EF4-FFF2-40B4-BE49-F238E27FC236}">
-                <a16:creationId xmlns:a16="http://schemas.microsoft.com/office/drawing/2014/main" id="{11ABDE52-B41A-0CFC-0161-564162C2563E}"/>
+                <a16:creationId xmlns:a16="http://schemas.microsoft.com/office/drawing/2014/main" id="{3240005C-F5AB-DEB2-475F-8FB1F4908026}"/>
               </a:ext>
             </a:extLst>
           </p:cNvPr>
@@ -14631,7 +14631,7 @@
             <p:cNvPr id="4" name="CaixaDeTexto 3">
               <a:extLst>
                 <a:ext uri="{FF2B5EF4-FFF2-40B4-BE49-F238E27FC236}">
-                  <a16:creationId xmlns:a16="http://schemas.microsoft.com/office/drawing/2014/main" id="{D007B679-BD54-ADE1-8AB8-2791A23095A1}"/>
+                  <a16:creationId xmlns:a16="http://schemas.microsoft.com/office/drawing/2014/main" id="{4BB292D6-3CE0-3503-30A7-BABC0ED0BA65}"/>
                 </a:ext>
               </a:extLst>
             </p:cNvPr>
@@ -14685,7 +14685,7 @@
             <p:cNvPr id="5" name="CaixaDeTexto 4">
               <a:extLst>
                 <a:ext uri="{FF2B5EF4-FFF2-40B4-BE49-F238E27FC236}">
-                  <a16:creationId xmlns:a16="http://schemas.microsoft.com/office/drawing/2014/main" id="{D0C036BA-2067-4E24-009B-5E54F2CA01A5}"/>
+                  <a16:creationId xmlns:a16="http://schemas.microsoft.com/office/drawing/2014/main" id="{1AAD6E75-2F0C-DBFE-4BF3-6F8B5A8017FB}"/>
                 </a:ext>
               </a:extLst>
             </p:cNvPr>
@@ -14730,7 +14730,7 @@
             <p:cNvPr id="6" name="CaixaDeTexto 5">
               <a:extLst>
                 <a:ext uri="{FF2B5EF4-FFF2-40B4-BE49-F238E27FC236}">
-                  <a16:creationId xmlns:a16="http://schemas.microsoft.com/office/drawing/2014/main" id="{3D582374-2B31-1176-37AB-0D11DE8C76D5}"/>
+                  <a16:creationId xmlns:a16="http://schemas.microsoft.com/office/drawing/2014/main" id="{82BEFCEA-78F3-4FDC-9A22-EC7BCBB805A4}"/>
                 </a:ext>
               </a:extLst>
             </p:cNvPr>
@@ -14776,7 +14776,7 @@
           <p:cNvPr id="11" name="Agrupar 10">
             <a:extLst>
               <a:ext uri="{FF2B5EF4-FFF2-40B4-BE49-F238E27FC236}">
-                <a16:creationId xmlns:a16="http://schemas.microsoft.com/office/drawing/2014/main" id="{018A23BC-B6B7-BEE5-F80C-C3894FA23EB4}"/>
+                <a16:creationId xmlns:a16="http://schemas.microsoft.com/office/drawing/2014/main" id="{EFC25BF1-7DB1-58C7-ECD8-EC5B3AB6D574}"/>
               </a:ext>
             </a:extLst>
           </p:cNvPr>
@@ -14796,7 +14796,7 @@
             <p:cNvPr id="8" name="CaixaDeTexto 7">
               <a:extLst>
                 <a:ext uri="{FF2B5EF4-FFF2-40B4-BE49-F238E27FC236}">
-                  <a16:creationId xmlns:a16="http://schemas.microsoft.com/office/drawing/2014/main" id="{33E6AAD1-C427-78D7-CAD1-9132BEF544F8}"/>
+                  <a16:creationId xmlns:a16="http://schemas.microsoft.com/office/drawing/2014/main" id="{20B1218E-0F76-4970-71BC-308C45FF4BF6}"/>
                 </a:ext>
               </a:extLst>
             </p:cNvPr>
@@ -14850,7 +14850,7 @@
             <p:cNvPr id="9" name="CaixaDeTexto 8">
               <a:extLst>
                 <a:ext uri="{FF2B5EF4-FFF2-40B4-BE49-F238E27FC236}">
-                  <a16:creationId xmlns:a16="http://schemas.microsoft.com/office/drawing/2014/main" id="{627F930A-84E9-4914-0FF4-8F4067F2CED0}"/>
+                  <a16:creationId xmlns:a16="http://schemas.microsoft.com/office/drawing/2014/main" id="{0A1A2651-4EA8-5806-0F4A-B1F89324A068}"/>
                 </a:ext>
               </a:extLst>
             </p:cNvPr>
@@ -14895,7 +14895,7 @@
             <p:cNvPr id="10" name="CaixaDeTexto 9">
               <a:extLst>
                 <a:ext uri="{FF2B5EF4-FFF2-40B4-BE49-F238E27FC236}">
-                  <a16:creationId xmlns:a16="http://schemas.microsoft.com/office/drawing/2014/main" id="{2A1A03E8-8B60-5711-FD70-2A77D93DF60A}"/>
+                  <a16:creationId xmlns:a16="http://schemas.microsoft.com/office/drawing/2014/main" id="{AF231DEF-40DA-7BCB-1D94-5E452851A902}"/>
                 </a:ext>
               </a:extLst>
             </p:cNvPr>
@@ -14941,7 +14941,7 @@
           <p:cNvPr id="15" name="Agrupar 14">
             <a:extLst>
               <a:ext uri="{FF2B5EF4-FFF2-40B4-BE49-F238E27FC236}">
-                <a16:creationId xmlns:a16="http://schemas.microsoft.com/office/drawing/2014/main" id="{5F258DF3-DB61-1CD5-FDC1-23120120ED93}"/>
+                <a16:creationId xmlns:a16="http://schemas.microsoft.com/office/drawing/2014/main" id="{54D92533-7950-67DC-0BF8-37008B61FC71}"/>
               </a:ext>
             </a:extLst>
           </p:cNvPr>
@@ -14961,7 +14961,7 @@
             <p:cNvPr id="12" name="CaixaDeTexto 11">
               <a:extLst>
                 <a:ext uri="{FF2B5EF4-FFF2-40B4-BE49-F238E27FC236}">
-                  <a16:creationId xmlns:a16="http://schemas.microsoft.com/office/drawing/2014/main" id="{8AE1D844-DDF8-A221-8546-D04946DD3825}"/>
+                  <a16:creationId xmlns:a16="http://schemas.microsoft.com/office/drawing/2014/main" id="{ED5E908D-1E40-AC12-B14A-7D942285CE36}"/>
                 </a:ext>
               </a:extLst>
             </p:cNvPr>
@@ -15015,7 +15015,7 @@
             <p:cNvPr id="13" name="CaixaDeTexto 12">
               <a:extLst>
                 <a:ext uri="{FF2B5EF4-FFF2-40B4-BE49-F238E27FC236}">
-                  <a16:creationId xmlns:a16="http://schemas.microsoft.com/office/drawing/2014/main" id="{DB7B49C4-D7B6-C030-4822-3D668783CF0A}"/>
+                  <a16:creationId xmlns:a16="http://schemas.microsoft.com/office/drawing/2014/main" id="{DA0C4A74-4CE6-BCC3-0E9C-1C352ACF743F}"/>
                 </a:ext>
               </a:extLst>
             </p:cNvPr>
@@ -15060,7 +15060,7 @@
             <p:cNvPr id="14" name="CaixaDeTexto 13">
               <a:extLst>
                 <a:ext uri="{FF2B5EF4-FFF2-40B4-BE49-F238E27FC236}">
-                  <a16:creationId xmlns:a16="http://schemas.microsoft.com/office/drawing/2014/main" id="{6A001BA8-71BE-9E14-359A-E90E63028E83}"/>
+                  <a16:creationId xmlns:a16="http://schemas.microsoft.com/office/drawing/2014/main" id="{E53DB852-A63D-00C5-C080-8A69204C290D}"/>
                 </a:ext>
               </a:extLst>
             </p:cNvPr>
@@ -15106,7 +15106,7 @@
           <p:cNvPr id="16" name="Conector reto 15">
             <a:extLst>
               <a:ext uri="{FF2B5EF4-FFF2-40B4-BE49-F238E27FC236}">
-                <a16:creationId xmlns:a16="http://schemas.microsoft.com/office/drawing/2014/main" id="{076713C4-1ACC-7AF5-4180-F826E8F03F38}"/>
+                <a16:creationId xmlns:a16="http://schemas.microsoft.com/office/drawing/2014/main" id="{C7302CD4-423F-363D-389A-75C4546AC31E}"/>
               </a:ext>
             </a:extLst>
           </p:cNvPr>
@@ -15153,7 +15153,7 @@
           <p:cNvPr id="17" name="Conector reto 16">
             <a:extLst>
               <a:ext uri="{FF2B5EF4-FFF2-40B4-BE49-F238E27FC236}">
-                <a16:creationId xmlns:a16="http://schemas.microsoft.com/office/drawing/2014/main" id="{B658651B-B56C-74A2-634D-FAAFB10E0859}"/>
+                <a16:creationId xmlns:a16="http://schemas.microsoft.com/office/drawing/2014/main" id="{7F96BB08-6AA7-1FD9-FE5C-33E0E6198FC2}"/>
               </a:ext>
             </a:extLst>
           </p:cNvPr>
@@ -15200,7 +15200,7 @@
           <p:cNvPr id="18" name="Conector reto 17">
             <a:extLst>
               <a:ext uri="{FF2B5EF4-FFF2-40B4-BE49-F238E27FC236}">
-                <a16:creationId xmlns:a16="http://schemas.microsoft.com/office/drawing/2014/main" id="{91510A7C-B1B5-DA37-E34A-29A8EE2799C7}"/>
+                <a16:creationId xmlns:a16="http://schemas.microsoft.com/office/drawing/2014/main" id="{B1B40C27-8D53-0E2C-9B5B-E91FA802467B}"/>
               </a:ext>
             </a:extLst>
           </p:cNvPr>
@@ -15247,7 +15247,7 @@
           <p:cNvPr id="19" name="Conector reto 18">
             <a:extLst>
               <a:ext uri="{FF2B5EF4-FFF2-40B4-BE49-F238E27FC236}">
-                <a16:creationId xmlns:a16="http://schemas.microsoft.com/office/drawing/2014/main" id="{550CD7E2-0E79-FAC2-C9E0-9C784CCB27A8}"/>
+                <a16:creationId xmlns:a16="http://schemas.microsoft.com/office/drawing/2014/main" id="{5218DE6B-3068-2707-83AC-0CC01CD01A61}"/>
               </a:ext>
             </a:extLst>
           </p:cNvPr>
@@ -15292,7 +15292,7 @@
           <p:cNvPr id="20" name="Elipse 19">
             <a:extLst>
               <a:ext uri="{FF2B5EF4-FFF2-40B4-BE49-F238E27FC236}">
-                <a16:creationId xmlns:a16="http://schemas.microsoft.com/office/drawing/2014/main" id="{86F41FAA-7B34-F947-6517-240B06840106}"/>
+                <a16:creationId xmlns:a16="http://schemas.microsoft.com/office/drawing/2014/main" id="{EC1C8AC4-B897-A8F0-837A-0832FF32A8EC}"/>
               </a:ext>
             </a:extLst>
           </p:cNvPr>
@@ -15360,7 +15360,7 @@
           <p:cNvPr id="21" name="CaixaDeTexto 20">
             <a:extLst>
               <a:ext uri="{FF2B5EF4-FFF2-40B4-BE49-F238E27FC236}">
-                <a16:creationId xmlns:a16="http://schemas.microsoft.com/office/drawing/2014/main" id="{1E533BBC-22D1-697C-77B5-A6EEB3B2C98D}"/>
+                <a16:creationId xmlns:a16="http://schemas.microsoft.com/office/drawing/2014/main" id="{04B55571-714E-589D-2B1C-CC8525FEADE1}"/>
               </a:ext>
             </a:extLst>
           </p:cNvPr>
@@ -15403,7 +15403,7 @@
     </p:spTree>
     <p:extLst>
       <p:ext uri="{BB962C8B-B14F-4D97-AF65-F5344CB8AC3E}">
-        <p14:creationId xmlns:p14="http://schemas.microsoft.com/office/powerpoint/2010/main" val="1843964734"/>
+        <p14:creationId xmlns:p14="http://schemas.microsoft.com/office/powerpoint/2010/main" val="3762224625"/>
       </p:ext>
     </p:extLst>
   </p:cSld>
@@ -15685,7 +15685,7 @@
           <p:cNvPr id="5" name="Agrupar 4">
             <a:extLst>
               <a:ext uri="{FF2B5EF4-FFF2-40B4-BE49-F238E27FC236}">
-                <a16:creationId xmlns:a16="http://schemas.microsoft.com/office/drawing/2014/main" id="{857D7F92-A535-BCA8-2C29-2871467F3786}"/>
+                <a16:creationId xmlns:a16="http://schemas.microsoft.com/office/drawing/2014/main" id="{641D0364-4745-DF26-89C3-3D02E9B7D4B8}"/>
               </a:ext>
             </a:extLst>
           </p:cNvPr>
@@ -15705,7 +15705,7 @@
             <p:cNvPr id="2" name="CaixaDeTexto 1">
               <a:extLst>
                 <a:ext uri="{FF2B5EF4-FFF2-40B4-BE49-F238E27FC236}">
-                  <a16:creationId xmlns:a16="http://schemas.microsoft.com/office/drawing/2014/main" id="{6FB048D7-015D-5DCB-19A3-1A4A8D311BD6}"/>
+                  <a16:creationId xmlns:a16="http://schemas.microsoft.com/office/drawing/2014/main" id="{113414AB-57CA-1C97-B30D-2452A6DEE0C3}"/>
                 </a:ext>
               </a:extLst>
             </p:cNvPr>
@@ -15759,7 +15759,7 @@
             <p:cNvPr id="3" name="CaixaDeTexto 2">
               <a:extLst>
                 <a:ext uri="{FF2B5EF4-FFF2-40B4-BE49-F238E27FC236}">
-                  <a16:creationId xmlns:a16="http://schemas.microsoft.com/office/drawing/2014/main" id="{5B127231-C6A4-CF99-B10D-6B9A605A670D}"/>
+                  <a16:creationId xmlns:a16="http://schemas.microsoft.com/office/drawing/2014/main" id="{3AA640AC-3903-407E-BE4E-28D99C532316}"/>
                 </a:ext>
               </a:extLst>
             </p:cNvPr>
@@ -15804,7 +15804,7 @@
             <p:cNvPr id="4" name="CaixaDeTexto 3">
               <a:extLst>
                 <a:ext uri="{FF2B5EF4-FFF2-40B4-BE49-F238E27FC236}">
-                  <a16:creationId xmlns:a16="http://schemas.microsoft.com/office/drawing/2014/main" id="{D48CE4EC-B53B-5255-B03E-5518165BDE44}"/>
+                  <a16:creationId xmlns:a16="http://schemas.microsoft.com/office/drawing/2014/main" id="{811E871B-929C-630C-92B9-AACEC572B1E7}"/>
                 </a:ext>
               </a:extLst>
             </p:cNvPr>
@@ -15859,7 +15859,7 @@
           <p:cNvPr id="6" name="CaixaDeTexto 5">
             <a:extLst>
               <a:ext uri="{FF2B5EF4-FFF2-40B4-BE49-F238E27FC236}">
-                <a16:creationId xmlns:a16="http://schemas.microsoft.com/office/drawing/2014/main" id="{B7C5032F-4878-86C0-3613-7FA4C18E0BF4}"/>
+                <a16:creationId xmlns:a16="http://schemas.microsoft.com/office/drawing/2014/main" id="{117CD789-A80D-B5BC-12BE-4BF43BF2EF39}"/>
               </a:ext>
             </a:extLst>
           </p:cNvPr>
@@ -15904,7 +15904,7 @@
           <p:cNvPr id="25" name="Agrupar 24">
             <a:extLst>
               <a:ext uri="{FF2B5EF4-FFF2-40B4-BE49-F238E27FC236}">
-                <a16:creationId xmlns:a16="http://schemas.microsoft.com/office/drawing/2014/main" id="{0EDB75D1-03A2-371D-4008-678A6E653EAA}"/>
+                <a16:creationId xmlns:a16="http://schemas.microsoft.com/office/drawing/2014/main" id="{7E0EC13B-24AB-2000-CE3E-13790BF16439}"/>
               </a:ext>
             </a:extLst>
           </p:cNvPr>
@@ -15924,7 +15924,7 @@
             <p:cNvPr id="7" name="Conector reto 6">
               <a:extLst>
                 <a:ext uri="{FF2B5EF4-FFF2-40B4-BE49-F238E27FC236}">
-                  <a16:creationId xmlns:a16="http://schemas.microsoft.com/office/drawing/2014/main" id="{A3173595-404F-BD45-A173-D7533DF4F315}"/>
+                  <a16:creationId xmlns:a16="http://schemas.microsoft.com/office/drawing/2014/main" id="{62283BF2-CEC3-3ED9-C761-A8C07A2B3860}"/>
                 </a:ext>
               </a:extLst>
             </p:cNvPr>
@@ -15971,7 +15971,7 @@
             <p:cNvPr id="8" name="Conector reto 7">
               <a:extLst>
                 <a:ext uri="{FF2B5EF4-FFF2-40B4-BE49-F238E27FC236}">
-                  <a16:creationId xmlns:a16="http://schemas.microsoft.com/office/drawing/2014/main" id="{3F220D97-13DB-0692-E4C2-C55DD8A8960F}"/>
+                  <a16:creationId xmlns:a16="http://schemas.microsoft.com/office/drawing/2014/main" id="{8378FBD7-2AD3-AD5C-2362-9C3718BEAA09}"/>
                 </a:ext>
               </a:extLst>
             </p:cNvPr>
@@ -16018,7 +16018,7 @@
             <p:cNvPr id="9" name="CaixaDeTexto 8">
               <a:extLst>
                 <a:ext uri="{FF2B5EF4-FFF2-40B4-BE49-F238E27FC236}">
-                  <a16:creationId xmlns:a16="http://schemas.microsoft.com/office/drawing/2014/main" id="{0D9E6F3D-C964-A6A0-D762-E03729576C86}"/>
+                  <a16:creationId xmlns:a16="http://schemas.microsoft.com/office/drawing/2014/main" id="{53BD11B5-750F-738B-CB0B-3B99982B7B98}"/>
                 </a:ext>
               </a:extLst>
             </p:cNvPr>
@@ -16063,7 +16063,7 @@
             <p:cNvPr id="10" name="Forma Livre: Forma 9">
               <a:extLst>
                 <a:ext uri="{FF2B5EF4-FFF2-40B4-BE49-F238E27FC236}">
-                  <a16:creationId xmlns:a16="http://schemas.microsoft.com/office/drawing/2014/main" id="{A02B1ED5-9BDF-1339-0AE2-9E5EBD6A6533}"/>
+                  <a16:creationId xmlns:a16="http://schemas.microsoft.com/office/drawing/2014/main" id="{D05550D5-AA34-91C7-24C7-04EE85B2A695}"/>
                 </a:ext>
               </a:extLst>
             </p:cNvPr>
@@ -16161,7 +16161,7 @@
             <p:cNvPr id="11" name="Forma Livre: Forma 10">
               <a:extLst>
                 <a:ext uri="{FF2B5EF4-FFF2-40B4-BE49-F238E27FC236}">
-                  <a16:creationId xmlns:a16="http://schemas.microsoft.com/office/drawing/2014/main" id="{07D6711F-170C-F3C5-1B1D-49DD14E27AC0}"/>
+                  <a16:creationId xmlns:a16="http://schemas.microsoft.com/office/drawing/2014/main" id="{792046BD-6D32-0F5F-691D-F08DA2ACCD10}"/>
                 </a:ext>
               </a:extLst>
             </p:cNvPr>
@@ -16240,7 +16240,7 @@
             <p:cNvPr id="12" name="CaixaDeTexto 11">
               <a:extLst>
                 <a:ext uri="{FF2B5EF4-FFF2-40B4-BE49-F238E27FC236}">
-                  <a16:creationId xmlns:a16="http://schemas.microsoft.com/office/drawing/2014/main" id="{5F54ABE0-9180-3176-3D01-FF4C7A881F1B}"/>
+                  <a16:creationId xmlns:a16="http://schemas.microsoft.com/office/drawing/2014/main" id="{C936EBAE-C9F5-44E6-40CF-263BC02788B2}"/>
                 </a:ext>
               </a:extLst>
             </p:cNvPr>
@@ -16285,7 +16285,7 @@
             <p:cNvPr id="13" name="Elipse 12">
               <a:extLst>
                 <a:ext uri="{FF2B5EF4-FFF2-40B4-BE49-F238E27FC236}">
-                  <a16:creationId xmlns:a16="http://schemas.microsoft.com/office/drawing/2014/main" id="{76F3A6E7-DF70-130C-6B3B-005040AC3628}"/>
+                  <a16:creationId xmlns:a16="http://schemas.microsoft.com/office/drawing/2014/main" id="{D13B07D3-59A5-A7F6-22E8-0C376FFC9A49}"/>
                 </a:ext>
               </a:extLst>
             </p:cNvPr>
@@ -16345,7 +16345,7 @@
             <p:cNvPr id="14" name="CaixaDeTexto 13">
               <a:extLst>
                 <a:ext uri="{FF2B5EF4-FFF2-40B4-BE49-F238E27FC236}">
-                  <a16:creationId xmlns:a16="http://schemas.microsoft.com/office/drawing/2014/main" id="{A90FA618-5C44-5F5B-AAA1-17914F0C7399}"/>
+                  <a16:creationId xmlns:a16="http://schemas.microsoft.com/office/drawing/2014/main" id="{EB8DF6EB-FD31-6285-3202-F4ACF2DC6AE9}"/>
                 </a:ext>
               </a:extLst>
             </p:cNvPr>
@@ -16390,7 +16390,7 @@
             <p:cNvPr id="15" name="CaixaDeTexto 14">
               <a:extLst>
                 <a:ext uri="{FF2B5EF4-FFF2-40B4-BE49-F238E27FC236}">
-                  <a16:creationId xmlns:a16="http://schemas.microsoft.com/office/drawing/2014/main" id="{ABF8CC32-D2CF-FCCB-4F5F-E924F515B80A}"/>
+                  <a16:creationId xmlns:a16="http://schemas.microsoft.com/office/drawing/2014/main" id="{96D2EB30-614E-385D-BE44-E68F6428B145}"/>
                 </a:ext>
               </a:extLst>
             </p:cNvPr>
@@ -16435,7 +16435,7 @@
             <p:cNvPr id="16" name="Elipse 15">
               <a:extLst>
                 <a:ext uri="{FF2B5EF4-FFF2-40B4-BE49-F238E27FC236}">
-                  <a16:creationId xmlns:a16="http://schemas.microsoft.com/office/drawing/2014/main" id="{3EE1D227-533E-702C-2F01-B4CC235E93EF}"/>
+                  <a16:creationId xmlns:a16="http://schemas.microsoft.com/office/drawing/2014/main" id="{8B11A253-0A6F-B2C4-448E-7955E7CB883E}"/>
                 </a:ext>
               </a:extLst>
             </p:cNvPr>
@@ -16495,7 +16495,7 @@
             <p:cNvPr id="17" name="CaixaDeTexto 16">
               <a:extLst>
                 <a:ext uri="{FF2B5EF4-FFF2-40B4-BE49-F238E27FC236}">
-                  <a16:creationId xmlns:a16="http://schemas.microsoft.com/office/drawing/2014/main" id="{AC7BC273-D961-692B-516A-5F90647F981A}"/>
+                  <a16:creationId xmlns:a16="http://schemas.microsoft.com/office/drawing/2014/main" id="{36592EAA-42C9-1610-BAF1-EEA038410770}"/>
                 </a:ext>
               </a:extLst>
             </p:cNvPr>
@@ -16540,7 +16540,7 @@
             <p:cNvPr id="18" name="CaixaDeTexto 17">
               <a:extLst>
                 <a:ext uri="{FF2B5EF4-FFF2-40B4-BE49-F238E27FC236}">
-                  <a16:creationId xmlns:a16="http://schemas.microsoft.com/office/drawing/2014/main" id="{B203C9B0-219D-5F4D-42AA-613F94AE0E75}"/>
+                  <a16:creationId xmlns:a16="http://schemas.microsoft.com/office/drawing/2014/main" id="{4A5C1CC1-F545-1BBB-20D8-1F8D9EF899B8}"/>
                 </a:ext>
               </a:extLst>
             </p:cNvPr>
@@ -16585,7 +16585,7 @@
             <p:cNvPr id="19" name="Elipse 18">
               <a:extLst>
                 <a:ext uri="{FF2B5EF4-FFF2-40B4-BE49-F238E27FC236}">
-                  <a16:creationId xmlns:a16="http://schemas.microsoft.com/office/drawing/2014/main" id="{0F9CF92A-B3B4-C478-6195-DF5FC5127786}"/>
+                  <a16:creationId xmlns:a16="http://schemas.microsoft.com/office/drawing/2014/main" id="{305D9116-9EF3-520A-D0CE-4DF8C4DFC4B4}"/>
                 </a:ext>
               </a:extLst>
             </p:cNvPr>
@@ -16645,7 +16645,7 @@
             <p:cNvPr id="20" name="CaixaDeTexto 19">
               <a:extLst>
                 <a:ext uri="{FF2B5EF4-FFF2-40B4-BE49-F238E27FC236}">
-                  <a16:creationId xmlns:a16="http://schemas.microsoft.com/office/drawing/2014/main" id="{16AC99EE-FD94-F78E-95D7-6A0EF4920D73}"/>
+                  <a16:creationId xmlns:a16="http://schemas.microsoft.com/office/drawing/2014/main" id="{AD70CCBB-85B3-8F56-7F1C-F8B1DA5D74F2}"/>
                 </a:ext>
               </a:extLst>
             </p:cNvPr>
@@ -16690,7 +16690,7 @@
             <p:cNvPr id="21" name="CaixaDeTexto 20">
               <a:extLst>
                 <a:ext uri="{FF2B5EF4-FFF2-40B4-BE49-F238E27FC236}">
-                  <a16:creationId xmlns:a16="http://schemas.microsoft.com/office/drawing/2014/main" id="{3F540D18-361A-1748-895E-E1E230096CF5}"/>
+                  <a16:creationId xmlns:a16="http://schemas.microsoft.com/office/drawing/2014/main" id="{50710443-2D5C-8383-A95E-670B12EE3AE3}"/>
                 </a:ext>
               </a:extLst>
             </p:cNvPr>
@@ -16735,7 +16735,7 @@
             <p:cNvPr id="22" name="Elipse 21">
               <a:extLst>
                 <a:ext uri="{FF2B5EF4-FFF2-40B4-BE49-F238E27FC236}">
-                  <a16:creationId xmlns:a16="http://schemas.microsoft.com/office/drawing/2014/main" id="{50AD8ABB-5E56-0C45-7A41-52142A867C95}"/>
+                  <a16:creationId xmlns:a16="http://schemas.microsoft.com/office/drawing/2014/main" id="{5A6E5E28-DB54-B1A8-991F-351AB8A46076}"/>
                 </a:ext>
               </a:extLst>
             </p:cNvPr>
@@ -16803,7 +16803,7 @@
             <p:cNvPr id="23" name="CaixaDeTexto 22">
               <a:extLst>
                 <a:ext uri="{FF2B5EF4-FFF2-40B4-BE49-F238E27FC236}">
-                  <a16:creationId xmlns:a16="http://schemas.microsoft.com/office/drawing/2014/main" id="{BF07D623-0978-89E2-A46D-AA98247DDA15}"/>
+                  <a16:creationId xmlns:a16="http://schemas.microsoft.com/office/drawing/2014/main" id="{0406A940-3CC1-A7DC-0CFC-46BE1867C171}"/>
                 </a:ext>
               </a:extLst>
             </p:cNvPr>
@@ -16848,7 +16848,7 @@
             <p:cNvPr id="24" name="CaixaDeTexto 23">
               <a:extLst>
                 <a:ext uri="{FF2B5EF4-FFF2-40B4-BE49-F238E27FC236}">
-                  <a16:creationId xmlns:a16="http://schemas.microsoft.com/office/drawing/2014/main" id="{995ED24A-A8C5-8BB2-8765-ABAAE910AB5C}"/>
+                  <a16:creationId xmlns:a16="http://schemas.microsoft.com/office/drawing/2014/main" id="{94B83057-8F4F-6DA6-7A5F-0F4D8DF46583}"/>
                 </a:ext>
               </a:extLst>
             </p:cNvPr>
@@ -16894,7 +16894,7 @@
           <p:cNvPr id="26" name="CaixaDeTexto 25">
             <a:extLst>
               <a:ext uri="{FF2B5EF4-FFF2-40B4-BE49-F238E27FC236}">
-                <a16:creationId xmlns:a16="http://schemas.microsoft.com/office/drawing/2014/main" id="{89820BCB-581E-3172-E39F-9DA7947595FF}"/>
+                <a16:creationId xmlns:a16="http://schemas.microsoft.com/office/drawing/2014/main" id="{36ADC95C-5E8E-571A-09DF-E54799622C1C}"/>
               </a:ext>
             </a:extLst>
           </p:cNvPr>
@@ -16948,7 +16948,7 @@
           <p:cNvPr id="27" name="Conector reto 26">
             <a:extLst>
               <a:ext uri="{FF2B5EF4-FFF2-40B4-BE49-F238E27FC236}">
-                <a16:creationId xmlns:a16="http://schemas.microsoft.com/office/drawing/2014/main" id="{8CA68399-1A97-BC28-81FB-5B65D7AFC60A}"/>
+                <a16:creationId xmlns:a16="http://schemas.microsoft.com/office/drawing/2014/main" id="{7CBD2FD4-D019-9A6B-5731-EDC1702C83F1}"/>
               </a:ext>
             </a:extLst>
           </p:cNvPr>
@@ -16995,7 +16995,7 @@
           <p:cNvPr id="28" name="Conector reto 27">
             <a:extLst>
               <a:ext uri="{FF2B5EF4-FFF2-40B4-BE49-F238E27FC236}">
-                <a16:creationId xmlns:a16="http://schemas.microsoft.com/office/drawing/2014/main" id="{14F4693A-4867-6805-4ABC-3BA272A637A6}"/>
+                <a16:creationId xmlns:a16="http://schemas.microsoft.com/office/drawing/2014/main" id="{3DF82DE2-B465-11D8-1D33-79380E32E2AA}"/>
               </a:ext>
             </a:extLst>
           </p:cNvPr>
@@ -17040,7 +17040,7 @@
           <p:cNvPr id="29" name="Elipse 28">
             <a:extLst>
               <a:ext uri="{FF2B5EF4-FFF2-40B4-BE49-F238E27FC236}">
-                <a16:creationId xmlns:a16="http://schemas.microsoft.com/office/drawing/2014/main" id="{CD5B4A8C-F26D-C9E0-26FA-114325C053C0}"/>
+                <a16:creationId xmlns:a16="http://schemas.microsoft.com/office/drawing/2014/main" id="{0AFFECD3-7132-CA52-692A-74A8940ABFF6}"/>
               </a:ext>
             </a:extLst>
           </p:cNvPr>
@@ -17108,7 +17108,7 @@
           <p:cNvPr id="30" name="CaixaDeTexto 29">
             <a:extLst>
               <a:ext uri="{FF2B5EF4-FFF2-40B4-BE49-F238E27FC236}">
-                <a16:creationId xmlns:a16="http://schemas.microsoft.com/office/drawing/2014/main" id="{E6B2CC90-00D6-D02A-2CDB-67B0A60ED1F0}"/>
+                <a16:creationId xmlns:a16="http://schemas.microsoft.com/office/drawing/2014/main" id="{6C7BC176-1966-BD51-13CC-BE6592D4D145}"/>
               </a:ext>
             </a:extLst>
           </p:cNvPr>
@@ -17151,7 +17151,7 @@
     </p:spTree>
     <p:extLst>
       <p:ext uri="{BB962C8B-B14F-4D97-AF65-F5344CB8AC3E}">
-        <p14:creationId xmlns:p14="http://schemas.microsoft.com/office/powerpoint/2010/main" val="2125563496"/>
+        <p14:creationId xmlns:p14="http://schemas.microsoft.com/office/powerpoint/2010/main" val="786429326"/>
       </p:ext>
     </p:extLst>
   </p:cSld>
@@ -17398,7 +17398,7 @@
           <p:cNvPr id="5" name="Agrupar 4">
             <a:extLst>
               <a:ext uri="{FF2B5EF4-FFF2-40B4-BE49-F238E27FC236}">
-                <a16:creationId xmlns:a16="http://schemas.microsoft.com/office/drawing/2014/main" id="{98B8CC2B-314F-07CB-550D-4BF7E86B9D02}"/>
+                <a16:creationId xmlns:a16="http://schemas.microsoft.com/office/drawing/2014/main" id="{6730ECD2-9AE5-603E-7FF8-7496F4C20226}"/>
               </a:ext>
             </a:extLst>
           </p:cNvPr>
@@ -17418,7 +17418,7 @@
             <p:cNvPr id="2" name="CaixaDeTexto 1">
               <a:extLst>
                 <a:ext uri="{FF2B5EF4-FFF2-40B4-BE49-F238E27FC236}">
-                  <a16:creationId xmlns:a16="http://schemas.microsoft.com/office/drawing/2014/main" id="{69BB250A-28D6-EEDC-0BFD-6CE9FE4F11C9}"/>
+                  <a16:creationId xmlns:a16="http://schemas.microsoft.com/office/drawing/2014/main" id="{ADB95E56-E3A4-0E9A-80E9-E4E06493549A}"/>
                 </a:ext>
               </a:extLst>
             </p:cNvPr>
@@ -17472,7 +17472,7 @@
             <p:cNvPr id="3" name="CaixaDeTexto 2">
               <a:extLst>
                 <a:ext uri="{FF2B5EF4-FFF2-40B4-BE49-F238E27FC236}">
-                  <a16:creationId xmlns:a16="http://schemas.microsoft.com/office/drawing/2014/main" id="{40824C5C-FAEE-EC7A-13DC-76FB102188A5}"/>
+                  <a16:creationId xmlns:a16="http://schemas.microsoft.com/office/drawing/2014/main" id="{3FE2A060-9549-37DB-C86A-4BF2E94751C0}"/>
                 </a:ext>
               </a:extLst>
             </p:cNvPr>
@@ -17517,7 +17517,7 @@
             <p:cNvPr id="4" name="CaixaDeTexto 3">
               <a:extLst>
                 <a:ext uri="{FF2B5EF4-FFF2-40B4-BE49-F238E27FC236}">
-                  <a16:creationId xmlns:a16="http://schemas.microsoft.com/office/drawing/2014/main" id="{F745928C-953F-D909-C642-EF04399611A0}"/>
+                  <a16:creationId xmlns:a16="http://schemas.microsoft.com/office/drawing/2014/main" id="{17334369-5BEA-CB0F-893E-697FDA053493}"/>
                 </a:ext>
               </a:extLst>
             </p:cNvPr>
@@ -17572,7 +17572,7 @@
           <p:cNvPr id="22" name="Agrupar 21">
             <a:extLst>
               <a:ext uri="{FF2B5EF4-FFF2-40B4-BE49-F238E27FC236}">
-                <a16:creationId xmlns:a16="http://schemas.microsoft.com/office/drawing/2014/main" id="{CE48F87B-1832-3BF8-6249-EE0F628D5F6B}"/>
+                <a16:creationId xmlns:a16="http://schemas.microsoft.com/office/drawing/2014/main" id="{64DC3C7C-08CD-4CA9-5B68-BD7D0B9C8708}"/>
               </a:ext>
             </a:extLst>
           </p:cNvPr>
@@ -17592,7 +17592,7 @@
             <p:cNvPr id="6" name="Forma Livre: Forma 5">
               <a:extLst>
                 <a:ext uri="{FF2B5EF4-FFF2-40B4-BE49-F238E27FC236}">
-                  <a16:creationId xmlns:a16="http://schemas.microsoft.com/office/drawing/2014/main" id="{A91B4A8E-A2C0-5263-0912-19636934E5D1}"/>
+                  <a16:creationId xmlns:a16="http://schemas.microsoft.com/office/drawing/2014/main" id="{CC2893C2-2EC0-CDED-1C0D-BCB822F286D4}"/>
                 </a:ext>
               </a:extLst>
             </p:cNvPr>
@@ -17663,7 +17663,7 @@
             <p:cNvPr id="7" name="Forma Livre: Forma 6">
               <a:extLst>
                 <a:ext uri="{FF2B5EF4-FFF2-40B4-BE49-F238E27FC236}">
-                  <a16:creationId xmlns:a16="http://schemas.microsoft.com/office/drawing/2014/main" id="{8515DED0-E9D6-AF53-5888-C13004E221CD}"/>
+                  <a16:creationId xmlns:a16="http://schemas.microsoft.com/office/drawing/2014/main" id="{F9D6A625-A6B3-72DE-3158-DD7E5C556890}"/>
                 </a:ext>
               </a:extLst>
             </p:cNvPr>
@@ -17734,7 +17734,7 @@
             <p:cNvPr id="8" name="Forma Livre: Forma 7">
               <a:extLst>
                 <a:ext uri="{FF2B5EF4-FFF2-40B4-BE49-F238E27FC236}">
-                  <a16:creationId xmlns:a16="http://schemas.microsoft.com/office/drawing/2014/main" id="{4CA3CE9F-ECE3-8EB7-59D0-A1FA811D4900}"/>
+                  <a16:creationId xmlns:a16="http://schemas.microsoft.com/office/drawing/2014/main" id="{7056757C-3DA4-07AC-AE05-7B63D5AC9C05}"/>
                 </a:ext>
               </a:extLst>
             </p:cNvPr>
@@ -17805,7 +17805,7 @@
             <p:cNvPr id="9" name="Forma Livre: Forma 8">
               <a:extLst>
                 <a:ext uri="{FF2B5EF4-FFF2-40B4-BE49-F238E27FC236}">
-                  <a16:creationId xmlns:a16="http://schemas.microsoft.com/office/drawing/2014/main" id="{EA0F9C8D-43D8-9BED-ACF2-26E2E5CF2733}"/>
+                  <a16:creationId xmlns:a16="http://schemas.microsoft.com/office/drawing/2014/main" id="{A60516A6-1561-C255-06F4-D58AE21B916C}"/>
                 </a:ext>
               </a:extLst>
             </p:cNvPr>
@@ -17876,7 +17876,7 @@
             <p:cNvPr id="10" name="Forma Livre: Forma 9">
               <a:extLst>
                 <a:ext uri="{FF2B5EF4-FFF2-40B4-BE49-F238E27FC236}">
-                  <a16:creationId xmlns:a16="http://schemas.microsoft.com/office/drawing/2014/main" id="{5261B891-2EB2-E711-26D7-16EE238AE75B}"/>
+                  <a16:creationId xmlns:a16="http://schemas.microsoft.com/office/drawing/2014/main" id="{15ABDC93-7C4A-EA1F-E2A9-CE987BB7136D}"/>
                 </a:ext>
               </a:extLst>
             </p:cNvPr>
@@ -17947,7 +17947,7 @@
             <p:cNvPr id="11" name="Retângulo: Cantos Arredondados 10">
               <a:extLst>
                 <a:ext uri="{FF2B5EF4-FFF2-40B4-BE49-F238E27FC236}">
-                  <a16:creationId xmlns:a16="http://schemas.microsoft.com/office/drawing/2014/main" id="{598A6783-30B0-647D-1CF6-57E750CA3FA8}"/>
+                  <a16:creationId xmlns:a16="http://schemas.microsoft.com/office/drawing/2014/main" id="{1534AAAA-E413-34EE-14C4-B11120861B33}"/>
                 </a:ext>
               </a:extLst>
             </p:cNvPr>
@@ -18019,7 +18019,7 @@
             <p:cNvPr id="12" name="Retângulo: Cantos Arredondados 11">
               <a:extLst>
                 <a:ext uri="{FF2B5EF4-FFF2-40B4-BE49-F238E27FC236}">
-                  <a16:creationId xmlns:a16="http://schemas.microsoft.com/office/drawing/2014/main" id="{2EF2D678-FBA0-5E2A-94BD-E8E8289108CE}"/>
+                  <a16:creationId xmlns:a16="http://schemas.microsoft.com/office/drawing/2014/main" id="{432BE046-D63C-AD22-1190-77AA5D13B12C}"/>
                 </a:ext>
               </a:extLst>
             </p:cNvPr>
@@ -18091,7 +18091,7 @@
             <p:cNvPr id="13" name="Retângulo: Cantos Arredondados 12">
               <a:extLst>
                 <a:ext uri="{FF2B5EF4-FFF2-40B4-BE49-F238E27FC236}">
-                  <a16:creationId xmlns:a16="http://schemas.microsoft.com/office/drawing/2014/main" id="{53390427-3BF9-4EB6-C096-8213AB7298F6}"/>
+                  <a16:creationId xmlns:a16="http://schemas.microsoft.com/office/drawing/2014/main" id="{C4F088D2-55A9-36EC-ED2D-1F854136004B}"/>
                 </a:ext>
               </a:extLst>
             </p:cNvPr>
@@ -18163,7 +18163,7 @@
             <p:cNvPr id="14" name="Retângulo: Cantos Arredondados 13">
               <a:extLst>
                 <a:ext uri="{FF2B5EF4-FFF2-40B4-BE49-F238E27FC236}">
-                  <a16:creationId xmlns:a16="http://schemas.microsoft.com/office/drawing/2014/main" id="{473A8114-138A-BA29-0213-A97BF9285E71}"/>
+                  <a16:creationId xmlns:a16="http://schemas.microsoft.com/office/drawing/2014/main" id="{102F2AE9-7AEF-9626-360F-194C86FDA74F}"/>
                 </a:ext>
               </a:extLst>
             </p:cNvPr>
@@ -18235,7 +18235,7 @@
             <p:cNvPr id="15" name="Retângulo: Cantos Arredondados 14">
               <a:extLst>
                 <a:ext uri="{FF2B5EF4-FFF2-40B4-BE49-F238E27FC236}">
-                  <a16:creationId xmlns:a16="http://schemas.microsoft.com/office/drawing/2014/main" id="{3BBFE925-554F-2359-2383-0CBFED5EA7C6}"/>
+                  <a16:creationId xmlns:a16="http://schemas.microsoft.com/office/drawing/2014/main" id="{7FC66229-21AD-6D9D-A36F-B481F4CDEB6F}"/>
                 </a:ext>
               </a:extLst>
             </p:cNvPr>
@@ -18307,7 +18307,7 @@
             <p:cNvPr id="16" name="Retângulo: Cantos Arredondados 15">
               <a:extLst>
                 <a:ext uri="{FF2B5EF4-FFF2-40B4-BE49-F238E27FC236}">
-                  <a16:creationId xmlns:a16="http://schemas.microsoft.com/office/drawing/2014/main" id="{FF198F2E-E9A9-61F8-0E2B-3F007D68D089}"/>
+                  <a16:creationId xmlns:a16="http://schemas.microsoft.com/office/drawing/2014/main" id="{62A5E104-9045-9772-AF44-330AC4FA53FA}"/>
                 </a:ext>
               </a:extLst>
             </p:cNvPr>
@@ -18369,7 +18369,7 @@
             <p:cNvPr id="17" name="CaixaDeTexto 16">
               <a:extLst>
                 <a:ext uri="{FF2B5EF4-FFF2-40B4-BE49-F238E27FC236}">
-                  <a16:creationId xmlns:a16="http://schemas.microsoft.com/office/drawing/2014/main" id="{47FD2B33-EFFA-A756-97AE-D420F62ECF0D}"/>
+                  <a16:creationId xmlns:a16="http://schemas.microsoft.com/office/drawing/2014/main" id="{C55A5637-6791-EF29-0EA7-4D2E08835606}"/>
                 </a:ext>
               </a:extLst>
             </p:cNvPr>
@@ -18414,7 +18414,7 @@
             <p:cNvPr id="18" name="CaixaDeTexto 17">
               <a:extLst>
                 <a:ext uri="{FF2B5EF4-FFF2-40B4-BE49-F238E27FC236}">
-                  <a16:creationId xmlns:a16="http://schemas.microsoft.com/office/drawing/2014/main" id="{82AC80D3-359D-7332-163D-20A1851FE49F}"/>
+                  <a16:creationId xmlns:a16="http://schemas.microsoft.com/office/drawing/2014/main" id="{80995BAF-5F1A-DBBE-F392-01B0CC47A9ED}"/>
                 </a:ext>
               </a:extLst>
             </p:cNvPr>
@@ -18459,7 +18459,7 @@
             <p:cNvPr id="19" name="Conector reto 18">
               <a:extLst>
                 <a:ext uri="{FF2B5EF4-FFF2-40B4-BE49-F238E27FC236}">
-                  <a16:creationId xmlns:a16="http://schemas.microsoft.com/office/drawing/2014/main" id="{08584888-C504-0B1E-629F-956574E11D5A}"/>
+                  <a16:creationId xmlns:a16="http://schemas.microsoft.com/office/drawing/2014/main" id="{A95F5FAD-475A-9A5A-F2F5-B628D66BFF76}"/>
                 </a:ext>
               </a:extLst>
             </p:cNvPr>
@@ -18506,7 +18506,7 @@
             <p:cNvPr id="20" name="Elipse 19">
               <a:extLst>
                 <a:ext uri="{FF2B5EF4-FFF2-40B4-BE49-F238E27FC236}">
-                  <a16:creationId xmlns:a16="http://schemas.microsoft.com/office/drawing/2014/main" id="{4B3323E0-2B9F-82E9-AC91-56330DF2B6DB}"/>
+                  <a16:creationId xmlns:a16="http://schemas.microsoft.com/office/drawing/2014/main" id="{EB7E2851-2DC7-1B39-D2D9-3F7122118C61}"/>
                 </a:ext>
               </a:extLst>
             </p:cNvPr>
@@ -18574,7 +18574,7 @@
             <p:cNvPr id="21" name="Retângulo: Cantos Arredondados 20">
               <a:extLst>
                 <a:ext uri="{FF2B5EF4-FFF2-40B4-BE49-F238E27FC236}">
-                  <a16:creationId xmlns:a16="http://schemas.microsoft.com/office/drawing/2014/main" id="{8E1598A5-E7EB-4B16-6900-67257485E564}"/>
+                  <a16:creationId xmlns:a16="http://schemas.microsoft.com/office/drawing/2014/main" id="{68199C09-88B2-40B4-B8FB-0D8ADFDB9437}"/>
                 </a:ext>
               </a:extLst>
             </p:cNvPr>
@@ -18653,7 +18653,7 @@
           <p:cNvPr id="23" name="CaixaDeTexto 22">
             <a:extLst>
               <a:ext uri="{FF2B5EF4-FFF2-40B4-BE49-F238E27FC236}">
-                <a16:creationId xmlns:a16="http://schemas.microsoft.com/office/drawing/2014/main" id="{D6C25BC9-AEA9-87EB-3834-FDE91E940869}"/>
+                <a16:creationId xmlns:a16="http://schemas.microsoft.com/office/drawing/2014/main" id="{0C37474D-A524-5626-8B68-ADF0D476A90B}"/>
               </a:ext>
             </a:extLst>
           </p:cNvPr>
@@ -18688,7 +18688,16 @@
                 </a:solidFill>
                 <a:latin typeface="Instrument Sans Medium" pitchFamily="2" charset="0"/>
               </a:rPr>
-              <a:t>Você conhece seu negócio; nós conhecemos tecnologia.</a:t>
+              <a:t>Você conhece seu negócio;</a:t>
+            </a:r>
+            <a:r>
+              <a:rPr lang="pt-BR" sz="1400">
+                <a:solidFill>
+                  <a:srgbClr val="9BA1A6"/>
+                </a:solidFill>
+                <a:latin typeface="Instrument Sans Medium" pitchFamily="2" charset="0"/>
+              </a:rPr>
+              <a:t> nós conhecemos tecnologia.</a:t>
             </a:r>
           </a:p>
         </p:txBody>
@@ -18698,7 +18707,7 @@
           <p:cNvPr id="24" name="Conector reto 23">
             <a:extLst>
               <a:ext uri="{FF2B5EF4-FFF2-40B4-BE49-F238E27FC236}">
-                <a16:creationId xmlns:a16="http://schemas.microsoft.com/office/drawing/2014/main" id="{794384EF-8D72-06DC-3A39-18B86420FB26}"/>
+                <a16:creationId xmlns:a16="http://schemas.microsoft.com/office/drawing/2014/main" id="{F9048276-DE6E-901F-90A4-3A3C0DCA1F02}"/>
               </a:ext>
             </a:extLst>
           </p:cNvPr>
@@ -18745,7 +18754,7 @@
           <p:cNvPr id="25" name="Conector reto 24">
             <a:extLst>
               <a:ext uri="{FF2B5EF4-FFF2-40B4-BE49-F238E27FC236}">
-                <a16:creationId xmlns:a16="http://schemas.microsoft.com/office/drawing/2014/main" id="{9ACE9E08-64DB-B69E-F607-640FD2601690}"/>
+                <a16:creationId xmlns:a16="http://schemas.microsoft.com/office/drawing/2014/main" id="{3E005A4A-3C3D-56E7-E70E-79CA73A36523}"/>
               </a:ext>
             </a:extLst>
           </p:cNvPr>
@@ -18790,7 +18799,7 @@
           <p:cNvPr id="26" name="Elipse 25">
             <a:extLst>
               <a:ext uri="{FF2B5EF4-FFF2-40B4-BE49-F238E27FC236}">
-                <a16:creationId xmlns:a16="http://schemas.microsoft.com/office/drawing/2014/main" id="{2D0AE428-F28C-3943-6A20-EA43A75471B3}"/>
+                <a16:creationId xmlns:a16="http://schemas.microsoft.com/office/drawing/2014/main" id="{8F497935-7398-604B-942D-ABF1BEDBFF66}"/>
               </a:ext>
             </a:extLst>
           </p:cNvPr>
@@ -18858,7 +18867,7 @@
           <p:cNvPr id="27" name="CaixaDeTexto 26">
             <a:extLst>
               <a:ext uri="{FF2B5EF4-FFF2-40B4-BE49-F238E27FC236}">
-                <a16:creationId xmlns:a16="http://schemas.microsoft.com/office/drawing/2014/main" id="{120D5758-BD66-9737-47AF-BF98AA529B88}"/>
+                <a16:creationId xmlns:a16="http://schemas.microsoft.com/office/drawing/2014/main" id="{91908CCB-A4F9-1C8F-D932-067AFD881E92}"/>
               </a:ext>
             </a:extLst>
           </p:cNvPr>
@@ -18901,7 +18910,7 @@
     </p:spTree>
     <p:extLst>
       <p:ext uri="{BB962C8B-B14F-4D97-AF65-F5344CB8AC3E}">
-        <p14:creationId xmlns:p14="http://schemas.microsoft.com/office/powerpoint/2010/main" val="2296775802"/>
+        <p14:creationId xmlns:p14="http://schemas.microsoft.com/office/powerpoint/2010/main" val="4018607175"/>
       </p:ext>
     </p:extLst>
   </p:cSld>
@@ -19112,7 +19121,7 @@
           <p:cNvPr id="5" name="Agrupar 4">
             <a:extLst>
               <a:ext uri="{FF2B5EF4-FFF2-40B4-BE49-F238E27FC236}">
-                <a16:creationId xmlns:a16="http://schemas.microsoft.com/office/drawing/2014/main" id="{72EBEDC5-4CED-C4F3-9981-3FD37A1C2FA5}"/>
+                <a16:creationId xmlns:a16="http://schemas.microsoft.com/office/drawing/2014/main" id="{C50AF743-07E1-238A-4DB3-7550F2FC844D}"/>
               </a:ext>
             </a:extLst>
           </p:cNvPr>
@@ -19132,7 +19141,7 @@
             <p:cNvPr id="2" name="CaixaDeTexto 1">
               <a:extLst>
                 <a:ext uri="{FF2B5EF4-FFF2-40B4-BE49-F238E27FC236}">
-                  <a16:creationId xmlns:a16="http://schemas.microsoft.com/office/drawing/2014/main" id="{326A3D60-D501-2FD2-B9F0-1F26370AD053}"/>
+                  <a16:creationId xmlns:a16="http://schemas.microsoft.com/office/drawing/2014/main" id="{B11CA0F4-7D42-5A0C-9868-31FD10E61991}"/>
                 </a:ext>
               </a:extLst>
             </p:cNvPr>
@@ -19186,7 +19195,7 @@
             <p:cNvPr id="3" name="CaixaDeTexto 2">
               <a:extLst>
                 <a:ext uri="{FF2B5EF4-FFF2-40B4-BE49-F238E27FC236}">
-                  <a16:creationId xmlns:a16="http://schemas.microsoft.com/office/drawing/2014/main" id="{FBDA0B3E-1A6D-2BD7-7BED-D615FFAD7247}"/>
+                  <a16:creationId xmlns:a16="http://schemas.microsoft.com/office/drawing/2014/main" id="{9EB9B944-CB9E-FED5-994C-65E78BC63938}"/>
                 </a:ext>
               </a:extLst>
             </p:cNvPr>
@@ -19231,7 +19240,7 @@
             <p:cNvPr id="4" name="CaixaDeTexto 3">
               <a:extLst>
                 <a:ext uri="{FF2B5EF4-FFF2-40B4-BE49-F238E27FC236}">
-                  <a16:creationId xmlns:a16="http://schemas.microsoft.com/office/drawing/2014/main" id="{0C057885-D483-E7EB-879C-62199DC7C633}"/>
+                  <a16:creationId xmlns:a16="http://schemas.microsoft.com/office/drawing/2014/main" id="{363025E2-DE63-9C43-3465-49408DEF2C8B}"/>
                 </a:ext>
               </a:extLst>
             </p:cNvPr>
@@ -19295,7 +19304,7 @@
           <p:cNvPr id="26" name="Agrupar 25">
             <a:extLst>
               <a:ext uri="{FF2B5EF4-FFF2-40B4-BE49-F238E27FC236}">
-                <a16:creationId xmlns:a16="http://schemas.microsoft.com/office/drawing/2014/main" id="{06FAA94B-85B5-D49C-4345-7BA092F9DD0C}"/>
+                <a16:creationId xmlns:a16="http://schemas.microsoft.com/office/drawing/2014/main" id="{23A112C4-29C3-9C49-825B-6E66C2FDF2EF}"/>
               </a:ext>
             </a:extLst>
           </p:cNvPr>
@@ -19315,7 +19324,7 @@
             <p:cNvPr id="6" name="Elipse 5">
               <a:extLst>
                 <a:ext uri="{FF2B5EF4-FFF2-40B4-BE49-F238E27FC236}">
-                  <a16:creationId xmlns:a16="http://schemas.microsoft.com/office/drawing/2014/main" id="{97CB11A8-13B1-A4F7-E665-8F1C26657FBD}"/>
+                  <a16:creationId xmlns:a16="http://schemas.microsoft.com/office/drawing/2014/main" id="{8BE65F02-E782-4E8C-3ADD-D4EED7FF9274}"/>
                 </a:ext>
               </a:extLst>
             </p:cNvPr>
@@ -19383,7 +19392,7 @@
             <p:cNvPr id="7" name="Conector reto 6">
               <a:extLst>
                 <a:ext uri="{FF2B5EF4-FFF2-40B4-BE49-F238E27FC236}">
-                  <a16:creationId xmlns:a16="http://schemas.microsoft.com/office/drawing/2014/main" id="{3ABAE398-4190-11FA-4223-3A2EDCEEB4B7}"/>
+                  <a16:creationId xmlns:a16="http://schemas.microsoft.com/office/drawing/2014/main" id="{05BE585B-279B-708F-5111-F8B5899D09ED}"/>
                 </a:ext>
               </a:extLst>
             </p:cNvPr>
@@ -19430,7 +19439,7 @@
             <p:cNvPr id="8" name="Conector reto 7">
               <a:extLst>
                 <a:ext uri="{FF2B5EF4-FFF2-40B4-BE49-F238E27FC236}">
-                  <a16:creationId xmlns:a16="http://schemas.microsoft.com/office/drawing/2014/main" id="{05794715-0100-5EA1-7F4F-457FB8CA8CE1}"/>
+                  <a16:creationId xmlns:a16="http://schemas.microsoft.com/office/drawing/2014/main" id="{0084ECAA-5620-A2E8-88FB-5B7491A57F0D}"/>
                 </a:ext>
               </a:extLst>
             </p:cNvPr>
@@ -19477,7 +19486,7 @@
             <p:cNvPr id="9" name="Conector reto 8">
               <a:extLst>
                 <a:ext uri="{FF2B5EF4-FFF2-40B4-BE49-F238E27FC236}">
-                  <a16:creationId xmlns:a16="http://schemas.microsoft.com/office/drawing/2014/main" id="{F4E0D399-332F-C87A-DDC2-E70EEDF5805A}"/>
+                  <a16:creationId xmlns:a16="http://schemas.microsoft.com/office/drawing/2014/main" id="{8B1C407E-D28E-4B54-EDCE-EF02223265B3}"/>
                 </a:ext>
               </a:extLst>
             </p:cNvPr>
@@ -19524,7 +19533,7 @@
             <p:cNvPr id="10" name="Conector reto 9">
               <a:extLst>
                 <a:ext uri="{FF2B5EF4-FFF2-40B4-BE49-F238E27FC236}">
-                  <a16:creationId xmlns:a16="http://schemas.microsoft.com/office/drawing/2014/main" id="{D05D7CD0-90D4-D103-2472-7719EE4A061A}"/>
+                  <a16:creationId xmlns:a16="http://schemas.microsoft.com/office/drawing/2014/main" id="{1CF84190-FCF1-62B7-8E48-0CB5F9D32C59}"/>
                 </a:ext>
               </a:extLst>
             </p:cNvPr>
@@ -19571,7 +19580,7 @@
             <p:cNvPr id="11" name="Conector reto 10">
               <a:extLst>
                 <a:ext uri="{FF2B5EF4-FFF2-40B4-BE49-F238E27FC236}">
-                  <a16:creationId xmlns:a16="http://schemas.microsoft.com/office/drawing/2014/main" id="{3FE55DF4-8B6B-43BC-74B4-A994D64FE9B0}"/>
+                  <a16:creationId xmlns:a16="http://schemas.microsoft.com/office/drawing/2014/main" id="{6A7792FB-FF2B-AA3F-6679-751D6D2992FE}"/>
                 </a:ext>
               </a:extLst>
             </p:cNvPr>
@@ -19618,7 +19627,7 @@
             <p:cNvPr id="12" name="Conector reto 11">
               <a:extLst>
                 <a:ext uri="{FF2B5EF4-FFF2-40B4-BE49-F238E27FC236}">
-                  <a16:creationId xmlns:a16="http://schemas.microsoft.com/office/drawing/2014/main" id="{704DC3E9-2E4A-20B1-19B6-944C4C177BB4}"/>
+                  <a16:creationId xmlns:a16="http://schemas.microsoft.com/office/drawing/2014/main" id="{23589C01-3686-248D-B280-9F2FDF318E2D}"/>
                 </a:ext>
               </a:extLst>
             </p:cNvPr>
@@ -19665,7 +19674,7 @@
             <p:cNvPr id="13" name="Conector reto 12">
               <a:extLst>
                 <a:ext uri="{FF2B5EF4-FFF2-40B4-BE49-F238E27FC236}">
-                  <a16:creationId xmlns:a16="http://schemas.microsoft.com/office/drawing/2014/main" id="{26BA1B85-8C5B-C232-E0CA-FE20E6EBF68E}"/>
+                  <a16:creationId xmlns:a16="http://schemas.microsoft.com/office/drawing/2014/main" id="{08155048-0313-9FF4-4A00-231F9789EF62}"/>
                 </a:ext>
               </a:extLst>
             </p:cNvPr>
@@ -19712,7 +19721,7 @@
             <p:cNvPr id="14" name="Conector reto 13">
               <a:extLst>
                 <a:ext uri="{FF2B5EF4-FFF2-40B4-BE49-F238E27FC236}">
-                  <a16:creationId xmlns:a16="http://schemas.microsoft.com/office/drawing/2014/main" id="{CC9A1781-ED71-9D19-EF3B-0B5436B7756B}"/>
+                  <a16:creationId xmlns:a16="http://schemas.microsoft.com/office/drawing/2014/main" id="{9AAD02B6-175A-0496-417E-D395A40D98F6}"/>
                 </a:ext>
               </a:extLst>
             </p:cNvPr>
@@ -19759,7 +19768,7 @@
             <p:cNvPr id="15" name="Elipse 14">
               <a:extLst>
                 <a:ext uri="{FF2B5EF4-FFF2-40B4-BE49-F238E27FC236}">
-                  <a16:creationId xmlns:a16="http://schemas.microsoft.com/office/drawing/2014/main" id="{93245A5A-01DF-DB41-EF39-23810821F1CC}"/>
+                  <a16:creationId xmlns:a16="http://schemas.microsoft.com/office/drawing/2014/main" id="{2248F046-58CE-BC88-332A-55A4DA6E917A}"/>
                 </a:ext>
               </a:extLst>
             </p:cNvPr>
@@ -19827,7 +19836,7 @@
             <p:cNvPr id="16" name="Retângulo: Cantos Arredondados 15">
               <a:extLst>
                 <a:ext uri="{FF2B5EF4-FFF2-40B4-BE49-F238E27FC236}">
-                  <a16:creationId xmlns:a16="http://schemas.microsoft.com/office/drawing/2014/main" id="{D394E640-7CD8-8837-C6E0-69DF4AB6B84A}"/>
+                  <a16:creationId xmlns:a16="http://schemas.microsoft.com/office/drawing/2014/main" id="{F355B83C-1239-D19D-D770-2771A3A75A23}"/>
                 </a:ext>
               </a:extLst>
             </p:cNvPr>
@@ -19899,7 +19908,7 @@
             <p:cNvPr id="17" name="Retângulo: Cantos Arredondados 16">
               <a:extLst>
                 <a:ext uri="{FF2B5EF4-FFF2-40B4-BE49-F238E27FC236}">
-                  <a16:creationId xmlns:a16="http://schemas.microsoft.com/office/drawing/2014/main" id="{1F5EC1F5-2D69-DE01-527C-59A339F40A84}"/>
+                  <a16:creationId xmlns:a16="http://schemas.microsoft.com/office/drawing/2014/main" id="{A9D3670F-7FCB-0E3B-F423-16A9AC3112E9}"/>
                 </a:ext>
               </a:extLst>
             </p:cNvPr>
@@ -19971,7 +19980,7 @@
             <p:cNvPr id="18" name="Retângulo: Cantos Arredondados 17">
               <a:extLst>
                 <a:ext uri="{FF2B5EF4-FFF2-40B4-BE49-F238E27FC236}">
-                  <a16:creationId xmlns:a16="http://schemas.microsoft.com/office/drawing/2014/main" id="{C5988DE8-9B68-F56E-C2EC-1F946FD276AE}"/>
+                  <a16:creationId xmlns:a16="http://schemas.microsoft.com/office/drawing/2014/main" id="{CD1F98D1-31E1-90EA-A6E3-9B8B2FA1067E}"/>
                 </a:ext>
               </a:extLst>
             </p:cNvPr>
@@ -20043,7 +20052,7 @@
             <p:cNvPr id="19" name="Retângulo: Cantos Arredondados 18">
               <a:extLst>
                 <a:ext uri="{FF2B5EF4-FFF2-40B4-BE49-F238E27FC236}">
-                  <a16:creationId xmlns:a16="http://schemas.microsoft.com/office/drawing/2014/main" id="{10BC62BF-C885-55C0-D468-C3143C123DE4}"/>
+                  <a16:creationId xmlns:a16="http://schemas.microsoft.com/office/drawing/2014/main" id="{FD81977D-9E60-AD2F-5CD2-0D7906779DB3}"/>
                 </a:ext>
               </a:extLst>
             </p:cNvPr>
@@ -20115,7 +20124,7 @@
             <p:cNvPr id="20" name="Retângulo: Cantos Arredondados 19">
               <a:extLst>
                 <a:ext uri="{FF2B5EF4-FFF2-40B4-BE49-F238E27FC236}">
-                  <a16:creationId xmlns:a16="http://schemas.microsoft.com/office/drawing/2014/main" id="{B738FEDB-AA20-BDAC-6C67-1C71488598A0}"/>
+                  <a16:creationId xmlns:a16="http://schemas.microsoft.com/office/drawing/2014/main" id="{025804F2-79F4-D2B8-4721-7E09802CD7F1}"/>
                 </a:ext>
               </a:extLst>
             </p:cNvPr>
@@ -20187,7 +20196,7 @@
             <p:cNvPr id="21" name="Retângulo: Cantos Arredondados 20">
               <a:extLst>
                 <a:ext uri="{FF2B5EF4-FFF2-40B4-BE49-F238E27FC236}">
-                  <a16:creationId xmlns:a16="http://schemas.microsoft.com/office/drawing/2014/main" id="{1B0C69E4-82BD-56C3-6548-154FCB7303D7}"/>
+                  <a16:creationId xmlns:a16="http://schemas.microsoft.com/office/drawing/2014/main" id="{24BAC972-67E6-7363-9F89-FEC34AA44AE1}"/>
                 </a:ext>
               </a:extLst>
             </p:cNvPr>
@@ -20259,7 +20268,7 @@
             <p:cNvPr id="22" name="Elipse 21">
               <a:extLst>
                 <a:ext uri="{FF2B5EF4-FFF2-40B4-BE49-F238E27FC236}">
-                  <a16:creationId xmlns:a16="http://schemas.microsoft.com/office/drawing/2014/main" id="{C1E9C24A-94F9-4046-438C-15AF6BA999F3}"/>
+                  <a16:creationId xmlns:a16="http://schemas.microsoft.com/office/drawing/2014/main" id="{F016A4E9-0BFF-6D3A-A377-49BA3F6BF00A}"/>
                 </a:ext>
               </a:extLst>
             </p:cNvPr>
@@ -20317,7 +20326,7 @@
             <p:cNvPr id="23" name="CaixaDeTexto 22">
               <a:extLst>
                 <a:ext uri="{FF2B5EF4-FFF2-40B4-BE49-F238E27FC236}">
-                  <a16:creationId xmlns:a16="http://schemas.microsoft.com/office/drawing/2014/main" id="{8B99E90F-B1BC-9161-A6F3-2488CB2A035D}"/>
+                  <a16:creationId xmlns:a16="http://schemas.microsoft.com/office/drawing/2014/main" id="{4FE4AD53-BB8D-9454-20AB-1C4625563D6B}"/>
                 </a:ext>
               </a:extLst>
             </p:cNvPr>
@@ -20362,7 +20371,7 @@
             <p:cNvPr id="24" name="Retângulo: Cantos Arredondados 23">
               <a:extLst>
                 <a:ext uri="{FF2B5EF4-FFF2-40B4-BE49-F238E27FC236}">
-                  <a16:creationId xmlns:a16="http://schemas.microsoft.com/office/drawing/2014/main" id="{2B09E470-4ABC-2B0A-66A4-40B2B5691E98}"/>
+                  <a16:creationId xmlns:a16="http://schemas.microsoft.com/office/drawing/2014/main" id="{784C54D3-1646-C69D-49F1-2CF6D803E7BF}"/>
                 </a:ext>
               </a:extLst>
             </p:cNvPr>
@@ -20440,7 +20449,7 @@
             <p:cNvPr id="25" name="Retângulo: Cantos Arredondados 24">
               <a:extLst>
                 <a:ext uri="{FF2B5EF4-FFF2-40B4-BE49-F238E27FC236}">
-                  <a16:creationId xmlns:a16="http://schemas.microsoft.com/office/drawing/2014/main" id="{EA891FE2-2DBF-94DB-D343-F44D5026E2B4}"/>
+                  <a16:creationId xmlns:a16="http://schemas.microsoft.com/office/drawing/2014/main" id="{4D3339A8-9956-CAF4-A8A9-B207E6EC659B}"/>
                 </a:ext>
               </a:extLst>
             </p:cNvPr>
@@ -20519,7 +20528,7 @@
           <p:cNvPr id="27" name="CaixaDeTexto 26">
             <a:extLst>
               <a:ext uri="{FF2B5EF4-FFF2-40B4-BE49-F238E27FC236}">
-                <a16:creationId xmlns:a16="http://schemas.microsoft.com/office/drawing/2014/main" id="{E708FB4A-968A-5226-A301-8E1CD1BF88ED}"/>
+                <a16:creationId xmlns:a16="http://schemas.microsoft.com/office/drawing/2014/main" id="{FC92CDC8-DC4D-32ED-7024-4CEABE75C67D}"/>
               </a:ext>
             </a:extLst>
           </p:cNvPr>
@@ -20573,7 +20582,7 @@
           <p:cNvPr id="28" name="Conector reto 27">
             <a:extLst>
               <a:ext uri="{FF2B5EF4-FFF2-40B4-BE49-F238E27FC236}">
-                <a16:creationId xmlns:a16="http://schemas.microsoft.com/office/drawing/2014/main" id="{BF04C12C-2C32-4D46-A365-135390E92B88}"/>
+                <a16:creationId xmlns:a16="http://schemas.microsoft.com/office/drawing/2014/main" id="{3030D25D-BD31-EF6B-A510-0DC495618B7B}"/>
               </a:ext>
             </a:extLst>
           </p:cNvPr>
@@ -20620,7 +20629,7 @@
           <p:cNvPr id="29" name="Conector reto 28">
             <a:extLst>
               <a:ext uri="{FF2B5EF4-FFF2-40B4-BE49-F238E27FC236}">
-                <a16:creationId xmlns:a16="http://schemas.microsoft.com/office/drawing/2014/main" id="{B887F58B-34CD-9282-90D7-58C4455DDC97}"/>
+                <a16:creationId xmlns:a16="http://schemas.microsoft.com/office/drawing/2014/main" id="{861621E4-DA93-6E23-BE44-151EBA5EF29D}"/>
               </a:ext>
             </a:extLst>
           </p:cNvPr>
@@ -20665,7 +20674,7 @@
           <p:cNvPr id="30" name="Elipse 29">
             <a:extLst>
               <a:ext uri="{FF2B5EF4-FFF2-40B4-BE49-F238E27FC236}">
-                <a16:creationId xmlns:a16="http://schemas.microsoft.com/office/drawing/2014/main" id="{740DDD79-FAE4-6EAA-84C2-BEDF5148A3B3}"/>
+                <a16:creationId xmlns:a16="http://schemas.microsoft.com/office/drawing/2014/main" id="{39DDD2A9-908A-3A72-F6BE-EA756DB42D99}"/>
               </a:ext>
             </a:extLst>
           </p:cNvPr>
@@ -20733,7 +20742,7 @@
           <p:cNvPr id="31" name="CaixaDeTexto 30">
             <a:extLst>
               <a:ext uri="{FF2B5EF4-FFF2-40B4-BE49-F238E27FC236}">
-                <a16:creationId xmlns:a16="http://schemas.microsoft.com/office/drawing/2014/main" id="{D996F6DF-5B2A-E2E7-3895-1118C997748A}"/>
+                <a16:creationId xmlns:a16="http://schemas.microsoft.com/office/drawing/2014/main" id="{96378224-80F5-B3D5-7DEB-4CDE05DBCDD2}"/>
               </a:ext>
             </a:extLst>
           </p:cNvPr>
@@ -20776,7 +20785,7 @@
     </p:spTree>
     <p:extLst>
       <p:ext uri="{BB962C8B-B14F-4D97-AF65-F5344CB8AC3E}">
-        <p14:creationId xmlns:p14="http://schemas.microsoft.com/office/powerpoint/2010/main" val="2509500210"/>
+        <p14:creationId xmlns:p14="http://schemas.microsoft.com/office/powerpoint/2010/main" val="1046990821"/>
       </p:ext>
     </p:extLst>
   </p:cSld>
@@ -20987,7 +20996,7 @@
           <p:cNvPr id="2" name="CaixaDeTexto 1">
             <a:extLst>
               <a:ext uri="{FF2B5EF4-FFF2-40B4-BE49-F238E27FC236}">
-                <a16:creationId xmlns:a16="http://schemas.microsoft.com/office/drawing/2014/main" id="{EBDF4ECF-20D7-8929-C027-0A26C0E6EE41}"/>
+                <a16:creationId xmlns:a16="http://schemas.microsoft.com/office/drawing/2014/main" id="{47C4750D-8506-C1DE-6B82-1E9DC1186EAF}"/>
               </a:ext>
             </a:extLst>
           </p:cNvPr>
@@ -21032,7 +21041,7 @@
           <p:cNvPr id="3" name="CaixaDeTexto 2">
             <a:extLst>
               <a:ext uri="{FF2B5EF4-FFF2-40B4-BE49-F238E27FC236}">
-                <a16:creationId xmlns:a16="http://schemas.microsoft.com/office/drawing/2014/main" id="{5687AAEA-9FE7-A85D-9864-2876A5135C37}"/>
+                <a16:creationId xmlns:a16="http://schemas.microsoft.com/office/drawing/2014/main" id="{2F1E85AB-34CF-28A8-1B79-CF3DE6460474}"/>
               </a:ext>
             </a:extLst>
           </p:cNvPr>
@@ -21086,7 +21095,7 @@
           <p:cNvPr id="14" name="Agrupar 13">
             <a:extLst>
               <a:ext uri="{FF2B5EF4-FFF2-40B4-BE49-F238E27FC236}">
-                <a16:creationId xmlns:a16="http://schemas.microsoft.com/office/drawing/2014/main" id="{408BCE43-6806-9776-BDA8-E1DFBCF82162}"/>
+                <a16:creationId xmlns:a16="http://schemas.microsoft.com/office/drawing/2014/main" id="{BBEB2D66-BC3A-6097-A30C-B2EED280F734}"/>
               </a:ext>
             </a:extLst>
           </p:cNvPr>
@@ -21106,7 +21115,7 @@
             <p:cNvPr id="4" name="CaixaDeTexto 3">
               <a:extLst>
                 <a:ext uri="{FF2B5EF4-FFF2-40B4-BE49-F238E27FC236}">
-                  <a16:creationId xmlns:a16="http://schemas.microsoft.com/office/drawing/2014/main" id="{121E03B3-F807-971A-EA7E-26E274349872}"/>
+                  <a16:creationId xmlns:a16="http://schemas.microsoft.com/office/drawing/2014/main" id="{CBD744CE-B01D-A866-D16F-81EEC0F0A23C}"/>
                 </a:ext>
               </a:extLst>
             </p:cNvPr>
@@ -21151,7 +21160,7 @@
             <p:cNvPr id="5" name="Conector reto 4">
               <a:extLst>
                 <a:ext uri="{FF2B5EF4-FFF2-40B4-BE49-F238E27FC236}">
-                  <a16:creationId xmlns:a16="http://schemas.microsoft.com/office/drawing/2014/main" id="{101248E1-3EFC-D99F-54EF-6DE56054C333}"/>
+                  <a16:creationId xmlns:a16="http://schemas.microsoft.com/office/drawing/2014/main" id="{D1634716-8927-0545-A8B8-3F0F1429697B}"/>
                 </a:ext>
               </a:extLst>
             </p:cNvPr>
@@ -21198,7 +21207,7 @@
             <p:cNvPr id="6" name="Elipse 5">
               <a:extLst>
                 <a:ext uri="{FF2B5EF4-FFF2-40B4-BE49-F238E27FC236}">
-                  <a16:creationId xmlns:a16="http://schemas.microsoft.com/office/drawing/2014/main" id="{49541685-1389-2012-FF82-79FDC8A7BECA}"/>
+                  <a16:creationId xmlns:a16="http://schemas.microsoft.com/office/drawing/2014/main" id="{69353E36-D674-C334-7E39-5AF664DCC89B}"/>
                 </a:ext>
               </a:extLst>
             </p:cNvPr>
@@ -21256,7 +21265,7 @@
             <p:cNvPr id="7" name="CaixaDeTexto 6">
               <a:extLst>
                 <a:ext uri="{FF2B5EF4-FFF2-40B4-BE49-F238E27FC236}">
-                  <a16:creationId xmlns:a16="http://schemas.microsoft.com/office/drawing/2014/main" id="{8F7B6BC8-5785-03FF-4605-820B7500074D}"/>
+                  <a16:creationId xmlns:a16="http://schemas.microsoft.com/office/drawing/2014/main" id="{266406D6-4FA9-AC04-95F4-61CDAE70D7A0}"/>
                 </a:ext>
               </a:extLst>
             </p:cNvPr>
@@ -21301,7 +21310,7 @@
             <p:cNvPr id="8" name="Elipse 7">
               <a:extLst>
                 <a:ext uri="{FF2B5EF4-FFF2-40B4-BE49-F238E27FC236}">
-                  <a16:creationId xmlns:a16="http://schemas.microsoft.com/office/drawing/2014/main" id="{EA6D4A62-8B0C-134A-7DF9-AA4C0D2BE439}"/>
+                  <a16:creationId xmlns:a16="http://schemas.microsoft.com/office/drawing/2014/main" id="{28197FBD-C288-F234-7446-3BC32C9A54F8}"/>
                 </a:ext>
               </a:extLst>
             </p:cNvPr>
@@ -21359,7 +21368,7 @@
             <p:cNvPr id="9" name="CaixaDeTexto 8">
               <a:extLst>
                 <a:ext uri="{FF2B5EF4-FFF2-40B4-BE49-F238E27FC236}">
-                  <a16:creationId xmlns:a16="http://schemas.microsoft.com/office/drawing/2014/main" id="{83972117-56D0-7DA6-24DB-CF9D83853199}"/>
+                  <a16:creationId xmlns:a16="http://schemas.microsoft.com/office/drawing/2014/main" id="{3FC99380-5930-5645-9DA4-B0AFBD7B0BD4}"/>
                 </a:ext>
               </a:extLst>
             </p:cNvPr>
@@ -21404,7 +21413,7 @@
             <p:cNvPr id="10" name="Elipse 9">
               <a:extLst>
                 <a:ext uri="{FF2B5EF4-FFF2-40B4-BE49-F238E27FC236}">
-                  <a16:creationId xmlns:a16="http://schemas.microsoft.com/office/drawing/2014/main" id="{6C1F6D2F-4B64-3126-5DC1-52B357992D65}"/>
+                  <a16:creationId xmlns:a16="http://schemas.microsoft.com/office/drawing/2014/main" id="{6C11F649-4042-AC9B-0231-355C2D643CE4}"/>
                 </a:ext>
               </a:extLst>
             </p:cNvPr>
@@ -21462,7 +21471,7 @@
             <p:cNvPr id="11" name="CaixaDeTexto 10">
               <a:extLst>
                 <a:ext uri="{FF2B5EF4-FFF2-40B4-BE49-F238E27FC236}">
-                  <a16:creationId xmlns:a16="http://schemas.microsoft.com/office/drawing/2014/main" id="{E9F70E61-22F3-2C2C-C924-D44277A8CE1F}"/>
+                  <a16:creationId xmlns:a16="http://schemas.microsoft.com/office/drawing/2014/main" id="{09CE0910-0814-EEA8-A586-3867BF5D641F}"/>
                 </a:ext>
               </a:extLst>
             </p:cNvPr>
@@ -21507,7 +21516,7 @@
             <p:cNvPr id="12" name="Elipse 11">
               <a:extLst>
                 <a:ext uri="{FF2B5EF4-FFF2-40B4-BE49-F238E27FC236}">
-                  <a16:creationId xmlns:a16="http://schemas.microsoft.com/office/drawing/2014/main" id="{7705DBA8-92E7-9D1D-A4B4-57B2849B4C15}"/>
+                  <a16:creationId xmlns:a16="http://schemas.microsoft.com/office/drawing/2014/main" id="{2B186A2D-47AF-019A-6897-ADB5B84E11A1}"/>
                 </a:ext>
               </a:extLst>
             </p:cNvPr>
@@ -21575,7 +21584,7 @@
             <p:cNvPr id="13" name="CaixaDeTexto 12">
               <a:extLst>
                 <a:ext uri="{FF2B5EF4-FFF2-40B4-BE49-F238E27FC236}">
-                  <a16:creationId xmlns:a16="http://schemas.microsoft.com/office/drawing/2014/main" id="{7C19594D-63C5-397B-E336-4A08C0D4F4CA}"/>
+                  <a16:creationId xmlns:a16="http://schemas.microsoft.com/office/drawing/2014/main" id="{4CE74B7E-EACD-E6A3-8D70-84959E2EE5B2}"/>
                 </a:ext>
               </a:extLst>
             </p:cNvPr>
@@ -21621,7 +21630,7 @@
           <p:cNvPr id="25" name="Agrupar 24">
             <a:extLst>
               <a:ext uri="{FF2B5EF4-FFF2-40B4-BE49-F238E27FC236}">
-                <a16:creationId xmlns:a16="http://schemas.microsoft.com/office/drawing/2014/main" id="{4EB3FDA9-BBF5-B6E1-57EF-ADA507C36B1D}"/>
+                <a16:creationId xmlns:a16="http://schemas.microsoft.com/office/drawing/2014/main" id="{B3DE1A80-1792-313D-CCB9-668CA5B28AC2}"/>
               </a:ext>
             </a:extLst>
           </p:cNvPr>
@@ -21641,7 +21650,7 @@
             <p:cNvPr id="15" name="CaixaDeTexto 14">
               <a:extLst>
                 <a:ext uri="{FF2B5EF4-FFF2-40B4-BE49-F238E27FC236}">
-                  <a16:creationId xmlns:a16="http://schemas.microsoft.com/office/drawing/2014/main" id="{3B84DC44-6BFB-71A5-2C6C-5626E0C07CED}"/>
+                  <a16:creationId xmlns:a16="http://schemas.microsoft.com/office/drawing/2014/main" id="{CE8CA2E7-124B-87A5-FB58-CA17354527F7}"/>
                 </a:ext>
               </a:extLst>
             </p:cNvPr>
@@ -21686,7 +21695,7 @@
             <p:cNvPr id="16" name="Conector reto 15">
               <a:extLst>
                 <a:ext uri="{FF2B5EF4-FFF2-40B4-BE49-F238E27FC236}">
-                  <a16:creationId xmlns:a16="http://schemas.microsoft.com/office/drawing/2014/main" id="{B15B3A64-C44B-56A1-5DC8-66BAFE5D10B2}"/>
+                  <a16:creationId xmlns:a16="http://schemas.microsoft.com/office/drawing/2014/main" id="{56BAF09D-6BAB-D425-8B78-736F67A30280}"/>
                 </a:ext>
               </a:extLst>
             </p:cNvPr>
@@ -21733,7 +21742,7 @@
             <p:cNvPr id="17" name="Elipse 16">
               <a:extLst>
                 <a:ext uri="{FF2B5EF4-FFF2-40B4-BE49-F238E27FC236}">
-                  <a16:creationId xmlns:a16="http://schemas.microsoft.com/office/drawing/2014/main" id="{F7B2AE7E-416E-B31A-9BCD-F1A8E32EF3CC}"/>
+                  <a16:creationId xmlns:a16="http://schemas.microsoft.com/office/drawing/2014/main" id="{D26B860B-E41B-9B81-68CC-2A794FC7AC56}"/>
                 </a:ext>
               </a:extLst>
             </p:cNvPr>
@@ -21791,7 +21800,7 @@
             <p:cNvPr id="18" name="CaixaDeTexto 17">
               <a:extLst>
                 <a:ext uri="{FF2B5EF4-FFF2-40B4-BE49-F238E27FC236}">
-                  <a16:creationId xmlns:a16="http://schemas.microsoft.com/office/drawing/2014/main" id="{84FBC208-E7BA-0547-EB04-BD4092F2D5A1}"/>
+                  <a16:creationId xmlns:a16="http://schemas.microsoft.com/office/drawing/2014/main" id="{490EF872-4F02-C005-80E7-FBBBD7608605}"/>
                 </a:ext>
               </a:extLst>
             </p:cNvPr>
@@ -21836,7 +21845,7 @@
             <p:cNvPr id="19" name="Elipse 18">
               <a:extLst>
                 <a:ext uri="{FF2B5EF4-FFF2-40B4-BE49-F238E27FC236}">
-                  <a16:creationId xmlns:a16="http://schemas.microsoft.com/office/drawing/2014/main" id="{E83A0F39-2EC4-8221-E87E-AB188A8C0746}"/>
+                  <a16:creationId xmlns:a16="http://schemas.microsoft.com/office/drawing/2014/main" id="{330C911A-8BE0-CFBC-ED6B-DBE320599908}"/>
                 </a:ext>
               </a:extLst>
             </p:cNvPr>
@@ -21894,7 +21903,7 @@
             <p:cNvPr id="20" name="CaixaDeTexto 19">
               <a:extLst>
                 <a:ext uri="{FF2B5EF4-FFF2-40B4-BE49-F238E27FC236}">
-                  <a16:creationId xmlns:a16="http://schemas.microsoft.com/office/drawing/2014/main" id="{29056667-EC2D-A85D-B731-F06A0A20CD2D}"/>
+                  <a16:creationId xmlns:a16="http://schemas.microsoft.com/office/drawing/2014/main" id="{E8AC6C18-A3FE-E87C-2EBF-3A01024843AD}"/>
                 </a:ext>
               </a:extLst>
             </p:cNvPr>
@@ -21939,7 +21948,7 @@
             <p:cNvPr id="21" name="Elipse 20">
               <a:extLst>
                 <a:ext uri="{FF2B5EF4-FFF2-40B4-BE49-F238E27FC236}">
-                  <a16:creationId xmlns:a16="http://schemas.microsoft.com/office/drawing/2014/main" id="{107696CF-4391-5417-4863-A92C0E4EEA40}"/>
+                  <a16:creationId xmlns:a16="http://schemas.microsoft.com/office/drawing/2014/main" id="{17747D4B-6C3D-DABF-F0C6-34847FA76C96}"/>
                 </a:ext>
               </a:extLst>
             </p:cNvPr>
@@ -21997,7 +22006,7 @@
             <p:cNvPr id="22" name="CaixaDeTexto 21">
               <a:extLst>
                 <a:ext uri="{FF2B5EF4-FFF2-40B4-BE49-F238E27FC236}">
-                  <a16:creationId xmlns:a16="http://schemas.microsoft.com/office/drawing/2014/main" id="{FDFF265B-9412-1DD5-E98E-B3A83D209344}"/>
+                  <a16:creationId xmlns:a16="http://schemas.microsoft.com/office/drawing/2014/main" id="{D4C2E2F3-4B6F-0FE5-F9FF-2E649BEC2B81}"/>
                 </a:ext>
               </a:extLst>
             </p:cNvPr>
@@ -22042,7 +22051,7 @@
             <p:cNvPr id="23" name="Elipse 22">
               <a:extLst>
                 <a:ext uri="{FF2B5EF4-FFF2-40B4-BE49-F238E27FC236}">
-                  <a16:creationId xmlns:a16="http://schemas.microsoft.com/office/drawing/2014/main" id="{BDE5920D-6A27-BCE2-108F-71E2436CE255}"/>
+                  <a16:creationId xmlns:a16="http://schemas.microsoft.com/office/drawing/2014/main" id="{22A7C29F-2CC2-A74E-FE11-001565EF741C}"/>
                 </a:ext>
               </a:extLst>
             </p:cNvPr>
@@ -22110,7 +22119,7 @@
             <p:cNvPr id="24" name="CaixaDeTexto 23">
               <a:extLst>
                 <a:ext uri="{FF2B5EF4-FFF2-40B4-BE49-F238E27FC236}">
-                  <a16:creationId xmlns:a16="http://schemas.microsoft.com/office/drawing/2014/main" id="{4B2736AF-25AE-8BD7-392B-B5818FBC7767}"/>
+                  <a16:creationId xmlns:a16="http://schemas.microsoft.com/office/drawing/2014/main" id="{96EDC6E4-6074-BBB9-B586-388E81DD1D33}"/>
                 </a:ext>
               </a:extLst>
             </p:cNvPr>
@@ -22156,7 +22165,7 @@
           <p:cNvPr id="36" name="Agrupar 35">
             <a:extLst>
               <a:ext uri="{FF2B5EF4-FFF2-40B4-BE49-F238E27FC236}">
-                <a16:creationId xmlns:a16="http://schemas.microsoft.com/office/drawing/2014/main" id="{99DE2B92-A08A-A149-03AD-AFDF94D79918}"/>
+                <a16:creationId xmlns:a16="http://schemas.microsoft.com/office/drawing/2014/main" id="{AC077446-E95D-C818-3BCA-50C8211C517B}"/>
               </a:ext>
             </a:extLst>
           </p:cNvPr>
@@ -22176,7 +22185,7 @@
             <p:cNvPr id="26" name="CaixaDeTexto 25">
               <a:extLst>
                 <a:ext uri="{FF2B5EF4-FFF2-40B4-BE49-F238E27FC236}">
-                  <a16:creationId xmlns:a16="http://schemas.microsoft.com/office/drawing/2014/main" id="{B7860B93-6F32-5BC6-2440-B0BE54C303A3}"/>
+                  <a16:creationId xmlns:a16="http://schemas.microsoft.com/office/drawing/2014/main" id="{285D5DD6-58D2-3503-3ADE-8A576D876F88}"/>
                 </a:ext>
               </a:extLst>
             </p:cNvPr>
@@ -22221,7 +22230,7 @@
             <p:cNvPr id="27" name="Conector reto 26">
               <a:extLst>
                 <a:ext uri="{FF2B5EF4-FFF2-40B4-BE49-F238E27FC236}">
-                  <a16:creationId xmlns:a16="http://schemas.microsoft.com/office/drawing/2014/main" id="{63607EF0-2370-5EFB-3AF4-6D55001A735C}"/>
+                  <a16:creationId xmlns:a16="http://schemas.microsoft.com/office/drawing/2014/main" id="{D276B766-2416-43DA-6A12-8E83CAAF41A4}"/>
                 </a:ext>
               </a:extLst>
             </p:cNvPr>
@@ -22268,7 +22277,7 @@
             <p:cNvPr id="28" name="Elipse 27">
               <a:extLst>
                 <a:ext uri="{FF2B5EF4-FFF2-40B4-BE49-F238E27FC236}">
-                  <a16:creationId xmlns:a16="http://schemas.microsoft.com/office/drawing/2014/main" id="{9A9052A5-C357-C6FB-0501-29DD340A486E}"/>
+                  <a16:creationId xmlns:a16="http://schemas.microsoft.com/office/drawing/2014/main" id="{4E7FC3CE-4D30-EE08-69A6-8003AA2D165B}"/>
                 </a:ext>
               </a:extLst>
             </p:cNvPr>
@@ -22326,7 +22335,7 @@
             <p:cNvPr id="29" name="CaixaDeTexto 28">
               <a:extLst>
                 <a:ext uri="{FF2B5EF4-FFF2-40B4-BE49-F238E27FC236}">
-                  <a16:creationId xmlns:a16="http://schemas.microsoft.com/office/drawing/2014/main" id="{D147C383-29A5-E453-975C-6B60C47B3C3F}"/>
+                  <a16:creationId xmlns:a16="http://schemas.microsoft.com/office/drawing/2014/main" id="{2E20D4EE-E864-5591-196D-ADDD0B1C9FD3}"/>
                 </a:ext>
               </a:extLst>
             </p:cNvPr>
@@ -22371,7 +22380,7 @@
             <p:cNvPr id="30" name="Elipse 29">
               <a:extLst>
                 <a:ext uri="{FF2B5EF4-FFF2-40B4-BE49-F238E27FC236}">
-                  <a16:creationId xmlns:a16="http://schemas.microsoft.com/office/drawing/2014/main" id="{0E89E328-0614-4AB8-FD73-7E46417541B1}"/>
+                  <a16:creationId xmlns:a16="http://schemas.microsoft.com/office/drawing/2014/main" id="{9600BA20-E7C6-D86D-1913-2B282F91F21D}"/>
                 </a:ext>
               </a:extLst>
             </p:cNvPr>
@@ -22429,7 +22438,7 @@
             <p:cNvPr id="31" name="CaixaDeTexto 30">
               <a:extLst>
                 <a:ext uri="{FF2B5EF4-FFF2-40B4-BE49-F238E27FC236}">
-                  <a16:creationId xmlns:a16="http://schemas.microsoft.com/office/drawing/2014/main" id="{FE769D5A-4E65-CB28-EFD4-0EC15910D529}"/>
+                  <a16:creationId xmlns:a16="http://schemas.microsoft.com/office/drawing/2014/main" id="{A5C8B3FA-B813-6323-AD31-D714ACC89B8F}"/>
                 </a:ext>
               </a:extLst>
             </p:cNvPr>
@@ -22474,7 +22483,7 @@
             <p:cNvPr id="32" name="Elipse 31">
               <a:extLst>
                 <a:ext uri="{FF2B5EF4-FFF2-40B4-BE49-F238E27FC236}">
-                  <a16:creationId xmlns:a16="http://schemas.microsoft.com/office/drawing/2014/main" id="{1A8B704F-1DA2-BDF2-9A23-9120C34F399D}"/>
+                  <a16:creationId xmlns:a16="http://schemas.microsoft.com/office/drawing/2014/main" id="{DEB26218-BFD8-2472-501B-6E215FD74347}"/>
                 </a:ext>
               </a:extLst>
             </p:cNvPr>
@@ -22532,7 +22541,7 @@
             <p:cNvPr id="33" name="CaixaDeTexto 32">
               <a:extLst>
                 <a:ext uri="{FF2B5EF4-FFF2-40B4-BE49-F238E27FC236}">
-                  <a16:creationId xmlns:a16="http://schemas.microsoft.com/office/drawing/2014/main" id="{1486CD59-B4FD-4C00-4373-71ED3A8EB34F}"/>
+                  <a16:creationId xmlns:a16="http://schemas.microsoft.com/office/drawing/2014/main" id="{9670A9D6-DD1E-0A5D-B27E-F0AC75CB711E}"/>
                 </a:ext>
               </a:extLst>
             </p:cNvPr>
@@ -22577,7 +22586,7 @@
             <p:cNvPr id="34" name="Elipse 33">
               <a:extLst>
                 <a:ext uri="{FF2B5EF4-FFF2-40B4-BE49-F238E27FC236}">
-                  <a16:creationId xmlns:a16="http://schemas.microsoft.com/office/drawing/2014/main" id="{1173A857-CBAC-E48C-5E71-8712D0FDCD35}"/>
+                  <a16:creationId xmlns:a16="http://schemas.microsoft.com/office/drawing/2014/main" id="{6C872A25-B6B3-15ED-1B6D-1863004DC3DC}"/>
                 </a:ext>
               </a:extLst>
             </p:cNvPr>
@@ -22645,7 +22654,7 @@
             <p:cNvPr id="35" name="CaixaDeTexto 34">
               <a:extLst>
                 <a:ext uri="{FF2B5EF4-FFF2-40B4-BE49-F238E27FC236}">
-                  <a16:creationId xmlns:a16="http://schemas.microsoft.com/office/drawing/2014/main" id="{56B20372-BFBD-83FF-85F0-EC3EF14F5DFA}"/>
+                  <a16:creationId xmlns:a16="http://schemas.microsoft.com/office/drawing/2014/main" id="{BD91B3A7-E5F2-0815-6ED1-82B2E3608C60}"/>
                 </a:ext>
               </a:extLst>
             </p:cNvPr>
@@ -22691,7 +22700,7 @@
           <p:cNvPr id="37" name="Conector reto 36">
             <a:extLst>
               <a:ext uri="{FF2B5EF4-FFF2-40B4-BE49-F238E27FC236}">
-                <a16:creationId xmlns:a16="http://schemas.microsoft.com/office/drawing/2014/main" id="{55B8B814-A174-769B-3507-571119D42555}"/>
+                <a16:creationId xmlns:a16="http://schemas.microsoft.com/office/drawing/2014/main" id="{45944FAE-A4A7-1CDB-E3BF-A7F59C6DC924}"/>
               </a:ext>
             </a:extLst>
           </p:cNvPr>
@@ -22738,7 +22747,7 @@
           <p:cNvPr id="38" name="Conector reto 37">
             <a:extLst>
               <a:ext uri="{FF2B5EF4-FFF2-40B4-BE49-F238E27FC236}">
-                <a16:creationId xmlns:a16="http://schemas.microsoft.com/office/drawing/2014/main" id="{D27F91E3-3DEC-ACE3-5DF2-A7689A5C814B}"/>
+                <a16:creationId xmlns:a16="http://schemas.microsoft.com/office/drawing/2014/main" id="{6B291FE9-9E8C-311A-860C-B3BE75698BF8}"/>
               </a:ext>
             </a:extLst>
           </p:cNvPr>
@@ -22785,7 +22794,7 @@
           <p:cNvPr id="39" name="Conector reto 38">
             <a:extLst>
               <a:ext uri="{FF2B5EF4-FFF2-40B4-BE49-F238E27FC236}">
-                <a16:creationId xmlns:a16="http://schemas.microsoft.com/office/drawing/2014/main" id="{0D875FFE-DFF4-45B2-C923-4CAA78B62476}"/>
+                <a16:creationId xmlns:a16="http://schemas.microsoft.com/office/drawing/2014/main" id="{E1693F3C-6D92-6754-62BA-471E4DF94DD0}"/>
               </a:ext>
             </a:extLst>
           </p:cNvPr>
@@ -22832,7 +22841,7 @@
           <p:cNvPr id="40" name="Conector reto 39">
             <a:extLst>
               <a:ext uri="{FF2B5EF4-FFF2-40B4-BE49-F238E27FC236}">
-                <a16:creationId xmlns:a16="http://schemas.microsoft.com/office/drawing/2014/main" id="{2AD1415A-0456-D645-5028-1E8B1D0791E2}"/>
+                <a16:creationId xmlns:a16="http://schemas.microsoft.com/office/drawing/2014/main" id="{F8B08953-E220-B8D4-4C87-2150A4F10752}"/>
               </a:ext>
             </a:extLst>
           </p:cNvPr>
@@ -22877,7 +22886,7 @@
           <p:cNvPr id="41" name="Elipse 40">
             <a:extLst>
               <a:ext uri="{FF2B5EF4-FFF2-40B4-BE49-F238E27FC236}">
-                <a16:creationId xmlns:a16="http://schemas.microsoft.com/office/drawing/2014/main" id="{AF1144BF-15AD-F06D-5B3D-BD228B0E59F4}"/>
+                <a16:creationId xmlns:a16="http://schemas.microsoft.com/office/drawing/2014/main" id="{7F25A1EF-5545-EE1E-4F25-D91A6F3F3515}"/>
               </a:ext>
             </a:extLst>
           </p:cNvPr>
@@ -22945,7 +22954,7 @@
           <p:cNvPr id="42" name="CaixaDeTexto 41">
             <a:extLst>
               <a:ext uri="{FF2B5EF4-FFF2-40B4-BE49-F238E27FC236}">
-                <a16:creationId xmlns:a16="http://schemas.microsoft.com/office/drawing/2014/main" id="{86BC4329-306A-4B70-5FE2-78B91E23BC3F}"/>
+                <a16:creationId xmlns:a16="http://schemas.microsoft.com/office/drawing/2014/main" id="{0F5BE033-235E-4C8E-9ACD-CA0FC5B2DC29}"/>
               </a:ext>
             </a:extLst>
           </p:cNvPr>
@@ -22988,7 +22997,7 @@
     </p:spTree>
     <p:extLst>
       <p:ext uri="{BB962C8B-B14F-4D97-AF65-F5344CB8AC3E}">
-        <p14:creationId xmlns:p14="http://schemas.microsoft.com/office/powerpoint/2010/main" val="4234904729"/>
+        <p14:creationId xmlns:p14="http://schemas.microsoft.com/office/powerpoint/2010/main" val="2392848840"/>
       </p:ext>
     </p:extLst>
   </p:cSld>

</xml_diff>